<commit_message>
Presentacion 4: fusion validada 9 g con guarda, RANSAC, Optuna profes, ruido
</commit_message>
<xml_diff>
--- a/presentaciones/presentacion4_autoexp/presentacion4_autoexp.pptx
+++ b/presentaciones/presentacion4_autoexp/presentacion4_autoexp.pptx
@@ -24,6 +24,7 @@
     <p:sldId id="272" r:id="rId23"/>
     <p:sldId id="273" r:id="rId24"/>
     <p:sldId id="274" r:id="rId25"/>
+    <p:sldId id="275" r:id="rId26"/>
   </p:sldIdLst>
   <p:sldSz cx="12188952" cy="6858000" type="screen4x3"/>
   <p:notesSz cx="6858000" cy="9144000"/>
@@ -3224,7 +3225,7 @@
               </a:defRPr>
             </a:pPr>
             <a:r>
-              <a:t>Validación en los 9 g: 40.2 dB de media con 64 puntos, sin DIP</a:t>
+              <a:t>Validación en los 9 g: 40.8 dB con 64 puntos (fusión con guarda); 40.3 sin DIP</a:t>
             </a:r>
           </a:p>
         </p:txBody>
@@ -3283,7 +3284,7 @@
               </a:defRPr>
             </a:pPr>
             <a:r>
-              <a:t>7 de 9 g ≥ 38 dB. Le gana a DIP con ~164 puntos en los g duros (-4, -3.5, -3); DIP con 164 sigue siendo mejor en los g suaves.</a:t>
+              <a:t>Fusión: 40.8 de media, 36.0 en el peor g, 7 de 9 g ≥ 38 dB. Solo TPS: 40.3 / 35.1, 7 de 9. Le ganan a DIP con ~164 puntos en los g duros; DIP con 164 sigue arriba en los suaves.</a:t>
             </a:r>
           </a:p>
         </p:txBody>
@@ -3914,7 +3915,7 @@
         </p:nvGraphicFramePr>
         <p:xfrm>
           <a:off x="731520" y="1371600"/>
-          <a:ext cx="10698480" cy="2304288"/>
+          <a:ext cx="10698480" cy="2688336"/>
         </p:xfrm>
         <a:graphic>
           <a:graphicData uri="http://schemas.openxmlformats.org/drawingml/2006/table">
@@ -4209,6 +4210,53 @@
                   <a:tcPr/>
                 </a:tc>
               </a:tr>
+              <a:tr h="384048">
+                <a:tc>
+                  <a:txBody>
+                    <a:bodyPr/>
+                    <a:lstStyle/>
+                    <a:p>
+                      <a:pPr>
+                        <a:defRPr sz="1200" b="1"/>
+                      </a:pPr>
+                      <a:r>
+                        <a:t>DIP, mejor de Optuna (181 trials): meshgrid, skip 0, LR ~5e-3, 3000 it</a:t>
+                      </a:r>
+                    </a:p>
+                  </a:txBody>
+                  <a:tcPr/>
+                </a:tc>
+                <a:tc>
+                  <a:txBody>
+                    <a:bodyPr/>
+                    <a:lstStyle/>
+                    <a:p>
+                      <a:pPr>
+                        <a:defRPr sz="1200" b="0"/>
+                      </a:pPr>
+                      <a:r>
+                        <a:t>29.9</a:t>
+                      </a:r>
+                    </a:p>
+                  </a:txBody>
+                  <a:tcPr/>
+                </a:tc>
+                <a:tc>
+                  <a:txBody>
+                    <a:bodyPr/>
+                    <a:lstStyle/>
+                    <a:p>
+                      <a:pPr>
+                        <a:defRPr sz="1200" b="0"/>
+                      </a:pPr>
+                      <a:r>
+                        <a:t>26.2</a:t>
+                      </a:r>
+                    </a:p>
+                  </a:txBody>
+                  <a:tcPr/>
+                </a:tc>
+              </a:tr>
             </a:tbl>
           </a:graphicData>
         </a:graphic>
@@ -4221,7 +4269,7 @@
         </p:nvSpPr>
         <p:spPr>
           <a:xfrm>
-            <a:off x="731520" y="3767328"/>
+            <a:off x="731520" y="4151376"/>
             <a:ext cx="10698480" cy="1280160"/>
           </a:xfrm>
           <a:prstGeom prst="rect">
@@ -4243,7 +4291,7 @@
               </a:defRPr>
             </a:pPr>
             <a:r>
-              <a:t>Con los hiperparámetros del paper para agujeros grandes, DIP le gana por +4 dB a la interpolación con los mismos puntos; la receta de la tesis (afinada para ~328 puntos) no. Estudio 'profes_grid_uniform' de Optuna en Mendieta.</a:t>
+              <a:t>Con los hiperparámetros del paper para agujeros grandes, DIP le gana a la interpolación con los mismos puntos (+4 dB; +5.5 con Optuna); la receta de la tesis (afinada para ~328 puntos) no. Todos los mejores trials son la config 'vase' afinada; el muestreo uniforme nunca aparece arriba.</a:t>
             </a:r>
           </a:p>
         </p:txBody>
@@ -4296,7 +4344,7 @@
               </a:defRPr>
             </a:pPr>
             <a:r>
-              <a:t>Híbrido: TPS pegada al borde + DIP en la zona suave</a:t>
+              <a:t>Híbrido: TPS pegada al borde + DIP en la zona suave (9 g)</a:t>
             </a:r>
           </a:p>
         </p:txBody>
@@ -4311,7 +4359,7 @@
         </p:nvGraphicFramePr>
         <p:xfrm>
           <a:off x="731520" y="1371600"/>
-          <a:ext cx="10698480" cy="2304288"/>
+          <a:ext cx="10698480" cy="1920240"/>
         </p:xfrm>
         <a:graphic>
           <a:graphicData uri="http://schemas.openxmlformats.org/drawingml/2006/table">
@@ -4320,10 +4368,10 @@
                 <a:tableStyleId>{5C22544A-7EE6-4342-B048-85BDC9FD1C3A}</a:tableStyleId>
               </a:tblPr>
               <a:tblGrid>
-                <a:gridCol w="4572000"/>
-                <a:gridCol w="1645920"/>
-                <a:gridCol w="1645920"/>
-                <a:gridCol w="2834640"/>
+                <a:gridCol w="5120640"/>
+                <a:gridCol w="1737360"/>
+                <a:gridCol w="1737360"/>
+                <a:gridCol w="2103120"/>
               </a:tblGrid>
               <a:tr h="384048">
                 <a:tc>
@@ -4335,7 +4383,7 @@
                         <a:defRPr sz="1300" b="1"/>
                       </a:pPr>
                       <a:r>
-                        <a:t>reconstrucción (mismos 64 puntos, 3 g)</a:t>
+                        <a:t>reconstrucción (mismos 64 puntos, 9 g)</a:t>
                       </a:r>
                     </a:p>
                   </a:txBody>
@@ -4380,7 +4428,7 @@
                         <a:defRPr sz="1300" b="1"/>
                       </a:pPr>
                       <a:r>
-                        <a:t>-4 / -2 / -0.5</a:t>
+                        <a:t>g ≥ 38 dB</a:t>
                       </a:r>
                     </a:p>
                   </a:txBody>
@@ -4397,7 +4445,7 @@
                         <a:defRPr sz="1200" b="1"/>
                       </a:pPr>
                       <a:r>
-                        <a:t>TPS sola (con monotonía)</a:t>
+                        <a:t>TPS sola (acantilado + monotonía + RANSAC)</a:t>
                       </a:r>
                     </a:p>
                   </a:txBody>
@@ -4412,7 +4460,7 @@
                         <a:defRPr sz="1200" b="0"/>
                       </a:pPr>
                       <a:r>
-                        <a:t>40.4</a:t>
+                        <a:t>40.3</a:t>
                       </a:r>
                     </a:p>
                   </a:txBody>
@@ -4427,7 +4475,7 @@
                         <a:defRPr sz="1200" b="0"/>
                       </a:pPr>
                       <a:r>
-                        <a:t>36.8</a:t>
+                        <a:t>35.1</a:t>
                       </a:r>
                     </a:p>
                   </a:txBody>
@@ -4442,7 +4490,7 @@
                         <a:defRPr sz="1200" b="0"/>
                       </a:pPr>
                       <a:r>
-                        <a:t>45.7 / 36.8 / 38.5</a:t>
+                        <a:t>7 / 9</a:t>
                       </a:r>
                     </a:p>
                   </a:txBody>
@@ -4459,7 +4507,7 @@
                         <a:defRPr sz="1200" b="1"/>
                       </a:pPr>
                       <a:r>
-                        <a:t>DIP (tesis) + ceros + franja TPS</a:t>
+                        <a:t>DIP (receta tesis) + ceros + franja TPS, sin fusionar</a:t>
                       </a:r>
                     </a:p>
                   </a:txBody>
@@ -4474,7 +4522,7 @@
                         <a:defRPr sz="1200" b="0"/>
                       </a:pPr>
                       <a:r>
-                        <a:t>39.3</a:t>
+                        <a:t>37.0</a:t>
                       </a:r>
                     </a:p>
                   </a:txBody>
@@ -4489,131 +4537,7 @@
                         <a:defRPr sz="1200" b="0"/>
                       </a:pPr>
                       <a:r>
-                        <a:t>38.0</a:t>
-                      </a:r>
-                    </a:p>
-                  </a:txBody>
-                  <a:tcPr/>
-                </a:tc>
-                <a:tc>
-                  <a:txBody>
-                    <a:bodyPr/>
-                    <a:lstStyle/>
-                    <a:p>
-                      <a:pPr>
-                        <a:defRPr sz="1200" b="0"/>
-                      </a:pPr>
-                      <a:r>
-                        <a:t>41.7 / 38.0 / 38.1</a:t>
-                      </a:r>
-                    </a:p>
-                  </a:txBody>
-                  <a:tcPr/>
-                </a:tc>
-              </a:tr>
-              <a:tr h="384048">
-                <a:tc>
-                  <a:txBody>
-                    <a:bodyPr/>
-                    <a:lstStyle/>
-                    <a:p>
-                      <a:pPr>
-                        <a:defRPr sz="1200" b="1"/>
-                      </a:pPr>
-                      <a:r>
-                        <a:t>DIP ('vase') + ceros + franja TPS</a:t>
-                      </a:r>
-                    </a:p>
-                  </a:txBody>
-                  <a:tcPr/>
-                </a:tc>
-                <a:tc>
-                  <a:txBody>
-                    <a:bodyPr/>
-                    <a:lstStyle/>
-                    <a:p>
-                      <a:pPr>
-                        <a:defRPr sz="1200" b="0"/>
-                      </a:pPr>
-                      <a:r>
-                        <a:t>35.4</a:t>
-                      </a:r>
-                    </a:p>
-                  </a:txBody>
-                  <a:tcPr/>
-                </a:tc>
-                <a:tc>
-                  <a:txBody>
-                    <a:bodyPr/>
-                    <a:lstStyle/>
-                    <a:p>
-                      <a:pPr>
-                        <a:defRPr sz="1200" b="0"/>
-                      </a:pPr>
-                      <a:r>
-                        <a:t>30.8</a:t>
-                      </a:r>
-                    </a:p>
-                  </a:txBody>
-                  <a:tcPr/>
-                </a:tc>
-                <a:tc>
-                  <a:txBody>
-                    <a:bodyPr/>
-                    <a:lstStyle/>
-                    <a:p>
-                      <a:pPr>
-                        <a:defRPr sz="1200" b="0"/>
-                      </a:pPr>
-                      <a:r>
-                        <a:t>30.8 / 36.5 / 38.9</a:t>
-                      </a:r>
-                    </a:p>
-                  </a:txBody>
-                  <a:tcPr/>
-                </a:tc>
-              </a:tr>
-              <a:tr h="384048">
-                <a:tc>
-                  <a:txBody>
-                    <a:bodyPr/>
-                    <a:lstStyle/>
-                    <a:p>
-                      <a:pPr>
-                        <a:defRPr sz="1200" b="1"/>
-                      </a:pPr>
-                      <a:r>
-                        <a:t>Fusión TPS + DIP tesis (B = 20 px)</a:t>
-                      </a:r>
-                    </a:p>
-                  </a:txBody>
-                  <a:tcPr/>
-                </a:tc>
-                <a:tc>
-                  <a:txBody>
-                    <a:bodyPr/>
-                    <a:lstStyle/>
-                    <a:p>
-                      <a:pPr>
-                        <a:defRPr sz="1200" b="0"/>
-                      </a:pPr>
-                      <a:r>
-                        <a:t>41.8</a:t>
-                      </a:r>
-                    </a:p>
-                  </a:txBody>
-                  <a:tcPr/>
-                </a:tc>
-                <a:tc>
-                  <a:txBody>
-                    <a:bodyPr/>
-                    <a:lstStyle/>
-                    <a:p>
-                      <a:pPr>
-                        <a:defRPr sz="1200" b="0"/>
-                      </a:pPr>
-                      <a:r>
-                        <a:t>39.5</a:t>
+                        <a:t>31.3</a:t>
                       </a:r>
                     </a:p>
                   </a:txBody>
@@ -4642,7 +4566,7 @@
                         <a:defRPr sz="1200" b="1"/>
                       </a:pPr>
                       <a:r>
-                        <a:t>Fusión TPS + DIP intermedio (B = 10 px)</a:t>
+                        <a:t>Fusión TPS + DIP (B = 20 px), sin guarda</a:t>
                       </a:r>
                     </a:p>
                   </a:txBody>
@@ -4657,7 +4581,7 @@
                         <a:defRPr sz="1200" b="0"/>
                       </a:pPr>
                       <a:r>
-                        <a:t>41.7</a:t>
+                        <a:t>40.3</a:t>
                       </a:r>
                     </a:p>
                   </a:txBody>
@@ -4672,7 +4596,36 @@
                         <a:defRPr sz="1200" b="0"/>
                       </a:pPr>
                       <a:r>
-                        <a:t>39.8</a:t>
+                        <a:t>32.5</a:t>
+                      </a:r>
+                    </a:p>
+                  </a:txBody>
+                  <a:tcPr/>
+                </a:tc>
+                <a:tc>
+                  <a:txBody>
+                    <a:bodyPr/>
+                    <a:lstStyle/>
+                    <a:p>
+                      <a:pPr>
+                        <a:defRPr sz="1200" b="0"/>
+                      </a:pPr>
+                    </a:p>
+                  </a:txBody>
+                  <a:tcPr/>
+                </a:tc>
+              </a:tr>
+              <a:tr h="384048">
+                <a:tc>
+                  <a:txBody>
+                    <a:bodyPr/>
+                    <a:lstStyle/>
+                    <a:p>
+                      <a:pPr>
+                        <a:defRPr sz="1200" b="1"/>
+                      </a:pPr>
+                      <a:r>
+                        <a:t>Fusión TPS + DIP + guarda de falla de DIP</a:t>
                       </a:r>
                     </a:p>
                   </a:txBody>
@@ -4687,7 +4640,37 @@
                         <a:defRPr sz="1200" b="0"/>
                       </a:pPr>
                       <a:r>
-                        <a:t>43.8 / 39.8 / 41.5</a:t>
+                        <a:t>40.8</a:t>
+                      </a:r>
+                    </a:p>
+                  </a:txBody>
+                  <a:tcPr/>
+                </a:tc>
+                <a:tc>
+                  <a:txBody>
+                    <a:bodyPr/>
+                    <a:lstStyle/>
+                    <a:p>
+                      <a:pPr>
+                        <a:defRPr sz="1200" b="0"/>
+                      </a:pPr>
+                      <a:r>
+                        <a:t>36.0</a:t>
+                      </a:r>
+                    </a:p>
+                  </a:txBody>
+                  <a:tcPr/>
+                </a:tc>
+                <a:tc>
+                  <a:txBody>
+                    <a:bodyPr/>
+                    <a:lstStyle/>
+                    <a:p>
+                      <a:pPr>
+                        <a:defRPr sz="1200" b="0"/>
+                      </a:pPr>
+                      <a:r>
+                        <a:t>7 / 9</a:t>
                       </a:r>
                     </a:p>
                   </a:txBody>
@@ -4706,7 +4689,7 @@
         </p:nvSpPr>
         <p:spPr>
           <a:xfrm>
-            <a:off x="731520" y="3767328"/>
+            <a:off x="731520" y="3383280"/>
             <a:ext cx="10698480" cy="1280160"/>
           </a:xfrm>
           <a:prstGeom prst="rect">
@@ -4728,7 +4711,19 @@
               </a:defRPr>
             </a:pPr>
             <a:r>
-              <a:t>Fusión: final = monotonía( w·TPS + (1−w)·DIP ), w = exp(−(d/B)²), d = distancia al acantilado. DIP va mejor en la meseta y en la zona suave; la TPS, en el frente abrupto. Juntas, los 3 g quedan ≥ 39.5 dB. Validación en 9 g: en curso.</a:t>
+              <a:t>Fusión: final = monotonía( w·TPS + (1−w)·DIP ), w = exp(−(d/B)²), d = distancia al acantilado. La fusión gana en 6 de 9 g, pero cuando DIP falla arrastra todo.</a:t>
+            </a:r>
+          </a:p>
+          <a:p>
+            <a:pPr>
+              <a:defRPr sz="1200" i="1">
+                <a:solidFill>
+                  <a:srgbClr val="404040"/>
+                </a:solidFill>
+              </a:defRPr>
+            </a:pPr>
+            <a:r>
+              <a:t>Guarda sin mirar el mapa: si DIP no reproduce los puntos reales consultados (RMS del residuo &gt; 0.02; cuando anda es ≤ 0.008 y cuando falla ≥ 0.03), en ese g se usa solo la TPS.</a:t>
             </a:r>
           </a:p>
         </p:txBody>
@@ -4781,14 +4776,14 @@
               </a:defRPr>
             </a:pPr>
             <a:r>
-              <a:t>Punto 5 de la reunión: Rosenbrock de vuelta a 3D</a:t>
+              <a:t>Ruido tipo KMC: la receta se puede hacer robusta</a:t>
             </a:r>
           </a:p>
         </p:txBody>
       </p:sp>
       <p:pic>
         <p:nvPicPr>
-          <p:cNvPr id="3" name="Picture 2" descr="rosenbrock_3d.png"/>
+          <p:cNvPr id="3" name="Picture 2" descr="ruido.png"/>
           <p:cNvPicPr>
             <a:picLocks noChangeAspect="1"/>
           </p:cNvPicPr>
@@ -4802,8 +4797,8 @@
         </p:blipFill>
         <p:spPr>
           <a:xfrm>
-            <a:off x="333756" y="1399032"/>
-            <a:ext cx="11521440" cy="4608576"/>
+            <a:off x="1751076" y="1300495"/>
+            <a:ext cx="8686800" cy="4805649"/>
           </a:xfrm>
           <a:prstGeom prst="rect">
             <a:avLst/>
@@ -4840,7 +4835,7 @@
               </a:defRPr>
             </a:pPr>
             <a:r>
-              <a:t>Con 1 % DIP recupera la forma pero la cresta angosta queda ondulada; con 5 % queda fiel. Con 64 puntos la TPS da una superficie reconocible pero con bultos.</a:t>
+              <a:t>Cada punto con ruido gaussiano de desvío σ (fijo por punto). Umbral de 'vale 0' = 3σ, salto mínimo ~5σ y recta del acantilado por RANSAC. σ hay que estimarlo en KMC con corridas repetidas.</a:t>
             </a:r>
           </a:p>
         </p:txBody>
@@ -4886,28 +4881,52 @@
           <a:lstStyle/>
           <a:p>
             <a:pPr>
-              <a:defRPr sz="2700" b="1">
+              <a:defRPr sz="2600" b="1">
                 <a:solidFill>
                   <a:srgbClr val="1F3B73"/>
                 </a:solidFill>
               </a:defRPr>
             </a:pPr>
             <a:r>
-              <a:t>Pedidos de la reunión: estado</a:t>
-            </a:r>
-          </a:p>
-        </p:txBody>
-      </p:sp>
-      <p:sp>
-        <p:nvSpPr>
-          <p:cNvPr id="3" name="TextBox 2"/>
+              <a:t>Punto 5 de la reunión: Rosenbrock de vuelta a 3D</a:t>
+            </a:r>
+          </a:p>
+        </p:txBody>
+      </p:sp>
+      <p:pic>
+        <p:nvPicPr>
+          <p:cNvPr id="3" name="Picture 2" descr="rosenbrock_3d.png"/>
+          <p:cNvPicPr>
+            <a:picLocks noChangeAspect="1"/>
+          </p:cNvPicPr>
+          <p:nvPr/>
+        </p:nvPicPr>
+        <p:blipFill>
+          <a:blip r:embed="rId2"/>
+          <a:stretch>
+            <a:fillRect/>
+          </a:stretch>
+        </p:blipFill>
+        <p:spPr>
+          <a:xfrm>
+            <a:off x="333756" y="1399032"/>
+            <a:ext cx="11521440" cy="4608576"/>
+          </a:xfrm>
+          <a:prstGeom prst="rect">
+            <a:avLst/>
+          </a:prstGeom>
+        </p:spPr>
+      </p:pic>
+      <p:sp>
+        <p:nvSpPr>
+          <p:cNvPr id="4" name="TextBox 3"/>
           <p:cNvSpPr txBox="1"/>
           <p:nvPr/>
         </p:nvSpPr>
         <p:spPr>
           <a:xfrm>
-            <a:off x="548640" y="1280160"/>
-            <a:ext cx="10972800" cy="5120640"/>
+            <a:off x="548640" y="6172200"/>
+            <a:ext cx="11064240" cy="640080"/>
           </a:xfrm>
           <a:prstGeom prst="rect">
             <a:avLst/>
@@ -4920,63 +4939,15 @@
           </a:bodyPr>
           <a:lstStyle/>
           <a:p>
-            <a:pPr>
-              <a:spcAft>
-                <a:spcPts val="500"/>
-              </a:spcAft>
-              <a:defRPr sz="1600">
+            <a:pPr algn="ctr">
+              <a:defRPr sz="1200" i="1">
                 <a:solidFill>
                   <a:srgbClr val="404040"/>
                 </a:solidFill>
               </a:defRPr>
             </a:pPr>
             <a:r>
-              <a:t>1–3) Optuna + grid/uniform con hiperparámetros + la grilla como hiperparámetro: estudio en Mendieta. La config 'vase' del paper es la mejor para DIP con 64 puntos. En el muestreo nuevo, la grilla (6 columnas × 5 filas) resultó ser el parámetro más sensible.</a:t>
-            </a:r>
-          </a:p>
-          <a:p>
-            <a:pPr>
-              <a:spcAft>
-                <a:spcPts val="500"/>
-              </a:spcAft>
-              <a:defRPr sz="1600">
-                <a:solidFill>
-                  <a:srgbClr val="404040"/>
-                </a:solidFill>
-              </a:defRPr>
-            </a:pPr>
-            <a:r>
-              <a:t>4) Ventana: la bisección ya concentra ~25 de los 64 puntos en una franja angosta alrededor del frente (ventana adaptativa).</a:t>
-            </a:r>
-          </a:p>
-          <a:p>
-            <a:pPr>
-              <a:spcAft>
-                <a:spcPts val="500"/>
-              </a:spcAft>
-              <a:defRPr sz="1600">
-                <a:solidFill>
-                  <a:srgbClr val="404040"/>
-                </a:solidFill>
-              </a:defRPr>
-            </a:pPr>
-            <a:r>
-              <a:t>5) Rosenbrock en 3D: hecho (diapositiva anterior).</a:t>
-            </a:r>
-          </a:p>
-          <a:p>
-            <a:pPr>
-              <a:spcAft>
-                <a:spcPts val="500"/>
-              </a:spcAft>
-              <a:defRPr sz="1600">
-                <a:solidFill>
-                  <a:srgbClr val="404040"/>
-                </a:solidFill>
-              </a:defRPr>
-            </a:pPr>
-            <a:r>
-              <a:t>6) Interpolación de scipy vs. DIP: con los mismos puntos empatan con la receta de la tesis (24.4 vs. 25.0); DIP con la config del paper gana (28.5).</a:t>
+              <a:t>Con 1 % DIP recupera la forma pero la cresta angosta queda ondulada; con 5 % queda fiel. Con 64 puntos la TPS da una superficie reconocible pero con bultos.</a:t>
             </a:r>
           </a:p>
         </p:txBody>
@@ -5029,7 +5000,7 @@
               </a:defRPr>
             </a:pPr>
             <a:r>
-              <a:t>Lo que se probó y NO funcionó (para no repetirlo)</a:t>
+              <a:t>Pedidos de la reunión: estado</a:t>
             </a:r>
           </a:p>
         </p:txBody>
@@ -5060,14 +5031,14 @@
               <a:spcAft>
                 <a:spcPts val="500"/>
               </a:spcAft>
-              <a:defRPr sz="1500">
+              <a:defRPr sz="1600">
                 <a:solidFill>
                   <a:srgbClr val="404040"/>
                 </a:solidFill>
               </a:defRPr>
             </a:pPr>
             <a:r>
-              <a:t>Frente como parábola por puntos medios de pares con salto: inestable, dejaba una costura.</a:t>
+              <a:t>1–3) Optuna + grid/uniform con hiperparámetros + la grilla como hiperparámetro: 181 trials en Mendieta. Mejor DIP con 64 puntos en grilla: 29.9 dB (config 'vase' del paper afinada); uniform siempre peor. En el muestreo nuevo, la grilla (6 columnas × 5 filas) es el parámetro más sensible.</a:t>
             </a:r>
           </a:p>
           <a:p>
@@ -5075,14 +5046,14 @@
               <a:spcAft>
                 <a:spcPts val="500"/>
               </a:spcAft>
-              <a:defRPr sz="1500">
+              <a:defRPr sz="1600">
                 <a:solidFill>
                   <a:srgbClr val="404040"/>
                 </a:solidFill>
               </a:defRPr>
             </a:pPr>
             <a:r>
-              <a:t>Bisección al nivel medio: en los g suaves caía dentro de la rampa, no en el acantilado.</a:t>
+              <a:t>4) Ventana: la bisección ya concentra ~25 de los 64 puntos en una franja angosta alrededor del frente (ventana adaptativa).</a:t>
             </a:r>
           </a:p>
           <a:p>
@@ -5090,14 +5061,14 @@
               <a:spcAft>
                 <a:spcPts val="500"/>
               </a:spcAft>
-              <a:defRPr sz="1500">
+              <a:defRPr sz="1600">
                 <a:solidFill>
                   <a:srgbClr val="404040"/>
                 </a:solidFill>
               </a:defRPr>
             </a:pPr>
             <a:r>
-              <a:t>Sondas del perfil de la rampa (3-7-14 px sobre el borde): le quitan presupuesto al relleno.</a:t>
+              <a:t>5) Rosenbrock en 3D: hecho (diapositiva anterior).</a:t>
             </a:r>
           </a:p>
           <a:p>
@@ -5105,59 +5076,14 @@
               <a:spcAft>
                 <a:spcPts val="500"/>
               </a:spcAft>
-              <a:defRPr sz="1500">
+              <a:defRPr sz="1600">
                 <a:solidFill>
                   <a:srgbClr val="404040"/>
                 </a:solidFill>
               </a:defRPr>
             </a:pPr>
             <a:r>
-              <a:t>Proceso gaussiano en lugar de la TPS: con tan pocos puntos, las escalas aprendidas quedan mal (g=-2: 22 dB vs. 36).</a:t>
-            </a:r>
-          </a:p>
-          <a:p>
-            <a:pPr>
-              <a:spcAft>
-                <a:spcPts val="500"/>
-              </a:spcAft>
-              <a:defRPr sz="1500">
-                <a:solidFill>
-                  <a:srgbClr val="404040"/>
-                </a:solidFill>
-              </a:defRPr>
-            </a:pPr>
-            <a:r>
-              <a:t>Relleno por ancho de las cotas de monotonía: mejor peor g, pero −2.7 dB en g=-4.</a:t>
-            </a:r>
-          </a:p>
-          <a:p>
-            <a:pPr>
-              <a:spcAft>
-                <a:spcPts val="500"/>
-              </a:spcAft>
-              <a:defRPr sz="1500">
-                <a:solidFill>
-                  <a:srgbClr val="404040"/>
-                </a:solidFill>
-              </a:defRPr>
-            </a:pPr>
-            <a:r>
-              <a:t>Grilla de 7-8 columnas: no falla el detector, se acaba el presupuesto en la bisección.</a:t>
-            </a:r>
-          </a:p>
-          <a:p>
-            <a:pPr>
-              <a:spcAft>
-                <a:spcPts val="500"/>
-              </a:spcAft>
-              <a:defRPr sz="1500">
-                <a:solidFill>
-                  <a:srgbClr val="404040"/>
-                </a:solidFill>
-              </a:defRPr>
-            </a:pPr>
-            <a:r>
-              <a:t>DIP 'kate' del paper con 64 puntos (18 dB): pensado para imágenes casi completas.</a:t>
+              <a:t>6) Interpolación de scipy vs. DIP: con los mismos puntos empatan con la receta de la tesis (24.4 vs. 25.0); DIP con la config del paper gana (28.5).</a:t>
             </a:r>
           </a:p>
         </p:txBody>
@@ -5210,7 +5136,7 @@
               </a:defRPr>
             </a:pPr>
             <a:r>
-              <a:t>Para KMC: recomendación y lo que falta validar</a:t>
+              <a:t>Lo que se probó y NO funcionó (para no repetirlo)</a:t>
             </a:r>
           </a:p>
         </p:txBody>
@@ -5241,14 +5167,14 @@
               <a:spcAft>
                 <a:spcPts val="500"/>
               </a:spcAft>
-              <a:defRPr sz="1600">
+              <a:defRPr sz="1500">
                 <a:solidFill>
                   <a:srgbClr val="404040"/>
                 </a:solidFill>
               </a:defRPr>
             </a:pPr>
             <a:r>
-              <a:t>Muestreo por tandas: grilla (paralelo) → ~5 rondas de bisección (una corrida por columna, en paralelo) → ~4 rondas de relleno de a 4. Unas 10 rondas de KMC en total.</a:t>
+              <a:t>Frente como parábola por puntos medios de pares con salto: inestable, dejaba una costura.</a:t>
             </a:r>
           </a:p>
           <a:p>
@@ -5256,14 +5182,14 @@
               <a:spcAft>
                 <a:spcPts val="500"/>
               </a:spcAft>
-              <a:defRPr sz="1600">
+              <a:defRPr sz="1500">
                 <a:solidFill>
                   <a:srgbClr val="404040"/>
                 </a:solidFill>
               </a:defRPr>
             </a:pPr>
             <a:r>
-              <a:t>Elegir las columnas según el presupuesto, dejando ~10 puntos para el relleno.</a:t>
+              <a:t>Bisección al nivel medio: en los g suaves caía dentro de la rampa, no en el acantilado.</a:t>
             </a:r>
           </a:p>
           <a:p>
@@ -5271,14 +5197,14 @@
               <a:spcAft>
                 <a:spcPts val="500"/>
               </a:spcAft>
-              <a:defRPr sz="1600">
+              <a:defRPr sz="1500">
                 <a:solidFill>
                   <a:srgbClr val="404040"/>
                 </a:solidFill>
               </a:defRPr>
             </a:pPr>
             <a:r>
-              <a:t>Reconstrucción: fusión TPS (cerca del acantilado) + DIP (zona suave) + monotonía.</a:t>
+              <a:t>Sondas del perfil de la rampa (3-7-14 px sobre el borde): le quitan presupuesto al relleno.</a:t>
             </a:r>
           </a:p>
           <a:p>
@@ -5286,59 +5212,74 @@
               <a:spcAft>
                 <a:spcPts val="500"/>
               </a:spcAft>
-              <a:defRPr sz="1600">
+              <a:defRPr sz="1500">
                 <a:solidFill>
                   <a:srgbClr val="404040"/>
                 </a:solidFill>
               </a:defRPr>
             </a:pPr>
             <a:r>
-              <a:t>Pendiente, y lo más importante:</a:t>
-            </a:r>
-          </a:p>
-          <a:p>
-            <a:pPr lvl="1">
+              <a:t>Proceso gaussiano en lugar de la TPS: con tan pocos puntos, las escalas aprendidas quedan mal (g=-2: 22 dB vs. 36).</a:t>
+            </a:r>
+          </a:p>
+          <a:p>
+            <a:pPr>
               <a:spcAft>
                 <a:spcPts val="500"/>
               </a:spcAft>
-              <a:defRPr sz="1300">
+              <a:defRPr sz="1500">
                 <a:solidFill>
                   <a:srgbClr val="404040"/>
                 </a:solidFill>
               </a:defRPr>
             </a:pPr>
             <a:r>
-              <a:t>¿Existe el acantilado a 0 en KMC, o el borde es difuso / ruidoso?</a:t>
-            </a:r>
-          </a:p>
-          <a:p>
-            <a:pPr lvl="1">
+              <a:t>Relleno por ancho de las cotas de monotonía: mejor peor g, pero −2.7 dB en g=-4.</a:t>
+            </a:r>
+          </a:p>
+          <a:p>
+            <a:pPr>
               <a:spcAft>
                 <a:spcPts val="500"/>
               </a:spcAft>
-              <a:defRPr sz="1300">
+              <a:defRPr sz="1500">
                 <a:solidFill>
                   <a:srgbClr val="404040"/>
                 </a:solidFill>
               </a:defRPr>
             </a:pPr>
             <a:r>
-              <a:t>Ruido: KMC es estocástico. La TPS pasa exacto por cada punto (copia el ruido); DIP es un prior pensado para imágenes ruidosas. Hay que medirlo con ruido simulado del tamaño del de KMC.</a:t>
-            </a:r>
-          </a:p>
-          <a:p>
-            <a:pPr lvl="1">
+              <a:t>Grilla de 7-8 columnas: no falla el detector, se acaba el presupuesto en la bisección.</a:t>
+            </a:r>
+          </a:p>
+          <a:p>
+            <a:pPr>
               <a:spcAft>
                 <a:spcPts val="500"/>
               </a:spcAft>
-              <a:defRPr sz="1300">
+              <a:defRPr sz="1500">
                 <a:solidFill>
                   <a:srgbClr val="404040"/>
                 </a:solidFill>
               </a:defRPr>
             </a:pPr>
             <a:r>
-              <a:t>Validar la fusión en los 9 g (DIP corriendo en Mendieta).</a:t>
+              <a:t>DIP 'kate' del paper con 64 puntos (18 dB): pensado para imágenes casi completas.</a:t>
+            </a:r>
+          </a:p>
+          <a:p>
+            <a:pPr>
+              <a:spcAft>
+                <a:spcPts val="500"/>
+              </a:spcAft>
+              <a:defRPr sz="1500">
+                <a:solidFill>
+                  <a:srgbClr val="404040"/>
+                </a:solidFill>
+              </a:defRPr>
+            </a:pPr>
+            <a:r>
+              <a:t>Fusión sin guarda en 9 g: cuando DIP falla en un g (-4 dB), arrastra el promedio.</a:t>
             </a:r>
           </a:p>
         </p:txBody>
@@ -5451,6 +5392,187 @@
             </a:pPr>
             <a:r>
               <a:t>Arriba: cada paso, con el mismo presupuesto de 64 puntos. Abajo: original vs. reconstrucción de 64 puntos, sin DIP, en 4 de los 9 g.</a:t>
+            </a:r>
+          </a:p>
+        </p:txBody>
+      </p:sp>
+    </p:spTree>
+  </p:cSld>
+  <p:clrMapOvr>
+    <a:masterClrMapping/>
+  </p:clrMapOvr>
+</p:sld>
+</file>
+
+<file path=ppt/slides/slide20.xml><?xml version="1.0" encoding="utf-8"?>
+<p:sld xmlns:a="http://schemas.openxmlformats.org/drawingml/2006/main" xmlns:p="http://schemas.openxmlformats.org/presentationml/2006/main" xmlns:r="http://schemas.openxmlformats.org/officeDocument/2006/relationships">
+  <p:cSld>
+    <p:spTree>
+      <p:nvGrpSpPr>
+        <p:cNvPr id="1" name=""/>
+        <p:cNvGrpSpPr/>
+        <p:nvPr/>
+      </p:nvGrpSpPr>
+      <p:grpSpPr/>
+      <p:sp>
+        <p:nvSpPr>
+          <p:cNvPr id="2" name="TextBox 1"/>
+          <p:cNvSpPr txBox="1"/>
+          <p:nvPr/>
+        </p:nvSpPr>
+        <p:spPr>
+          <a:xfrm>
+            <a:off x="548640" y="320040"/>
+            <a:ext cx="11064240" cy="822960"/>
+          </a:xfrm>
+          <a:prstGeom prst="rect">
+            <a:avLst/>
+          </a:prstGeom>
+          <a:noFill/>
+        </p:spPr>
+        <p:txBody>
+          <a:bodyPr wrap="square">
+            <a:spAutoFit/>
+          </a:bodyPr>
+          <a:lstStyle/>
+          <a:p>
+            <a:pPr>
+              <a:defRPr sz="2700" b="1">
+                <a:solidFill>
+                  <a:srgbClr val="1F3B73"/>
+                </a:solidFill>
+              </a:defRPr>
+            </a:pPr>
+            <a:r>
+              <a:t>Para KMC: recomendación y lo que falta validar</a:t>
+            </a:r>
+          </a:p>
+        </p:txBody>
+      </p:sp>
+      <p:sp>
+        <p:nvSpPr>
+          <p:cNvPr id="3" name="TextBox 2"/>
+          <p:cNvSpPr txBox="1"/>
+          <p:nvPr/>
+        </p:nvSpPr>
+        <p:spPr>
+          <a:xfrm>
+            <a:off x="548640" y="1280160"/>
+            <a:ext cx="10972800" cy="5120640"/>
+          </a:xfrm>
+          <a:prstGeom prst="rect">
+            <a:avLst/>
+          </a:prstGeom>
+          <a:noFill/>
+        </p:spPr>
+        <p:txBody>
+          <a:bodyPr wrap="square">
+            <a:spAutoFit/>
+          </a:bodyPr>
+          <a:lstStyle/>
+          <a:p>
+            <a:pPr>
+              <a:spcAft>
+                <a:spcPts val="500"/>
+              </a:spcAft>
+              <a:defRPr sz="1600">
+                <a:solidFill>
+                  <a:srgbClr val="404040"/>
+                </a:solidFill>
+              </a:defRPr>
+            </a:pPr>
+            <a:r>
+              <a:t>Muestreo por tandas: grilla (paralelo) → ~5 rondas de bisección (una corrida por columna, en paralelo) → ~4 rondas de relleno de a 4. Unas 10 rondas de KMC en total.</a:t>
+            </a:r>
+          </a:p>
+          <a:p>
+            <a:pPr>
+              <a:spcAft>
+                <a:spcPts val="500"/>
+              </a:spcAft>
+              <a:defRPr sz="1600">
+                <a:solidFill>
+                  <a:srgbClr val="404040"/>
+                </a:solidFill>
+              </a:defRPr>
+            </a:pPr>
+            <a:r>
+              <a:t>Elegir las columnas según el presupuesto, dejando ~10 puntos para el relleno.</a:t>
+            </a:r>
+          </a:p>
+          <a:p>
+            <a:pPr>
+              <a:spcAft>
+                <a:spcPts val="500"/>
+              </a:spcAft>
+              <a:defRPr sz="1600">
+                <a:solidFill>
+                  <a:srgbClr val="404040"/>
+                </a:solidFill>
+              </a:defRPr>
+            </a:pPr>
+            <a:r>
+              <a:t>Reconstrucción: fusión TPS (cerca del acantilado) + DIP (zona suave) + monotonía, con guarda.</a:t>
+            </a:r>
+          </a:p>
+          <a:p>
+            <a:pPr>
+              <a:spcAft>
+                <a:spcPts val="500"/>
+              </a:spcAft>
+              <a:defRPr sz="1600">
+                <a:solidFill>
+                  <a:srgbClr val="404040"/>
+                </a:solidFill>
+              </a:defRPr>
+            </a:pPr>
+            <a:r>
+              <a:t>Pendiente, y lo más importante:</a:t>
+            </a:r>
+          </a:p>
+          <a:p>
+            <a:pPr lvl="1">
+              <a:spcAft>
+                <a:spcPts val="500"/>
+              </a:spcAft>
+              <a:defRPr sz="1300">
+                <a:solidFill>
+                  <a:srgbClr val="404040"/>
+                </a:solidFill>
+              </a:defRPr>
+            </a:pPr>
+            <a:r>
+              <a:t>¿Existe el acantilado a 0 en KMC, o el borde es difuso / ruidoso?</a:t>
+            </a:r>
+          </a:p>
+          <a:p>
+            <a:pPr lvl="1">
+              <a:spcAft>
+                <a:spcPts val="500"/>
+              </a:spcAft>
+              <a:defRPr sz="1300">
+                <a:solidFill>
+                  <a:srgbClr val="404040"/>
+                </a:solidFill>
+              </a:defRPr>
+            </a:pPr>
+            <a:r>
+              <a:t>Ruido: con σ = 0.01 la receta robusta pierde ~2 dB y con σ = 0.03 ~6 dB (sin DIP). Falta DIP con ruido (en Mendieta). Hay que estimar σ de KMC con corridas repetidas.</a:t>
+            </a:r>
+          </a:p>
+          <a:p>
+            <a:pPr lvl="1">
+              <a:spcAft>
+                <a:spcPts val="500"/>
+              </a:spcAft>
+              <a:defRPr sz="1300">
+                <a:solidFill>
+                  <a:srgbClr val="404040"/>
+                </a:solidFill>
+              </a:defRPr>
+            </a:pPr>
+            <a:r>
+              <a:t>Guarda de DIP: si DIP no ajusta los puntos reales, se usa solo la TPS (o se relanza DIP con otra semilla).</a:t>
             </a:r>
           </a:p>
         </p:txBody>
@@ -6447,7 +6569,7 @@
               </a:defRPr>
             </a:pPr>
             <a:r>
-              <a:t>Media y peor g en los 3 g de desarrollo. De 24.4 dB (grilla + TPS) a 41.7 dB (fusión con DIP).</a:t>
+              <a:t>Media y peor g en los 3 g de desarrollo. De 24.4 dB (grilla + TPS) a 41.8 dB (fusión con DIP).</a:t>
             </a:r>
           </a:p>
         </p:txBody>

</xml_diff>

<commit_message>
autoexp: TPS suavizada 1e-4 por defecto (40.6 en 9 g), fusion con guarda 41.1 (37.3), 8/9 g >= 38; parametro unico sigma para KMC; presentacion actualizada
</commit_message>
<xml_diff>
--- a/presentaciones/presentacion4_autoexp/presentacion4_autoexp.pptx
+++ b/presentaciones/presentacion4_autoexp/presentacion4_autoexp.pptx
@@ -3225,7 +3225,7 @@
               </a:defRPr>
             </a:pPr>
             <a:r>
-              <a:t>Validación en los 9 g: 40.8 dB con 64 puntos (fusión con guarda); 40.3 sin DIP</a:t>
+              <a:t>Validación en los 9 g: 41.1 dB con 64 puntos (fusión con guarda); 40.6 sin DIP</a:t>
             </a:r>
           </a:p>
         </p:txBody>
@@ -3284,7 +3284,7 @@
               </a:defRPr>
             </a:pPr>
             <a:r>
-              <a:t>Fusión: 40.8 de media, 36.0 en el peor g, 7 de 9 g ≥ 38 dB. Solo TPS: 40.3 / 35.1, 7 de 9. Le ganan a DIP con ~164 puntos en los g duros; DIP con 164 sigue arriba en los suaves.</a:t>
+              <a:t>Fusión: 41.1 de media, 37.2 en el peor g, 8 de 9 g ≥ 38 dB. Solo TPS: 40.6 / 36.2, 8 de 9. Le ganan a DIP con ~164 puntos en los g duros; DIP con 164 sigue arriba en los suaves.</a:t>
             </a:r>
           </a:p>
         </p:txBody>
@@ -4460,7 +4460,7 @@
                         <a:defRPr sz="1200" b="0"/>
                       </a:pPr>
                       <a:r>
-                        <a:t>40.3</a:t>
+                        <a:t>40.6</a:t>
                       </a:r>
                     </a:p>
                   </a:txBody>
@@ -4475,7 +4475,7 @@
                         <a:defRPr sz="1200" b="0"/>
                       </a:pPr>
                       <a:r>
-                        <a:t>35.1</a:t>
+                        <a:t>36.2</a:t>
                       </a:r>
                     </a:p>
                   </a:txBody>
@@ -4490,7 +4490,7 @@
                         <a:defRPr sz="1200" b="0"/>
                       </a:pPr>
                       <a:r>
-                        <a:t>7 / 9</a:t>
+                        <a:t>8 / 9</a:t>
                       </a:r>
                     </a:p>
                   </a:txBody>
@@ -4566,7 +4566,7 @@
                         <a:defRPr sz="1200" b="1"/>
                       </a:pPr>
                       <a:r>
-                        <a:t>Fusión TPS + DIP (B = 20 px), sin guarda</a:t>
+                        <a:t>Fusión TPS + DIP (B = 20 px), sin guarda (TPS sin suavizar)</a:t>
                       </a:r>
                     </a:p>
                   </a:txBody>
@@ -4640,7 +4640,7 @@
                         <a:defRPr sz="1200" b="0"/>
                       </a:pPr>
                       <a:r>
-                        <a:t>40.8</a:t>
+                        <a:t>41.1</a:t>
                       </a:r>
                     </a:p>
                   </a:txBody>
@@ -4655,7 +4655,7 @@
                         <a:defRPr sz="1200" b="0"/>
                       </a:pPr>
                       <a:r>
-                        <a:t>36.0</a:t>
+                        <a:t>37.2</a:t>
                       </a:r>
                     </a:p>
                   </a:txBody>
@@ -4670,7 +4670,7 @@
                         <a:defRPr sz="1200" b="0"/>
                       </a:pPr>
                       <a:r>
-                        <a:t>7 / 9</a:t>
+                        <a:t>8 / 9</a:t>
                       </a:r>
                     </a:p>
                   </a:txBody>
@@ -6382,7 +6382,7 @@
               </a:defRPr>
             </a:pPr>
             <a:r>
-              <a:t>Acantilado: recta ajustada a los pares vecinos 0 / no-0 (robusta a outliers). Debajo: 0.</a:t>
+              <a:t>Acantilado: recta ajustada por RANSAC a los pares vecinos 0 / no-0. Debajo: 0.</a:t>
             </a:r>
           </a:p>
           <a:p>
@@ -6397,7 +6397,7 @@
               </a:defRPr>
             </a:pPr>
             <a:r>
-              <a:t>Arriba: TPS solo con los puntos de arriba (no interpola a través del salto).</a:t>
+              <a:t>Arriba: TPS (suavizado 1e-4) solo con los puntos de arriba: no interpola a través del salto.</a:t>
             </a:r>
           </a:p>
           <a:p>

</xml_diff>

<commit_message>
autoexp: DIP con ruido + fusion (suma ~0.7 dB y SSIM), robustez v2 (38.9+-1.3), sondas de rampa descartadas; presentacion actualizada
</commit_message>
<xml_diff>
--- a/presentaciones/presentacion4_autoexp/presentacion4_autoexp.pptx
+++ b/presentaciones/presentacion4_autoexp/presentacion4_autoexp.pptx
@@ -25,6 +25,7 @@
     <p:sldId id="273" r:id="rId24"/>
     <p:sldId id="274" r:id="rId25"/>
     <p:sldId id="275" r:id="rId26"/>
+    <p:sldId id="276" r:id="rId27"/>
   </p:sldIdLst>
   <p:sldSz cx="12188952" cy="6858000" type="screen4x3"/>
   <p:notesSz cx="6858000" cy="9144000"/>
@@ -3491,7 +3492,7 @@
               </a:defRPr>
             </a:pPr>
             <a:r>
-              <a:t>Robustez: ¿depende de dónde cae la grilla?</a:t>
+              <a:t>Robustez: ¿depende de dónde cae la grilla? (sin DIP, 9 g)</a:t>
             </a:r>
           </a:p>
         </p:txBody>
@@ -3506,7 +3507,7 @@
         </p:nvGraphicFramePr>
         <p:xfrm>
           <a:off x="731520" y="1371600"/>
-          <a:ext cx="10698480" cy="2304288"/>
+          <a:ext cx="10698480" cy="1536192"/>
         </p:xfrm>
         <a:graphic>
           <a:graphicData uri="http://schemas.openxmlformats.org/drawingml/2006/table">
@@ -3576,53 +3577,6 @@
                         <a:defRPr sz="1200" b="1"/>
                       </a:pPr>
                       <a:r>
-                        <a:t>0.20</a:t>
-                      </a:r>
-                    </a:p>
-                  </a:txBody>
-                  <a:tcPr/>
-                </a:tc>
-                <a:tc>
-                  <a:txBody>
-                    <a:bodyPr/>
-                    <a:lstStyle/>
-                    <a:p>
-                      <a:pPr>
-                        <a:defRPr sz="1200" b="0"/>
-                      </a:pPr>
-                      <a:r>
-                        <a:t>32.6</a:t>
-                      </a:r>
-                    </a:p>
-                  </a:txBody>
-                  <a:tcPr/>
-                </a:tc>
-                <a:tc>
-                  <a:txBody>
-                    <a:bodyPr/>
-                    <a:lstStyle/>
-                    <a:p>
-                      <a:pPr>
-                        <a:defRPr sz="1200" b="0"/>
-                      </a:pPr>
-                      <a:r>
-                        <a:t>30.3</a:t>
-                      </a:r>
-                    </a:p>
-                  </a:txBody>
-                  <a:tcPr/>
-                </a:tc>
-              </a:tr>
-              <a:tr h="384048">
-                <a:tc>
-                  <a:txBody>
-                    <a:bodyPr/>
-                    <a:lstStyle/>
-                    <a:p>
-                      <a:pPr>
-                        <a:defRPr sz="1200" b="1"/>
-                      </a:pPr>
-                      <a:r>
                         <a:t>0.35</a:t>
                       </a:r>
                     </a:p>
@@ -3638,7 +3592,7 @@
                         <a:defRPr sz="1200" b="0"/>
                       </a:pPr>
                       <a:r>
-                        <a:t>37.3</a:t>
+                        <a:t>38.4</a:t>
                       </a:r>
                     </a:p>
                   </a:txBody>
@@ -3653,7 +3607,7 @@
                         <a:defRPr sz="1200" b="0"/>
                       </a:pPr>
                       <a:r>
-                        <a:t>32.7</a:t>
+                        <a:t>35.8</a:t>
                       </a:r>
                     </a:p>
                   </a:txBody>
@@ -3685,7 +3639,7 @@
                         <a:defRPr sz="1200" b="0"/>
                       </a:pPr>
                       <a:r>
-                        <a:t>38.7</a:t>
+                        <a:t>40.6</a:t>
                       </a:r>
                     </a:p>
                   </a:txBody>
@@ -3700,7 +3654,7 @@
                         <a:defRPr sz="1200" b="0"/>
                       </a:pPr>
                       <a:r>
-                        <a:t>33.2</a:t>
+                        <a:t>36.2</a:t>
                       </a:r>
                     </a:p>
                   </a:txBody>
@@ -3732,7 +3686,7 @@
                         <a:defRPr sz="1200" b="0"/>
                       </a:pPr>
                       <a:r>
-                        <a:t>36.5</a:t>
+                        <a:t>37.7</a:t>
                       </a:r>
                     </a:p>
                   </a:txBody>
@@ -3747,54 +3701,7 @@
                         <a:defRPr sz="1200" b="0"/>
                       </a:pPr>
                       <a:r>
-                        <a:t>33.6</a:t>
-                      </a:r>
-                    </a:p>
-                  </a:txBody>
-                  <a:tcPr/>
-                </a:tc>
-              </a:tr>
-              <a:tr h="384048">
-                <a:tc>
-                  <a:txBody>
-                    <a:bodyPr/>
-                    <a:lstStyle/>
-                    <a:p>
-                      <a:pPr>
-                        <a:defRPr sz="1200" b="1"/>
-                      </a:pPr>
-                      <a:r>
-                        <a:t>0.80</a:t>
-                      </a:r>
-                    </a:p>
-                  </a:txBody>
-                  <a:tcPr/>
-                </a:tc>
-                <a:tc>
-                  <a:txBody>
-                    <a:bodyPr/>
-                    <a:lstStyle/>
-                    <a:p>
-                      <a:pPr>
-                        <a:defRPr sz="1200" b="0"/>
-                      </a:pPr>
-                      <a:r>
-                        <a:t>34.9</a:t>
-                      </a:r>
-                    </a:p>
-                  </a:txBody>
-                  <a:tcPr/>
-                </a:tc>
-                <a:tc>
-                  <a:txBody>
-                    <a:bodyPr/>
-                    <a:lstStyle/>
-                    <a:p>
-                      <a:pPr>
-                        <a:defRPr sz="1200" b="0"/>
-                      </a:pPr>
-                      <a:r>
-                        <a:t>29.6</a:t>
+                        <a:t>35.6</a:t>
                       </a:r>
                     </a:p>
                   </a:txBody>
@@ -3813,7 +3720,7 @@
         </p:nvSpPr>
         <p:spPr>
           <a:xfrm>
-            <a:off x="731520" y="3767328"/>
+            <a:off x="731520" y="2999232"/>
             <a:ext cx="10698480" cy="1280160"/>
           </a:xfrm>
           <a:prstGeom prst="rect">
@@ -3835,19 +3742,7 @@
               </a:defRPr>
             </a:pPr>
             <a:r>
-              <a:t>Todo se afinó con offset 0.5, así que ese valor está algo favorecido. Lo honesto es reportar la banda (~37.5 ± 1 dB con esta versión del muestreo), no el mejor caso.</a:t>
-            </a:r>
-          </a:p>
-          <a:p>
-            <a:pPr>
-              <a:defRPr sz="1200" i="1">
-                <a:solidFill>
-                  <a:srgbClr val="404040"/>
-                </a:solidFill>
-              </a:defRPr>
-            </a:pPr>
-            <a:r>
-              <a:t>(Filas 0.20 y 0.80: versión anterior del relleno.)</a:t>
+              <a:t>Todo se afinó con offset 0.5, así que ese valor está algo favorecido. Lo honesto es reportar ~38.9 ± 1.3 dB de media. El peor g casi no depende de la grilla.</a:t>
             </a:r>
           </a:p>
         </p:txBody>
@@ -4888,35 +4783,271 @@
               </a:defRPr>
             </a:pPr>
             <a:r>
-              <a:t>Punto 5 de la reunión: Rosenbrock de vuelta a 3D</a:t>
-            </a:r>
-          </a:p>
-        </p:txBody>
-      </p:sp>
-      <p:pic>
-        <p:nvPicPr>
-          <p:cNvPr id="3" name="Picture 2" descr="rosenbrock_3d.png"/>
-          <p:cNvPicPr>
-            <a:picLocks noChangeAspect="1"/>
-          </p:cNvPicPr>
+              <a:t>Con ruido, DIP sí suma (fusión)</a:t>
+            </a:r>
+          </a:p>
+        </p:txBody>
+      </p:sp>
+      <p:graphicFrame>
+        <p:nvGraphicFramePr>
+          <p:cNvPr id="3" name="Table 2"/>
+          <p:cNvGraphicFramePr>
+            <a:graphicFrameLocks noGrp="1"/>
+          </p:cNvGraphicFramePr>
           <p:nvPr/>
-        </p:nvPicPr>
-        <p:blipFill>
-          <a:blip r:embed="rId2"/>
-          <a:stretch>
-            <a:fillRect/>
-          </a:stretch>
-        </p:blipFill>
-        <p:spPr>
-          <a:xfrm>
-            <a:off x="333756" y="1399032"/>
-            <a:ext cx="11521440" cy="4608576"/>
-          </a:xfrm>
-          <a:prstGeom prst="rect">
-            <a:avLst/>
-          </a:prstGeom>
-        </p:spPr>
-      </p:pic>
+        </p:nvGraphicFramePr>
+        <p:xfrm>
+          <a:off x="731520" y="1371600"/>
+          <a:ext cx="10698480" cy="1152144"/>
+        </p:xfrm>
+        <a:graphic>
+          <a:graphicData uri="http://schemas.openxmlformats.org/drawingml/2006/table">
+            <a:tbl>
+              <a:tblPr firstRow="1" bandRow="1">
+                <a:tableStyleId>{5C22544A-7EE6-4342-B048-85BDC9FD1C3A}</a:tableStyleId>
+              </a:tblPr>
+              <a:tblGrid>
+                <a:gridCol w="1828800"/>
+                <a:gridCol w="2194560"/>
+                <a:gridCol w="2011680"/>
+                <a:gridCol w="2194560"/>
+                <a:gridCol w="2468880"/>
+              </a:tblGrid>
+              <a:tr h="384048">
+                <a:tc>
+                  <a:txBody>
+                    <a:bodyPr/>
+                    <a:lstStyle/>
+                    <a:p>
+                      <a:pPr>
+                        <a:defRPr sz="1300" b="1"/>
+                      </a:pPr>
+                      <a:r>
+                        <a:t>ruido σ (4 g)</a:t>
+                      </a:r>
+                    </a:p>
+                  </a:txBody>
+                  <a:tcPr/>
+                </a:tc>
+                <a:tc>
+                  <a:txBody>
+                    <a:bodyPr/>
+                    <a:lstStyle/>
+                    <a:p>
+                      <a:pPr>
+                        <a:defRPr sz="1300" b="1"/>
+                      </a:pPr>
+                      <a:r>
+                        <a:t>TPS robusta sola</a:t>
+                      </a:r>
+                    </a:p>
+                  </a:txBody>
+                  <a:tcPr/>
+                </a:tc>
+                <a:tc>
+                  <a:txBody>
+                    <a:bodyPr/>
+                    <a:lstStyle/>
+                    <a:p>
+                      <a:pPr>
+                        <a:defRPr sz="1300" b="1"/>
+                      </a:pPr>
+                      <a:r>
+                        <a:t>DIP solo</a:t>
+                      </a:r>
+                    </a:p>
+                  </a:txBody>
+                  <a:tcPr/>
+                </a:tc>
+                <a:tc>
+                  <a:txBody>
+                    <a:bodyPr/>
+                    <a:lstStyle/>
+                    <a:p>
+                      <a:pPr>
+                        <a:defRPr sz="1300" b="1"/>
+                      </a:pPr>
+                      <a:r>
+                        <a:t>fusión TPS + DIP</a:t>
+                      </a:r>
+                    </a:p>
+                  </a:txBody>
+                  <a:tcPr/>
+                </a:tc>
+                <a:tc>
+                  <a:txBody>
+                    <a:bodyPr/>
+                    <a:lstStyle/>
+                    <a:p>
+                      <a:pPr>
+                        <a:defRPr sz="1300" b="1"/>
+                      </a:pPr>
+                      <a:r>
+                        <a:t>SSIM TPS → fusión</a:t>
+                      </a:r>
+                    </a:p>
+                  </a:txBody>
+                  <a:tcPr/>
+                </a:tc>
+              </a:tr>
+              <a:tr h="384048">
+                <a:tc>
+                  <a:txBody>
+                    <a:bodyPr/>
+                    <a:lstStyle/>
+                    <a:p>
+                      <a:pPr>
+                        <a:defRPr sz="1200" b="1"/>
+                      </a:pPr>
+                      <a:r>
+                        <a:t>0.01</a:t>
+                      </a:r>
+                    </a:p>
+                  </a:txBody>
+                  <a:tcPr/>
+                </a:tc>
+                <a:tc>
+                  <a:txBody>
+                    <a:bodyPr/>
+                    <a:lstStyle/>
+                    <a:p>
+                      <a:pPr>
+                        <a:defRPr sz="1200" b="0"/>
+                      </a:pPr>
+                      <a:r>
+                        <a:t>38.3 (35.0)</a:t>
+                      </a:r>
+                    </a:p>
+                  </a:txBody>
+                  <a:tcPr/>
+                </a:tc>
+                <a:tc>
+                  <a:txBody>
+                    <a:bodyPr/>
+                    <a:lstStyle/>
+                    <a:p>
+                      <a:pPr>
+                        <a:defRPr sz="1200" b="0"/>
+                      </a:pPr>
+                      <a:r>
+                        <a:t>35.8 (33.8)</a:t>
+                      </a:r>
+                    </a:p>
+                  </a:txBody>
+                  <a:tcPr/>
+                </a:tc>
+                <a:tc>
+                  <a:txBody>
+                    <a:bodyPr/>
+                    <a:lstStyle/>
+                    <a:p>
+                      <a:pPr>
+                        <a:defRPr sz="1200" b="0"/>
+                      </a:pPr>
+                      <a:r>
+                        <a:t>39.0 (35.5)</a:t>
+                      </a:r>
+                    </a:p>
+                  </a:txBody>
+                  <a:tcPr/>
+                </a:tc>
+                <a:tc>
+                  <a:txBody>
+                    <a:bodyPr/>
+                    <a:lstStyle/>
+                    <a:p>
+                      <a:pPr>
+                        <a:defRPr sz="1200" b="0"/>
+                      </a:pPr>
+                      <a:r>
+                        <a:t>0.983 → 0.990</a:t>
+                      </a:r>
+                    </a:p>
+                  </a:txBody>
+                  <a:tcPr/>
+                </a:tc>
+              </a:tr>
+              <a:tr h="384048">
+                <a:tc>
+                  <a:txBody>
+                    <a:bodyPr/>
+                    <a:lstStyle/>
+                    <a:p>
+                      <a:pPr>
+                        <a:defRPr sz="1200" b="1"/>
+                      </a:pPr>
+                      <a:r>
+                        <a:t>0.03</a:t>
+                      </a:r>
+                    </a:p>
+                  </a:txBody>
+                  <a:tcPr/>
+                </a:tc>
+                <a:tc>
+                  <a:txBody>
+                    <a:bodyPr/>
+                    <a:lstStyle/>
+                    <a:p>
+                      <a:pPr>
+                        <a:defRPr sz="1200" b="0"/>
+                      </a:pPr>
+                      <a:r>
+                        <a:t>34.2 (32.4)</a:t>
+                      </a:r>
+                    </a:p>
+                  </a:txBody>
+                  <a:tcPr/>
+                </a:tc>
+                <a:tc>
+                  <a:txBody>
+                    <a:bodyPr/>
+                    <a:lstStyle/>
+                    <a:p>
+                      <a:pPr>
+                        <a:defRPr sz="1200" b="0"/>
+                      </a:pPr>
+                      <a:r>
+                        <a:t>33.0 (31.3)</a:t>
+                      </a:r>
+                    </a:p>
+                  </a:txBody>
+                  <a:tcPr/>
+                </a:tc>
+                <a:tc>
+                  <a:txBody>
+                    <a:bodyPr/>
+                    <a:lstStyle/>
+                    <a:p>
+                      <a:pPr>
+                        <a:defRPr sz="1200" b="0"/>
+                      </a:pPr>
+                      <a:r>
+                        <a:t>34.9 (33.6)</a:t>
+                      </a:r>
+                    </a:p>
+                  </a:txBody>
+                  <a:tcPr/>
+                </a:tc>
+                <a:tc>
+                  <a:txBody>
+                    <a:bodyPr/>
+                    <a:lstStyle/>
+                    <a:p>
+                      <a:pPr>
+                        <a:defRPr sz="1200" b="0"/>
+                      </a:pPr>
+                      <a:r>
+                        <a:t>0.963 → 0.982</a:t>
+                      </a:r>
+                    </a:p>
+                  </a:txBody>
+                  <a:tcPr/>
+                </a:tc>
+              </a:tr>
+            </a:tbl>
+          </a:graphicData>
+        </a:graphic>
+      </p:graphicFrame>
       <p:sp>
         <p:nvSpPr>
           <p:cNvPr id="4" name="TextBox 3"/>
@@ -4925,8 +5056,8 @@
         </p:nvSpPr>
         <p:spPr>
           <a:xfrm>
-            <a:off x="548640" y="6172200"/>
-            <a:ext cx="11064240" cy="640080"/>
+            <a:off x="731520" y="2615184"/>
+            <a:ext cx="10698480" cy="1280160"/>
           </a:xfrm>
           <a:prstGeom prst="rect">
             <a:avLst/>
@@ -4939,7 +5070,7 @@
           </a:bodyPr>
           <a:lstStyle/>
           <a:p>
-            <a:pPr algn="ctr">
+            <a:pPr>
               <a:defRPr sz="1200" i="1">
                 <a:solidFill>
                   <a:srgbClr val="404040"/>
@@ -4947,7 +5078,19 @@
               </a:defRPr>
             </a:pPr>
             <a:r>
-              <a:t>Con 1 % DIP recupera la forma pero la cresta angosta queda ondulada; con 5 % queda fiel. Con 64 puntos la TPS da una superficie reconocible pero con bultos.</a:t>
+              <a:t>Media (peor g). Con ruido, DIP solo pierde contra la TPS, pero fusionado suma ~0.7 dB, más en el peor g, y sobre todo en SSIM: DIP filtra el ruido que la TPS copia punto a punto.</a:t>
+            </a:r>
+          </a:p>
+          <a:p>
+            <a:pPr>
+              <a:defRPr sz="1200" i="1">
+                <a:solidFill>
+                  <a:srgbClr val="404040"/>
+                </a:solidFill>
+              </a:defRPr>
+            </a:pPr>
+            <a:r>
+              <a:t>Guarda con ruido: 0.02 + 2σ.</a:t>
             </a:r>
           </a:p>
         </p:txBody>
@@ -4993,28 +5136,52 @@
           <a:lstStyle/>
           <a:p>
             <a:pPr>
-              <a:defRPr sz="2700" b="1">
+              <a:defRPr sz="2600" b="1">
                 <a:solidFill>
                   <a:srgbClr val="1F3B73"/>
                 </a:solidFill>
               </a:defRPr>
             </a:pPr>
             <a:r>
-              <a:t>Pedidos de la reunión: estado</a:t>
-            </a:r>
-          </a:p>
-        </p:txBody>
-      </p:sp>
-      <p:sp>
-        <p:nvSpPr>
-          <p:cNvPr id="3" name="TextBox 2"/>
+              <a:t>Punto 5 de la reunión: Rosenbrock de vuelta a 3D</a:t>
+            </a:r>
+          </a:p>
+        </p:txBody>
+      </p:sp>
+      <p:pic>
+        <p:nvPicPr>
+          <p:cNvPr id="3" name="Picture 2" descr="rosenbrock_3d.png"/>
+          <p:cNvPicPr>
+            <a:picLocks noChangeAspect="1"/>
+          </p:cNvPicPr>
+          <p:nvPr/>
+        </p:nvPicPr>
+        <p:blipFill>
+          <a:blip r:embed="rId2"/>
+          <a:stretch>
+            <a:fillRect/>
+          </a:stretch>
+        </p:blipFill>
+        <p:spPr>
+          <a:xfrm>
+            <a:off x="333756" y="1399032"/>
+            <a:ext cx="11521440" cy="4608576"/>
+          </a:xfrm>
+          <a:prstGeom prst="rect">
+            <a:avLst/>
+          </a:prstGeom>
+        </p:spPr>
+      </p:pic>
+      <p:sp>
+        <p:nvSpPr>
+          <p:cNvPr id="4" name="TextBox 3"/>
           <p:cNvSpPr txBox="1"/>
           <p:nvPr/>
         </p:nvSpPr>
         <p:spPr>
           <a:xfrm>
-            <a:off x="548640" y="1280160"/>
-            <a:ext cx="10972800" cy="5120640"/>
+            <a:off x="548640" y="6172200"/>
+            <a:ext cx="11064240" cy="640080"/>
           </a:xfrm>
           <a:prstGeom prst="rect">
             <a:avLst/>
@@ -5027,63 +5194,15 @@
           </a:bodyPr>
           <a:lstStyle/>
           <a:p>
-            <a:pPr>
-              <a:spcAft>
-                <a:spcPts val="500"/>
-              </a:spcAft>
-              <a:defRPr sz="1600">
+            <a:pPr algn="ctr">
+              <a:defRPr sz="1200" i="1">
                 <a:solidFill>
                   <a:srgbClr val="404040"/>
                 </a:solidFill>
               </a:defRPr>
             </a:pPr>
             <a:r>
-              <a:t>1–3) Optuna + grid/uniform con hiperparámetros + la grilla como hiperparámetro: 181 trials en Mendieta. Mejor DIP con 64 puntos en grilla: 29.9 dB (config 'vase' del paper afinada); uniform siempre peor. En el muestreo nuevo, la grilla (6 columnas × 5 filas) es el parámetro más sensible.</a:t>
-            </a:r>
-          </a:p>
-          <a:p>
-            <a:pPr>
-              <a:spcAft>
-                <a:spcPts val="500"/>
-              </a:spcAft>
-              <a:defRPr sz="1600">
-                <a:solidFill>
-                  <a:srgbClr val="404040"/>
-                </a:solidFill>
-              </a:defRPr>
-            </a:pPr>
-            <a:r>
-              <a:t>4) Ventana: la bisección ya concentra ~25 de los 64 puntos en una franja angosta alrededor del frente (ventana adaptativa).</a:t>
-            </a:r>
-          </a:p>
-          <a:p>
-            <a:pPr>
-              <a:spcAft>
-                <a:spcPts val="500"/>
-              </a:spcAft>
-              <a:defRPr sz="1600">
-                <a:solidFill>
-                  <a:srgbClr val="404040"/>
-                </a:solidFill>
-              </a:defRPr>
-            </a:pPr>
-            <a:r>
-              <a:t>5) Rosenbrock en 3D: hecho (diapositiva anterior).</a:t>
-            </a:r>
-          </a:p>
-          <a:p>
-            <a:pPr>
-              <a:spcAft>
-                <a:spcPts val="500"/>
-              </a:spcAft>
-              <a:defRPr sz="1600">
-                <a:solidFill>
-                  <a:srgbClr val="404040"/>
-                </a:solidFill>
-              </a:defRPr>
-            </a:pPr>
-            <a:r>
-              <a:t>6) Interpolación de scipy vs. DIP: con los mismos puntos empatan con la receta de la tesis (24.4 vs. 25.0); DIP con la config del paper gana (28.5).</a:t>
+              <a:t>Con 1 % DIP recupera la forma pero la cresta angosta queda ondulada; con 5 % queda fiel. Con 64 puntos la TPS da una superficie reconocible pero con bultos.</a:t>
             </a:r>
           </a:p>
         </p:txBody>
@@ -5136,7 +5255,7 @@
               </a:defRPr>
             </a:pPr>
             <a:r>
-              <a:t>Lo que se probó y NO funcionó (para no repetirlo)</a:t>
+              <a:t>Pedidos de la reunión: estado</a:t>
             </a:r>
           </a:p>
         </p:txBody>
@@ -5167,14 +5286,14 @@
               <a:spcAft>
                 <a:spcPts val="500"/>
               </a:spcAft>
-              <a:defRPr sz="1500">
+              <a:defRPr sz="1600">
                 <a:solidFill>
                   <a:srgbClr val="404040"/>
                 </a:solidFill>
               </a:defRPr>
             </a:pPr>
             <a:r>
-              <a:t>Frente como parábola por puntos medios de pares con salto: inestable, dejaba una costura.</a:t>
+              <a:t>1–3) Optuna + grid/uniform con hiperparámetros + la grilla como hiperparámetro: 181 trials en Mendieta. Mejor DIP con 64 puntos en grilla: 29.9 dB (config 'vase' del paper afinada); uniform siempre peor. En el muestreo nuevo, la grilla (6 columnas × 5 filas) es el parámetro más sensible.</a:t>
             </a:r>
           </a:p>
           <a:p>
@@ -5182,14 +5301,14 @@
               <a:spcAft>
                 <a:spcPts val="500"/>
               </a:spcAft>
-              <a:defRPr sz="1500">
+              <a:defRPr sz="1600">
                 <a:solidFill>
                   <a:srgbClr val="404040"/>
                 </a:solidFill>
               </a:defRPr>
             </a:pPr>
             <a:r>
-              <a:t>Bisección al nivel medio: en los g suaves caía dentro de la rampa, no en el acantilado.</a:t>
+              <a:t>4) Ventana: la bisección ya concentra ~25 de los 64 puntos en una franja angosta alrededor del frente (ventana adaptativa).</a:t>
             </a:r>
           </a:p>
           <a:p>
@@ -5197,14 +5316,14 @@
               <a:spcAft>
                 <a:spcPts val="500"/>
               </a:spcAft>
-              <a:defRPr sz="1500">
+              <a:defRPr sz="1600">
                 <a:solidFill>
                   <a:srgbClr val="404040"/>
                 </a:solidFill>
               </a:defRPr>
             </a:pPr>
             <a:r>
-              <a:t>Sondas del perfil de la rampa (3-7-14 px sobre el borde): le quitan presupuesto al relleno.</a:t>
+              <a:t>5) Rosenbrock en 3D: hecho (diapositiva anterior).</a:t>
             </a:r>
           </a:p>
           <a:p>
@@ -5212,74 +5331,14 @@
               <a:spcAft>
                 <a:spcPts val="500"/>
               </a:spcAft>
-              <a:defRPr sz="1500">
+              <a:defRPr sz="1600">
                 <a:solidFill>
                   <a:srgbClr val="404040"/>
                 </a:solidFill>
               </a:defRPr>
             </a:pPr>
             <a:r>
-              <a:t>Proceso gaussiano en lugar de la TPS: con tan pocos puntos, las escalas aprendidas quedan mal (g=-2: 22 dB vs. 36).</a:t>
-            </a:r>
-          </a:p>
-          <a:p>
-            <a:pPr>
-              <a:spcAft>
-                <a:spcPts val="500"/>
-              </a:spcAft>
-              <a:defRPr sz="1500">
-                <a:solidFill>
-                  <a:srgbClr val="404040"/>
-                </a:solidFill>
-              </a:defRPr>
-            </a:pPr>
-            <a:r>
-              <a:t>Relleno por ancho de las cotas de monotonía: mejor peor g, pero −2.7 dB en g=-4.</a:t>
-            </a:r>
-          </a:p>
-          <a:p>
-            <a:pPr>
-              <a:spcAft>
-                <a:spcPts val="500"/>
-              </a:spcAft>
-              <a:defRPr sz="1500">
-                <a:solidFill>
-                  <a:srgbClr val="404040"/>
-                </a:solidFill>
-              </a:defRPr>
-            </a:pPr>
-            <a:r>
-              <a:t>Grilla de 7-8 columnas: no falla el detector, se acaba el presupuesto en la bisección.</a:t>
-            </a:r>
-          </a:p>
-          <a:p>
-            <a:pPr>
-              <a:spcAft>
-                <a:spcPts val="500"/>
-              </a:spcAft>
-              <a:defRPr sz="1500">
-                <a:solidFill>
-                  <a:srgbClr val="404040"/>
-                </a:solidFill>
-              </a:defRPr>
-            </a:pPr>
-            <a:r>
-              <a:t>DIP 'kate' del paper con 64 puntos (18 dB): pensado para imágenes casi completas.</a:t>
-            </a:r>
-          </a:p>
-          <a:p>
-            <a:pPr>
-              <a:spcAft>
-                <a:spcPts val="500"/>
-              </a:spcAft>
-              <a:defRPr sz="1500">
-                <a:solidFill>
-                  <a:srgbClr val="404040"/>
-                </a:solidFill>
-              </a:defRPr>
-            </a:pPr>
-            <a:r>
-              <a:t>Fusión sin guarda en 9 g: cuando DIP falla en un g (-4 dB), arrastra el promedio.</a:t>
+              <a:t>6) Interpolación de scipy vs. DIP: con los mismos puntos empatan con la receta de la tesis (24.4 vs. 25.0); DIP con la config del paper gana (28.5).</a:t>
             </a:r>
           </a:p>
         </p:txBody>
@@ -5444,6 +5503,202 @@
               </a:defRPr>
             </a:pPr>
             <a:r>
+              <a:t>Lo que se probó y NO funcionó (para no repetirlo)</a:t>
+            </a:r>
+          </a:p>
+        </p:txBody>
+      </p:sp>
+      <p:sp>
+        <p:nvSpPr>
+          <p:cNvPr id="3" name="TextBox 2"/>
+          <p:cNvSpPr txBox="1"/>
+          <p:nvPr/>
+        </p:nvSpPr>
+        <p:spPr>
+          <a:xfrm>
+            <a:off x="548640" y="1280160"/>
+            <a:ext cx="10972800" cy="5120640"/>
+          </a:xfrm>
+          <a:prstGeom prst="rect">
+            <a:avLst/>
+          </a:prstGeom>
+          <a:noFill/>
+        </p:spPr>
+        <p:txBody>
+          <a:bodyPr wrap="square">
+            <a:spAutoFit/>
+          </a:bodyPr>
+          <a:lstStyle/>
+          <a:p>
+            <a:pPr>
+              <a:spcAft>
+                <a:spcPts val="500"/>
+              </a:spcAft>
+              <a:defRPr sz="1500">
+                <a:solidFill>
+                  <a:srgbClr val="404040"/>
+                </a:solidFill>
+              </a:defRPr>
+            </a:pPr>
+            <a:r>
+              <a:t>Frente como parábola por puntos medios de pares con salto: inestable, dejaba una costura.</a:t>
+            </a:r>
+          </a:p>
+          <a:p>
+            <a:pPr>
+              <a:spcAft>
+                <a:spcPts val="500"/>
+              </a:spcAft>
+              <a:defRPr sz="1500">
+                <a:solidFill>
+                  <a:srgbClr val="404040"/>
+                </a:solidFill>
+              </a:defRPr>
+            </a:pPr>
+            <a:r>
+              <a:t>Bisección al nivel medio: en los g suaves caía dentro de la rampa, no en el acantilado.</a:t>
+            </a:r>
+          </a:p>
+          <a:p>
+            <a:pPr>
+              <a:spcAft>
+                <a:spcPts val="500"/>
+              </a:spcAft>
+              <a:defRPr sz="1500">
+                <a:solidFill>
+                  <a:srgbClr val="404040"/>
+                </a:solidFill>
+              </a:defRPr>
+            </a:pPr>
+            <a:r>
+              <a:t>Sondas del perfil de la rampa (3-7-14 px sobre el borde): le quitan presupuesto al relleno.</a:t>
+            </a:r>
+          </a:p>
+          <a:p>
+            <a:pPr>
+              <a:spcAft>
+                <a:spcPts val="500"/>
+              </a:spcAft>
+              <a:defRPr sz="1500">
+                <a:solidFill>
+                  <a:srgbClr val="404040"/>
+                </a:solidFill>
+              </a:defRPr>
+            </a:pPr>
+            <a:r>
+              <a:t>Proceso gaussiano en lugar de la TPS: con tan pocos puntos, las escalas aprendidas quedan mal (g=-2: 22 dB vs. 36).</a:t>
+            </a:r>
+          </a:p>
+          <a:p>
+            <a:pPr>
+              <a:spcAft>
+                <a:spcPts val="500"/>
+              </a:spcAft>
+              <a:defRPr sz="1500">
+                <a:solidFill>
+                  <a:srgbClr val="404040"/>
+                </a:solidFill>
+              </a:defRPr>
+            </a:pPr>
+            <a:r>
+              <a:t>Relleno por ancho de las cotas de monotonía: mejor peor g, pero −2.7 dB en g=-4.</a:t>
+            </a:r>
+          </a:p>
+          <a:p>
+            <a:pPr>
+              <a:spcAft>
+                <a:spcPts val="500"/>
+              </a:spcAft>
+              <a:defRPr sz="1500">
+                <a:solidFill>
+                  <a:srgbClr val="404040"/>
+                </a:solidFill>
+              </a:defRPr>
+            </a:pPr>
+            <a:r>
+              <a:t>Grilla de 7-8 columnas: no falla el detector, se acaba el presupuesto en la bisección.</a:t>
+            </a:r>
+          </a:p>
+          <a:p>
+            <a:pPr>
+              <a:spcAft>
+                <a:spcPts val="500"/>
+              </a:spcAft>
+              <a:defRPr sz="1500">
+                <a:solidFill>
+                  <a:srgbClr val="404040"/>
+                </a:solidFill>
+              </a:defRPr>
+            </a:pPr>
+            <a:r>
+              <a:t>DIP 'kate' del paper con 64 puntos (18 dB): pensado para imágenes casi completas.</a:t>
+            </a:r>
+          </a:p>
+          <a:p>
+            <a:pPr>
+              <a:spcAft>
+                <a:spcPts val="500"/>
+              </a:spcAft>
+              <a:defRPr sz="1500">
+                <a:solidFill>
+                  <a:srgbClr val="404040"/>
+                </a:solidFill>
+              </a:defRPr>
+            </a:pPr>
+            <a:r>
+              <a:t>Fusión sin guarda en 9 g: cuando DIP falla en un g (-4 dB), arrastra el promedio.</a:t>
+            </a:r>
+          </a:p>
+        </p:txBody>
+      </p:sp>
+    </p:spTree>
+  </p:cSld>
+  <p:clrMapOvr>
+    <a:masterClrMapping/>
+  </p:clrMapOvr>
+</p:sld>
+</file>
+
+<file path=ppt/slides/slide21.xml><?xml version="1.0" encoding="utf-8"?>
+<p:sld xmlns:a="http://schemas.openxmlformats.org/drawingml/2006/main" xmlns:p="http://schemas.openxmlformats.org/presentationml/2006/main" xmlns:r="http://schemas.openxmlformats.org/officeDocument/2006/relationships">
+  <p:cSld>
+    <p:spTree>
+      <p:nvGrpSpPr>
+        <p:cNvPr id="1" name=""/>
+        <p:cNvGrpSpPr/>
+        <p:nvPr/>
+      </p:nvGrpSpPr>
+      <p:grpSpPr/>
+      <p:sp>
+        <p:nvSpPr>
+          <p:cNvPr id="2" name="TextBox 1"/>
+          <p:cNvSpPr txBox="1"/>
+          <p:nvPr/>
+        </p:nvSpPr>
+        <p:spPr>
+          <a:xfrm>
+            <a:off x="548640" y="320040"/>
+            <a:ext cx="11064240" cy="822960"/>
+          </a:xfrm>
+          <a:prstGeom prst="rect">
+            <a:avLst/>
+          </a:prstGeom>
+          <a:noFill/>
+        </p:spPr>
+        <p:txBody>
+          <a:bodyPr wrap="square">
+            <a:spAutoFit/>
+          </a:bodyPr>
+          <a:lstStyle/>
+          <a:p>
+            <a:pPr>
+              <a:defRPr sz="2700" b="1">
+                <a:solidFill>
+                  <a:srgbClr val="1F3B73"/>
+                </a:solidFill>
+              </a:defRPr>
+            </a:pPr>
+            <a:r>
               <a:t>Para KMC: recomendación y lo que falta validar</a:t>
             </a:r>
           </a:p>
@@ -5557,7 +5812,7 @@
               </a:defRPr>
             </a:pPr>
             <a:r>
-              <a:t>Ruido: con σ = 0.01 la receta robusta pierde ~2 dB y con σ = 0.03 ~6 dB (sin DIP). Falta DIP con ruido (en Mendieta). Hay que estimar σ de KMC con corridas repetidas.</a:t>
+              <a:t>Ruido: con σ = 0.01 se pierden ~1.5 dB y con σ = 0.03 ~5 dB (fusión con DIP). Con ruido DIP suma más (sobre todo SSIM). Hay que estimar σ de KMC con corridas repetidas.</a:t>
             </a:r>
           </a:p>
           <a:p>

</xml_diff>

<commit_message>
autoexp: planificador de tandas para KMC (kmc_planner), biseccion en lote, LOO sin suavizado (reproduce 40.6 en 9 g), sigma=0.05 con DIP; presentacion y docs
</commit_message>
<xml_diff>
--- a/presentaciones/presentacion4_autoexp/presentacion4_autoexp.pptx
+++ b/presentaciones/presentacion4_autoexp/presentacion4_autoexp.pptx
@@ -26,6 +26,7 @@
     <p:sldId id="274" r:id="rId25"/>
     <p:sldId id="275" r:id="rId26"/>
     <p:sldId id="276" r:id="rId27"/>
+    <p:sldId id="277" r:id="rId28"/>
   </p:sldIdLst>
   <p:sldSz cx="12188952" cy="6858000" type="screen4x3"/>
   <p:notesSz cx="6858000" cy="9144000"/>
@@ -4798,7 +4799,7 @@
         </p:nvGraphicFramePr>
         <p:xfrm>
           <a:off x="731520" y="1371600"/>
-          <a:ext cx="10698480" cy="1152144"/>
+          <a:ext cx="10698480" cy="1536192"/>
         </p:xfrm>
         <a:graphic>
           <a:graphicData uri="http://schemas.openxmlformats.org/drawingml/2006/table">
@@ -5044,6 +5045,83 @@
                   <a:tcPr/>
                 </a:tc>
               </a:tr>
+              <a:tr h="384048">
+                <a:tc>
+                  <a:txBody>
+                    <a:bodyPr/>
+                    <a:lstStyle/>
+                    <a:p>
+                      <a:pPr>
+                        <a:defRPr sz="1200" b="1"/>
+                      </a:pPr>
+                      <a:r>
+                        <a:t>0.05</a:t>
+                      </a:r>
+                    </a:p>
+                  </a:txBody>
+                  <a:tcPr/>
+                </a:tc>
+                <a:tc>
+                  <a:txBody>
+                    <a:bodyPr/>
+                    <a:lstStyle/>
+                    <a:p>
+                      <a:pPr>
+                        <a:defRPr sz="1200" b="0"/>
+                      </a:pPr>
+                      <a:r>
+                        <a:t>31.4 (30.7)</a:t>
+                      </a:r>
+                    </a:p>
+                  </a:txBody>
+                  <a:tcPr/>
+                </a:tc>
+                <a:tc>
+                  <a:txBody>
+                    <a:bodyPr/>
+                    <a:lstStyle/>
+                    <a:p>
+                      <a:pPr>
+                        <a:defRPr sz="1200" b="0"/>
+                      </a:pPr>
+                      <a:r>
+                        <a:t>29.6 (28.9)</a:t>
+                      </a:r>
+                    </a:p>
+                  </a:txBody>
+                  <a:tcPr/>
+                </a:tc>
+                <a:tc>
+                  <a:txBody>
+                    <a:bodyPr/>
+                    <a:lstStyle/>
+                    <a:p>
+                      <a:pPr>
+                        <a:defRPr sz="1200" b="0"/>
+                      </a:pPr>
+                      <a:r>
+                        <a:t>32.6 (31.2)</a:t>
+                      </a:r>
+                    </a:p>
+                  </a:txBody>
+                  <a:tcPr/>
+                </a:tc>
+                <a:tc>
+                  <a:txBody>
+                    <a:bodyPr/>
+                    <a:lstStyle/>
+                    <a:p>
+                      <a:pPr>
+                        <a:defRPr sz="1200" b="0"/>
+                      </a:pPr>
+                      <a:r>
+                        <a:t>0.939 → 0.968</a:t>
+                      </a:r>
+                    </a:p>
+                  </a:txBody>
+                  <a:tcPr/>
+                </a:tc>
+              </a:tr>
             </a:tbl>
           </a:graphicData>
         </a:graphic>
@@ -5056,7 +5134,7 @@
         </p:nvSpPr>
         <p:spPr>
           <a:xfrm>
-            <a:off x="731520" y="2615184"/>
+            <a:off x="731520" y="2999232"/>
             <a:ext cx="10698480" cy="1280160"/>
           </a:xfrm>
           <a:prstGeom prst="rect">
@@ -5078,19 +5156,7 @@
               </a:defRPr>
             </a:pPr>
             <a:r>
-              <a:t>Media (peor g). Con ruido, DIP solo pierde contra la TPS, pero fusionado suma ~0.7 dB, más en el peor g, y sobre todo en SSIM: DIP filtra el ruido que la TPS copia punto a punto.</a:t>
-            </a:r>
-          </a:p>
-          <a:p>
-            <a:pPr>
-              <a:defRPr sz="1200" i="1">
-                <a:solidFill>
-                  <a:srgbClr val="404040"/>
-                </a:solidFill>
-              </a:defRPr>
-            </a:pPr>
-            <a:r>
-              <a:t>Guarda con ruido: 0.02 + 2σ.</a:t>
+              <a:t>Media (peor g). Con ruido, DIP solo pierde contra la TPS, pero fusionado suma, y más cuanto más ruido (+0.7, +0.7, +1.2 dB), sobre todo en SSIM: DIP filtra el ruido que la TPS copia punto a punto. Guarda con ruido: 0.02 + 2σ.</a:t>
             </a:r>
           </a:p>
         </p:txBody>
@@ -5660,6 +5726,157 @@
 </file>
 
 <file path=ppt/slides/slide21.xml><?xml version="1.0" encoding="utf-8"?>
+<p:sld xmlns:a="http://schemas.openxmlformats.org/drawingml/2006/main" xmlns:p="http://schemas.openxmlformats.org/presentationml/2006/main" xmlns:r="http://schemas.openxmlformats.org/officeDocument/2006/relationships">
+  <p:cSld>
+    <p:spTree>
+      <p:nvGrpSpPr>
+        <p:cNvPr id="1" name=""/>
+        <p:cNvGrpSpPr/>
+        <p:nvPr/>
+      </p:nvGrpSpPr>
+      <p:grpSpPr/>
+      <p:sp>
+        <p:nvSpPr>
+          <p:cNvPr id="2" name="TextBox 1"/>
+          <p:cNvSpPr txBox="1"/>
+          <p:nvPr/>
+        </p:nvSpPr>
+        <p:spPr>
+          <a:xfrm>
+            <a:off x="548640" y="320040"/>
+            <a:ext cx="11064240" cy="822960"/>
+          </a:xfrm>
+          <a:prstGeom prst="rect">
+            <a:avLst/>
+          </a:prstGeom>
+          <a:noFill/>
+        </p:spPr>
+        <p:txBody>
+          <a:bodyPr wrap="square">
+            <a:spAutoFit/>
+          </a:bodyPr>
+          <a:lstStyle/>
+          <a:p>
+            <a:pPr>
+              <a:defRPr sz="2700" b="1">
+                <a:solidFill>
+                  <a:srgbClr val="1F3B73"/>
+                </a:solidFill>
+              </a:defRPr>
+            </a:pPr>
+            <a:r>
+              <a:t>Listo para KMC: planificador de tandas (autoexp/kmc_planner.py)</a:t>
+            </a:r>
+          </a:p>
+        </p:txBody>
+      </p:sp>
+      <p:sp>
+        <p:nvSpPr>
+          <p:cNvPr id="3" name="TextBox 2"/>
+          <p:cNvSpPr txBox="1"/>
+          <p:nvPr/>
+        </p:nvSpPr>
+        <p:spPr>
+          <a:xfrm>
+            <a:off x="548640" y="1280160"/>
+            <a:ext cx="10972800" cy="5120640"/>
+          </a:xfrm>
+          <a:prstGeom prst="rect">
+            <a:avLst/>
+          </a:prstGeom>
+          <a:noFill/>
+        </p:spPr>
+        <p:txBody>
+          <a:bodyPr wrap="square">
+            <a:spAutoFit/>
+          </a:bodyPr>
+          <a:lstStyle/>
+          <a:p>
+            <a:pPr>
+              <a:spcAft>
+                <a:spcPts val="500"/>
+              </a:spcAft>
+              <a:defRPr sz="1700">
+                <a:solidFill>
+                  <a:srgbClr val="404040"/>
+                </a:solidFill>
+              </a:defRPr>
+            </a:pPr>
+            <a:r>
+              <a:t>init --budget 64 --sigma σ  →  next  →  (correr KMC)  →  add resultados.csv  →  next ...  →  reconstruct</a:t>
+            </a:r>
+          </a:p>
+          <a:p>
+            <a:pPr>
+              <a:spcAft>
+                <a:spcPts val="500"/>
+              </a:spcAft>
+              <a:defRPr sz="1700">
+                <a:solidFill>
+                  <a:srgbClr val="404040"/>
+                </a:solidFill>
+              </a:defRPr>
+            </a:pPr>
+            <a:r>
+              <a:t>Cada 'next' devuelve la tanda siguiente en (log Ξ, log ℓ), para correr en paralelo en el cluster.</a:t>
+            </a:r>
+          </a:p>
+          <a:p>
+            <a:pPr>
+              <a:spcAft>
+                <a:spcPts val="500"/>
+              </a:spcAft>
+              <a:defRPr sz="1700">
+                <a:solidFill>
+                  <a:srgbClr val="404040"/>
+                </a:solidFill>
+              </a:defRPr>
+            </a:pPr>
+            <a:r>
+              <a:t>Con 64 puntos: 9 tandas = 30 (grilla) + 4-5 rondas de ~5 (bisección) + 3-4 rondas de 4 (relleno).</a:t>
+            </a:r>
+          </a:p>
+          <a:p>
+            <a:pPr>
+              <a:spcAft>
+                <a:spcPts val="500"/>
+              </a:spcAft>
+              <a:defRPr sz="1700">
+                <a:solidFill>
+                  <a:srgbClr val="404040"/>
+                </a:solidFill>
+              </a:defRPr>
+            </a:pPr>
+            <a:r>
+              <a:t>Probado de punta a punta contra el modelo del continuo (simulate): g=-4 46.2 dB, g=-2 38.6, g=-0.5 39.4; g=-2 con ruido σ=0.01: 37.6.</a:t>
+            </a:r>
+          </a:p>
+          <a:p>
+            <a:pPr>
+              <a:spcAft>
+                <a:spcPts val="500"/>
+              </a:spcAft>
+              <a:defRPr sz="1700">
+                <a:solidFill>
+                  <a:srgbClr val="404040"/>
+                </a:solidFill>
+              </a:defRPr>
+            </a:pPr>
+            <a:r>
+              <a:t>σ se estima con corridas repetidas de KMC (NRUNS) y fija todos los umbrales solo.</a:t>
+            </a:r>
+          </a:p>
+        </p:txBody>
+      </p:sp>
+    </p:spTree>
+  </p:cSld>
+  <p:clrMapOvr>
+    <a:masterClrMapping/>
+  </p:clrMapOvr>
+</p:sld>
+</file>
+
+<file path=ppt/slides/slide22.xml><?xml version="1.0" encoding="utf-8"?>
 <p:sld xmlns:a="http://schemas.openxmlformats.org/drawingml/2006/main" xmlns:p="http://schemas.openxmlformats.org/presentationml/2006/main" xmlns:r="http://schemas.openxmlformats.org/officeDocument/2006/relationships">
   <p:cSld>
     <p:spTree>

</xml_diff>

<commit_message>
Presentacion 4: figura de que zona rellena cada metodo (0 / TPS / DIP)
</commit_message>
<xml_diff>
--- a/presentaciones/presentacion4_autoexp/presentacion4_autoexp.pptx
+++ b/presentaciones/presentacion4_autoexp/presentacion4_autoexp.pptx
@@ -27,6 +27,7 @@
     <p:sldId id="275" r:id="rId26"/>
     <p:sldId id="276" r:id="rId27"/>
     <p:sldId id="277" r:id="rId28"/>
+    <p:sldId id="278" r:id="rId29"/>
   </p:sldIdLst>
   <p:sldSz cx="12188952" cy="6858000" type="screen4x3"/>
   <p:notesSz cx="6858000" cy="9144000"/>
@@ -4672,6 +4673,118 @@
               </a:defRPr>
             </a:pPr>
             <a:r>
+              <a:t>Quién rellena cada zona: 0 / TPS / DIP</a:t>
+            </a:r>
+          </a:p>
+        </p:txBody>
+      </p:sp>
+      <p:pic>
+        <p:nvPicPr>
+          <p:cNvPr id="3" name="Picture 2" descr="zonas_tps_dip.png"/>
+          <p:cNvPicPr>
+            <a:picLocks noChangeAspect="1"/>
+          </p:cNvPicPr>
+          <p:nvPr/>
+        </p:nvPicPr>
+        <p:blipFill>
+          <a:blip r:embed="rId2"/>
+          <a:stretch>
+            <a:fillRect/>
+          </a:stretch>
+        </p:blipFill>
+        <p:spPr>
+          <a:xfrm>
+            <a:off x="333756" y="2039112"/>
+            <a:ext cx="11521440" cy="3328415"/>
+          </a:xfrm>
+          <a:prstGeom prst="rect">
+            <a:avLst/>
+          </a:prstGeom>
+        </p:spPr>
+      </p:pic>
+      <p:sp>
+        <p:nvSpPr>
+          <p:cNvPr id="4" name="TextBox 3"/>
+          <p:cNvSpPr txBox="1"/>
+          <p:nvPr/>
+        </p:nvSpPr>
+        <p:spPr>
+          <a:xfrm>
+            <a:off x="548640" y="6172200"/>
+            <a:ext cx="11064240" cy="640080"/>
+          </a:xfrm>
+          <a:prstGeom prst="rect">
+            <a:avLst/>
+          </a:prstGeom>
+          <a:noFill/>
+        </p:spPr>
+        <p:txBody>
+          <a:bodyPr wrap="square">
+            <a:spAutoFit/>
+          </a:bodyPr>
+          <a:lstStyle/>
+          <a:p>
+            <a:pPr algn="ctr">
+              <a:defRPr sz="1200" i="1">
+                <a:solidFill>
+                  <a:srgbClr val="404040"/>
+                </a:solidFill>
+              </a:defRPr>
+            </a:pPr>
+            <a:r>
+              <a:t>Debajo del borde (salto a 0): 0 directo. Pegado al borde: interpolación TPS. Lejos del borde, en la zona lisa: DIP. El paso entre TPS y DIP es gradual (peso exp(−(d/20)²)).</a:t>
+            </a:r>
+          </a:p>
+        </p:txBody>
+      </p:sp>
+    </p:spTree>
+  </p:cSld>
+  <p:clrMapOvr>
+    <a:masterClrMapping/>
+  </p:clrMapOvr>
+</p:sld>
+</file>
+
+<file path=ppt/slides/slide17.xml><?xml version="1.0" encoding="utf-8"?>
+<p:sld xmlns:a="http://schemas.openxmlformats.org/drawingml/2006/main" xmlns:p="http://schemas.openxmlformats.org/presentationml/2006/main" xmlns:r="http://schemas.openxmlformats.org/officeDocument/2006/relationships">
+  <p:cSld>
+    <p:spTree>
+      <p:nvGrpSpPr>
+        <p:cNvPr id="1" name=""/>
+        <p:cNvGrpSpPr/>
+        <p:nvPr/>
+      </p:nvGrpSpPr>
+      <p:grpSpPr/>
+      <p:sp>
+        <p:nvSpPr>
+          <p:cNvPr id="2" name="TextBox 1"/>
+          <p:cNvSpPr txBox="1"/>
+          <p:nvPr/>
+        </p:nvSpPr>
+        <p:spPr>
+          <a:xfrm>
+            <a:off x="548640" y="320040"/>
+            <a:ext cx="11064240" cy="822960"/>
+          </a:xfrm>
+          <a:prstGeom prst="rect">
+            <a:avLst/>
+          </a:prstGeom>
+          <a:noFill/>
+        </p:spPr>
+        <p:txBody>
+          <a:bodyPr wrap="square">
+            <a:spAutoFit/>
+          </a:bodyPr>
+          <a:lstStyle/>
+          <a:p>
+            <a:pPr>
+              <a:defRPr sz="2600" b="1">
+                <a:solidFill>
+                  <a:srgbClr val="1F3B73"/>
+                </a:solidFill>
+              </a:defRPr>
+            </a:pPr>
+            <a:r>
               <a:t>Ruido tipo KMC: la receta se puede hacer robusta</a:t>
             </a:r>
           </a:p>
@@ -4744,7 +4857,7 @@
 </p:sld>
 </file>
 
-<file path=ppt/slides/slide17.xml><?xml version="1.0" encoding="utf-8"?>
+<file path=ppt/slides/slide18.xml><?xml version="1.0" encoding="utf-8"?>
 <p:sld xmlns:a="http://schemas.openxmlformats.org/drawingml/2006/main" xmlns:p="http://schemas.openxmlformats.org/presentationml/2006/main" xmlns:r="http://schemas.openxmlformats.org/officeDocument/2006/relationships">
   <p:cSld>
     <p:spTree>
@@ -5169,7 +5282,7 @@
 </p:sld>
 </file>
 
-<file path=ppt/slides/slide18.xml><?xml version="1.0" encoding="utf-8"?>
+<file path=ppt/slides/slide19.xml><?xml version="1.0" encoding="utf-8"?>
 <p:sld xmlns:a="http://schemas.openxmlformats.org/drawingml/2006/main" xmlns:p="http://schemas.openxmlformats.org/presentationml/2006/main" xmlns:r="http://schemas.openxmlformats.org/officeDocument/2006/relationships">
   <p:cSld>
     <p:spTree>
@@ -5269,142 +5382,6 @@
             </a:pPr>
             <a:r>
               <a:t>Con 1 % DIP recupera la forma pero la cresta angosta queda ondulada; con 5 % queda fiel. Con 64 puntos la TPS da una superficie reconocible pero con bultos.</a:t>
-            </a:r>
-          </a:p>
-        </p:txBody>
-      </p:sp>
-    </p:spTree>
-  </p:cSld>
-  <p:clrMapOvr>
-    <a:masterClrMapping/>
-  </p:clrMapOvr>
-</p:sld>
-</file>
-
-<file path=ppt/slides/slide19.xml><?xml version="1.0" encoding="utf-8"?>
-<p:sld xmlns:a="http://schemas.openxmlformats.org/drawingml/2006/main" xmlns:p="http://schemas.openxmlformats.org/presentationml/2006/main" xmlns:r="http://schemas.openxmlformats.org/officeDocument/2006/relationships">
-  <p:cSld>
-    <p:spTree>
-      <p:nvGrpSpPr>
-        <p:cNvPr id="1" name=""/>
-        <p:cNvGrpSpPr/>
-        <p:nvPr/>
-      </p:nvGrpSpPr>
-      <p:grpSpPr/>
-      <p:sp>
-        <p:nvSpPr>
-          <p:cNvPr id="2" name="TextBox 1"/>
-          <p:cNvSpPr txBox="1"/>
-          <p:nvPr/>
-        </p:nvSpPr>
-        <p:spPr>
-          <a:xfrm>
-            <a:off x="548640" y="320040"/>
-            <a:ext cx="11064240" cy="822960"/>
-          </a:xfrm>
-          <a:prstGeom prst="rect">
-            <a:avLst/>
-          </a:prstGeom>
-          <a:noFill/>
-        </p:spPr>
-        <p:txBody>
-          <a:bodyPr wrap="square">
-            <a:spAutoFit/>
-          </a:bodyPr>
-          <a:lstStyle/>
-          <a:p>
-            <a:pPr>
-              <a:defRPr sz="2700" b="1">
-                <a:solidFill>
-                  <a:srgbClr val="1F3B73"/>
-                </a:solidFill>
-              </a:defRPr>
-            </a:pPr>
-            <a:r>
-              <a:t>Pedidos de la reunión: estado</a:t>
-            </a:r>
-          </a:p>
-        </p:txBody>
-      </p:sp>
-      <p:sp>
-        <p:nvSpPr>
-          <p:cNvPr id="3" name="TextBox 2"/>
-          <p:cNvSpPr txBox="1"/>
-          <p:nvPr/>
-        </p:nvSpPr>
-        <p:spPr>
-          <a:xfrm>
-            <a:off x="548640" y="1280160"/>
-            <a:ext cx="10972800" cy="5120640"/>
-          </a:xfrm>
-          <a:prstGeom prst="rect">
-            <a:avLst/>
-          </a:prstGeom>
-          <a:noFill/>
-        </p:spPr>
-        <p:txBody>
-          <a:bodyPr wrap="square">
-            <a:spAutoFit/>
-          </a:bodyPr>
-          <a:lstStyle/>
-          <a:p>
-            <a:pPr>
-              <a:spcAft>
-                <a:spcPts val="500"/>
-              </a:spcAft>
-              <a:defRPr sz="1600">
-                <a:solidFill>
-                  <a:srgbClr val="404040"/>
-                </a:solidFill>
-              </a:defRPr>
-            </a:pPr>
-            <a:r>
-              <a:t>1–3) Optuna + grid/uniform con hiperparámetros + la grilla como hiperparámetro: 181 trials en Mendieta. Mejor DIP con 64 puntos en grilla: 29.9 dB (config 'vase' del paper afinada); uniform siempre peor. En el muestreo nuevo, la grilla (6 columnas × 5 filas) es el parámetro más sensible.</a:t>
-            </a:r>
-          </a:p>
-          <a:p>
-            <a:pPr>
-              <a:spcAft>
-                <a:spcPts val="500"/>
-              </a:spcAft>
-              <a:defRPr sz="1600">
-                <a:solidFill>
-                  <a:srgbClr val="404040"/>
-                </a:solidFill>
-              </a:defRPr>
-            </a:pPr>
-            <a:r>
-              <a:t>4) Ventana: la bisección ya concentra ~25 de los 64 puntos en una franja angosta alrededor del frente (ventana adaptativa).</a:t>
-            </a:r>
-          </a:p>
-          <a:p>
-            <a:pPr>
-              <a:spcAft>
-                <a:spcPts val="500"/>
-              </a:spcAft>
-              <a:defRPr sz="1600">
-                <a:solidFill>
-                  <a:srgbClr val="404040"/>
-                </a:solidFill>
-              </a:defRPr>
-            </a:pPr>
-            <a:r>
-              <a:t>5) Rosenbrock en 3D: hecho (diapositiva anterior).</a:t>
-            </a:r>
-          </a:p>
-          <a:p>
-            <a:pPr>
-              <a:spcAft>
-                <a:spcPts val="500"/>
-              </a:spcAft>
-              <a:defRPr sz="1600">
-                <a:solidFill>
-                  <a:srgbClr val="404040"/>
-                </a:solidFill>
-              </a:defRPr>
-            </a:pPr>
-            <a:r>
-              <a:t>6) Interpolación de scipy vs. DIP: con los mismos puntos empatan con la receta de la tesis (24.4 vs. 25.0); DIP con la config del paper gana (28.5).</a:t>
             </a:r>
           </a:p>
         </p:txBody>
@@ -5569,7 +5546,7 @@
               </a:defRPr>
             </a:pPr>
             <a:r>
-              <a:t>Lo que se probó y NO funcionó (para no repetirlo)</a:t>
+              <a:t>Pedidos de la reunión: estado</a:t>
             </a:r>
           </a:p>
         </p:txBody>
@@ -5600,14 +5577,14 @@
               <a:spcAft>
                 <a:spcPts val="500"/>
               </a:spcAft>
-              <a:defRPr sz="1500">
+              <a:defRPr sz="1600">
                 <a:solidFill>
                   <a:srgbClr val="404040"/>
                 </a:solidFill>
               </a:defRPr>
             </a:pPr>
             <a:r>
-              <a:t>Frente como parábola por puntos medios de pares con salto: inestable, dejaba una costura.</a:t>
+              <a:t>1–3) Optuna + grid/uniform con hiperparámetros + la grilla como hiperparámetro: 181 trials en Mendieta. Mejor DIP con 64 puntos en grilla: 29.9 dB (config 'vase' del paper afinada); uniform siempre peor. En el muestreo nuevo, la grilla (6 columnas × 5 filas) es el parámetro más sensible.</a:t>
             </a:r>
           </a:p>
           <a:p>
@@ -5615,14 +5592,14 @@
               <a:spcAft>
                 <a:spcPts val="500"/>
               </a:spcAft>
-              <a:defRPr sz="1500">
+              <a:defRPr sz="1600">
                 <a:solidFill>
                   <a:srgbClr val="404040"/>
                 </a:solidFill>
               </a:defRPr>
             </a:pPr>
             <a:r>
-              <a:t>Bisección al nivel medio: en los g suaves caía dentro de la rampa, no en el acantilado.</a:t>
+              <a:t>4) Ventana: la bisección ya concentra ~25 de los 64 puntos en una franja angosta alrededor del frente (ventana adaptativa).</a:t>
             </a:r>
           </a:p>
           <a:p>
@@ -5630,14 +5607,14 @@
               <a:spcAft>
                 <a:spcPts val="500"/>
               </a:spcAft>
-              <a:defRPr sz="1500">
+              <a:defRPr sz="1600">
                 <a:solidFill>
                   <a:srgbClr val="404040"/>
                 </a:solidFill>
               </a:defRPr>
             </a:pPr>
             <a:r>
-              <a:t>Sondas del perfil de la rampa (3-7-14 px sobre el borde): le quitan presupuesto al relleno.</a:t>
+              <a:t>5) Rosenbrock en 3D: hecho (diapositiva anterior).</a:t>
             </a:r>
           </a:p>
           <a:p>
@@ -5645,74 +5622,14 @@
               <a:spcAft>
                 <a:spcPts val="500"/>
               </a:spcAft>
-              <a:defRPr sz="1500">
+              <a:defRPr sz="1600">
                 <a:solidFill>
                   <a:srgbClr val="404040"/>
                 </a:solidFill>
               </a:defRPr>
             </a:pPr>
             <a:r>
-              <a:t>Proceso gaussiano en lugar de la TPS: con tan pocos puntos, las escalas aprendidas quedan mal (g=-2: 22 dB vs. 36).</a:t>
-            </a:r>
-          </a:p>
-          <a:p>
-            <a:pPr>
-              <a:spcAft>
-                <a:spcPts val="500"/>
-              </a:spcAft>
-              <a:defRPr sz="1500">
-                <a:solidFill>
-                  <a:srgbClr val="404040"/>
-                </a:solidFill>
-              </a:defRPr>
-            </a:pPr>
-            <a:r>
-              <a:t>Relleno por ancho de las cotas de monotonía: mejor peor g, pero −2.7 dB en g=-4.</a:t>
-            </a:r>
-          </a:p>
-          <a:p>
-            <a:pPr>
-              <a:spcAft>
-                <a:spcPts val="500"/>
-              </a:spcAft>
-              <a:defRPr sz="1500">
-                <a:solidFill>
-                  <a:srgbClr val="404040"/>
-                </a:solidFill>
-              </a:defRPr>
-            </a:pPr>
-            <a:r>
-              <a:t>Grilla de 7-8 columnas: no falla el detector, se acaba el presupuesto en la bisección.</a:t>
-            </a:r>
-          </a:p>
-          <a:p>
-            <a:pPr>
-              <a:spcAft>
-                <a:spcPts val="500"/>
-              </a:spcAft>
-              <a:defRPr sz="1500">
-                <a:solidFill>
-                  <a:srgbClr val="404040"/>
-                </a:solidFill>
-              </a:defRPr>
-            </a:pPr>
-            <a:r>
-              <a:t>DIP 'kate' del paper con 64 puntos (18 dB): pensado para imágenes casi completas.</a:t>
-            </a:r>
-          </a:p>
-          <a:p>
-            <a:pPr>
-              <a:spcAft>
-                <a:spcPts val="500"/>
-              </a:spcAft>
-              <a:defRPr sz="1500">
-                <a:solidFill>
-                  <a:srgbClr val="404040"/>
-                </a:solidFill>
-              </a:defRPr>
-            </a:pPr>
-            <a:r>
-              <a:t>Fusión sin guarda en 9 g: cuando DIP falla en un g (-4 dB), arrastra el promedio.</a:t>
+              <a:t>6) Interpolación de scipy vs. DIP: con los mismos puntos empatan con la receta de la tesis (24.4 vs. 25.0); DIP con la config del paper gana (28.5).</a:t>
             </a:r>
           </a:p>
         </p:txBody>
@@ -5765,7 +5682,7 @@
               </a:defRPr>
             </a:pPr>
             <a:r>
-              <a:t>Listo para KMC: planificador de tandas (autoexp/kmc_planner.py)</a:t>
+              <a:t>Lo que se probó y NO funcionó (para no repetirlo)</a:t>
             </a:r>
           </a:p>
         </p:txBody>
@@ -5796,14 +5713,14 @@
               <a:spcAft>
                 <a:spcPts val="500"/>
               </a:spcAft>
-              <a:defRPr sz="1700">
+              <a:defRPr sz="1500">
                 <a:solidFill>
                   <a:srgbClr val="404040"/>
                 </a:solidFill>
               </a:defRPr>
             </a:pPr>
             <a:r>
-              <a:t>init --budget 64 --sigma σ  →  next  →  (correr KMC)  →  add resultados.csv  →  next ...  →  reconstruct</a:t>
+              <a:t>Frente como parábola por puntos medios de pares con salto: inestable, dejaba una costura.</a:t>
             </a:r>
           </a:p>
           <a:p>
@@ -5811,14 +5728,14 @@
               <a:spcAft>
                 <a:spcPts val="500"/>
               </a:spcAft>
-              <a:defRPr sz="1700">
+              <a:defRPr sz="1500">
                 <a:solidFill>
                   <a:srgbClr val="404040"/>
                 </a:solidFill>
               </a:defRPr>
             </a:pPr>
             <a:r>
-              <a:t>Cada 'next' devuelve la tanda siguiente en (log Ξ, log ℓ), para correr en paralelo en el cluster.</a:t>
+              <a:t>Bisección al nivel medio: en los g suaves caía dentro de la rampa, no en el acantilado.</a:t>
             </a:r>
           </a:p>
           <a:p>
@@ -5826,14 +5743,14 @@
               <a:spcAft>
                 <a:spcPts val="500"/>
               </a:spcAft>
-              <a:defRPr sz="1700">
+              <a:defRPr sz="1500">
                 <a:solidFill>
                   <a:srgbClr val="404040"/>
                 </a:solidFill>
               </a:defRPr>
             </a:pPr>
             <a:r>
-              <a:t>Con 64 puntos: 9 tandas = 30 (grilla) + 4-5 rondas de ~5 (bisección) + 3-4 rondas de 4 (relleno).</a:t>
+              <a:t>Sondas del perfil de la rampa (3-7-14 px sobre el borde): le quitan presupuesto al relleno.</a:t>
             </a:r>
           </a:p>
           <a:p>
@@ -5841,14 +5758,14 @@
               <a:spcAft>
                 <a:spcPts val="500"/>
               </a:spcAft>
-              <a:defRPr sz="1700">
+              <a:defRPr sz="1500">
                 <a:solidFill>
                   <a:srgbClr val="404040"/>
                 </a:solidFill>
               </a:defRPr>
             </a:pPr>
             <a:r>
-              <a:t>Probado de punta a punta contra el modelo del continuo (simulate): g=-4 46.2 dB, g=-2 38.6, g=-0.5 39.4; g=-2 con ruido σ=0.01: 37.6.</a:t>
+              <a:t>Proceso gaussiano en lugar de la TPS: con tan pocos puntos, las escalas aprendidas quedan mal (g=-2: 22 dB vs. 36).</a:t>
             </a:r>
           </a:p>
           <a:p>
@@ -5856,14 +5773,59 @@
               <a:spcAft>
                 <a:spcPts val="500"/>
               </a:spcAft>
-              <a:defRPr sz="1700">
+              <a:defRPr sz="1500">
                 <a:solidFill>
                   <a:srgbClr val="404040"/>
                 </a:solidFill>
               </a:defRPr>
             </a:pPr>
             <a:r>
-              <a:t>σ se estima con corridas repetidas de KMC (NRUNS) y fija todos los umbrales solo.</a:t>
+              <a:t>Relleno por ancho de las cotas de monotonía: mejor peor g, pero −2.7 dB en g=-4.</a:t>
+            </a:r>
+          </a:p>
+          <a:p>
+            <a:pPr>
+              <a:spcAft>
+                <a:spcPts val="500"/>
+              </a:spcAft>
+              <a:defRPr sz="1500">
+                <a:solidFill>
+                  <a:srgbClr val="404040"/>
+                </a:solidFill>
+              </a:defRPr>
+            </a:pPr>
+            <a:r>
+              <a:t>Grilla de 7-8 columnas: no falla el detector, se acaba el presupuesto en la bisección.</a:t>
+            </a:r>
+          </a:p>
+          <a:p>
+            <a:pPr>
+              <a:spcAft>
+                <a:spcPts val="500"/>
+              </a:spcAft>
+              <a:defRPr sz="1500">
+                <a:solidFill>
+                  <a:srgbClr val="404040"/>
+                </a:solidFill>
+              </a:defRPr>
+            </a:pPr>
+            <a:r>
+              <a:t>DIP 'kate' del paper con 64 puntos (18 dB): pensado para imágenes casi completas.</a:t>
+            </a:r>
+          </a:p>
+          <a:p>
+            <a:pPr>
+              <a:spcAft>
+                <a:spcPts val="500"/>
+              </a:spcAft>
+              <a:defRPr sz="1500">
+                <a:solidFill>
+                  <a:srgbClr val="404040"/>
+                </a:solidFill>
+              </a:defRPr>
+            </a:pPr>
+            <a:r>
+              <a:t>Fusión sin guarda en 9 g: cuando DIP falla en un g (-4 dB), arrastra el promedio.</a:t>
             </a:r>
           </a:p>
         </p:txBody>
@@ -5877,6 +5839,157 @@
 </file>
 
 <file path=ppt/slides/slide22.xml><?xml version="1.0" encoding="utf-8"?>
+<p:sld xmlns:a="http://schemas.openxmlformats.org/drawingml/2006/main" xmlns:p="http://schemas.openxmlformats.org/presentationml/2006/main" xmlns:r="http://schemas.openxmlformats.org/officeDocument/2006/relationships">
+  <p:cSld>
+    <p:spTree>
+      <p:nvGrpSpPr>
+        <p:cNvPr id="1" name=""/>
+        <p:cNvGrpSpPr/>
+        <p:nvPr/>
+      </p:nvGrpSpPr>
+      <p:grpSpPr/>
+      <p:sp>
+        <p:nvSpPr>
+          <p:cNvPr id="2" name="TextBox 1"/>
+          <p:cNvSpPr txBox="1"/>
+          <p:nvPr/>
+        </p:nvSpPr>
+        <p:spPr>
+          <a:xfrm>
+            <a:off x="548640" y="320040"/>
+            <a:ext cx="11064240" cy="822960"/>
+          </a:xfrm>
+          <a:prstGeom prst="rect">
+            <a:avLst/>
+          </a:prstGeom>
+          <a:noFill/>
+        </p:spPr>
+        <p:txBody>
+          <a:bodyPr wrap="square">
+            <a:spAutoFit/>
+          </a:bodyPr>
+          <a:lstStyle/>
+          <a:p>
+            <a:pPr>
+              <a:defRPr sz="2700" b="1">
+                <a:solidFill>
+                  <a:srgbClr val="1F3B73"/>
+                </a:solidFill>
+              </a:defRPr>
+            </a:pPr>
+            <a:r>
+              <a:t>Listo para KMC: planificador de tandas (autoexp/kmc_planner.py)</a:t>
+            </a:r>
+          </a:p>
+        </p:txBody>
+      </p:sp>
+      <p:sp>
+        <p:nvSpPr>
+          <p:cNvPr id="3" name="TextBox 2"/>
+          <p:cNvSpPr txBox="1"/>
+          <p:nvPr/>
+        </p:nvSpPr>
+        <p:spPr>
+          <a:xfrm>
+            <a:off x="548640" y="1280160"/>
+            <a:ext cx="10972800" cy="5120640"/>
+          </a:xfrm>
+          <a:prstGeom prst="rect">
+            <a:avLst/>
+          </a:prstGeom>
+          <a:noFill/>
+        </p:spPr>
+        <p:txBody>
+          <a:bodyPr wrap="square">
+            <a:spAutoFit/>
+          </a:bodyPr>
+          <a:lstStyle/>
+          <a:p>
+            <a:pPr>
+              <a:spcAft>
+                <a:spcPts val="500"/>
+              </a:spcAft>
+              <a:defRPr sz="1700">
+                <a:solidFill>
+                  <a:srgbClr val="404040"/>
+                </a:solidFill>
+              </a:defRPr>
+            </a:pPr>
+            <a:r>
+              <a:t>init --budget 64 --sigma σ  →  next  →  (correr KMC)  →  add resultados.csv  →  next ...  →  reconstruct</a:t>
+            </a:r>
+          </a:p>
+          <a:p>
+            <a:pPr>
+              <a:spcAft>
+                <a:spcPts val="500"/>
+              </a:spcAft>
+              <a:defRPr sz="1700">
+                <a:solidFill>
+                  <a:srgbClr val="404040"/>
+                </a:solidFill>
+              </a:defRPr>
+            </a:pPr>
+            <a:r>
+              <a:t>Cada 'next' devuelve la tanda siguiente en (log Ξ, log ℓ), para correr en paralelo en el cluster.</a:t>
+            </a:r>
+          </a:p>
+          <a:p>
+            <a:pPr>
+              <a:spcAft>
+                <a:spcPts val="500"/>
+              </a:spcAft>
+              <a:defRPr sz="1700">
+                <a:solidFill>
+                  <a:srgbClr val="404040"/>
+                </a:solidFill>
+              </a:defRPr>
+            </a:pPr>
+            <a:r>
+              <a:t>Con 64 puntos: 9 tandas = 30 (grilla) + 4-5 rondas de ~5 (bisección) + 3-4 rondas de 4 (relleno).</a:t>
+            </a:r>
+          </a:p>
+          <a:p>
+            <a:pPr>
+              <a:spcAft>
+                <a:spcPts val="500"/>
+              </a:spcAft>
+              <a:defRPr sz="1700">
+                <a:solidFill>
+                  <a:srgbClr val="404040"/>
+                </a:solidFill>
+              </a:defRPr>
+            </a:pPr>
+            <a:r>
+              <a:t>Probado de punta a punta contra el modelo del continuo (simulate): g=-4 46.2 dB, g=-2 38.6, g=-0.5 39.4; g=-2 con ruido σ=0.01: 37.6.</a:t>
+            </a:r>
+          </a:p>
+          <a:p>
+            <a:pPr>
+              <a:spcAft>
+                <a:spcPts val="500"/>
+              </a:spcAft>
+              <a:defRPr sz="1700">
+                <a:solidFill>
+                  <a:srgbClr val="404040"/>
+                </a:solidFill>
+              </a:defRPr>
+            </a:pPr>
+            <a:r>
+              <a:t>σ se estima con corridas repetidas de KMC (NRUNS) y fija todos los umbrales solo.</a:t>
+            </a:r>
+          </a:p>
+        </p:txBody>
+      </p:sp>
+    </p:spTree>
+  </p:cSld>
+  <p:clrMapOvr>
+    <a:masterClrMapping/>
+  </p:clrMapOvr>
+</p:sld>
+</file>
+
+<file path=ppt/slides/slide23.xml><?xml version="1.0" encoding="utf-8"?>
 <p:sld xmlns:a="http://schemas.openxmlformats.org/drawingml/2006/main" xmlns:p="http://schemas.openxmlformats.org/presentationml/2006/main" xmlns:r="http://schemas.openxmlformats.org/officeDocument/2006/relationships">
   <p:cSld>
     <p:spTree>

</xml_diff>

<commit_message>
autoexp: borde curvo/por tramos + segundo paso de biseccion; diagramas deformados (33.4 vs 24.5 baseline); mejor de 2 DIP 41.3 en 9 g; presentacion
</commit_message>
<xml_diff>
--- a/presentaciones/presentacion4_autoexp/presentacion4_autoexp.pptx
+++ b/presentaciones/presentacion4_autoexp/presentacion4_autoexp.pptx
@@ -28,6 +28,8 @@
     <p:sldId id="276" r:id="rId27"/>
     <p:sldId id="277" r:id="rId28"/>
     <p:sldId id="278" r:id="rId29"/>
+    <p:sldId id="279" r:id="rId30"/>
+    <p:sldId id="280" r:id="rId31"/>
   </p:sldIdLst>
   <p:sldSz cx="12188952" cy="6858000" type="screen4x3"/>
   <p:notesSz cx="6858000" cy="9144000"/>
@@ -3228,7 +3230,7 @@
               </a:defRPr>
             </a:pPr>
             <a:r>
-              <a:t>Validación en los 9 g: 41.1 dB con 64 puntos (fusión con guarda); 40.6 sin DIP</a:t>
+              <a:t>Validación en los 9 g: 41.3 dB con 64 puntos (fusión con guarda); 40.6 sin DIP</a:t>
             </a:r>
           </a:p>
         </p:txBody>
@@ -3287,7 +3289,7 @@
               </a:defRPr>
             </a:pPr>
             <a:r>
-              <a:t>Fusión: 41.1 de media, 37.2 en el peor g, 8 de 9 g ≥ 38 dB. Solo TPS: 40.6 / 36.2, 8 de 9. Le ganan a DIP con ~164 puntos en los g duros; DIP con 164 sigue arriba en los suaves.</a:t>
+              <a:t>Fusión: 41.3 de media, 37.7 en el peor g, 8 de 9 g ≥ 38 dB. Solo TPS: 40.6 / 36.2, 8 de 9. Le ganan a DIP con ~164 puntos en los g duros; DIP con 164 sigue arriba en los suaves.</a:t>
             </a:r>
           </a:p>
         </p:txBody>
@@ -4537,7 +4539,7 @@
                         <a:defRPr sz="1200" b="0"/>
                       </a:pPr>
                       <a:r>
-                        <a:t>41.1</a:t>
+                        <a:t>41.3</a:t>
                       </a:r>
                     </a:p>
                   </a:txBody>
@@ -4552,7 +4554,7 @@
                         <a:defRPr sz="1200" b="0"/>
                       </a:pPr>
                       <a:r>
-                        <a:t>37.2</a:t>
+                        <a:t>37.7</a:t>
                       </a:r>
                     </a:p>
                   </a:txBody>
@@ -4778,6 +4780,299 @@
           <a:lstStyle/>
           <a:p>
             <a:pPr>
+              <a:defRPr sz="2700" b="1">
+                <a:solidFill>
+                  <a:srgbClr val="1F3B73"/>
+                </a:solidFill>
+              </a:defRPr>
+            </a:pPr>
+            <a:r>
+              <a:t>En KMC no sabemos la forma exacta: el método chequea sus supuestos</a:t>
+            </a:r>
+          </a:p>
+        </p:txBody>
+      </p:sp>
+      <p:sp>
+        <p:nvSpPr>
+          <p:cNvPr id="3" name="TextBox 2"/>
+          <p:cNvSpPr txBox="1"/>
+          <p:nvPr/>
+        </p:nvSpPr>
+        <p:spPr>
+          <a:xfrm>
+            <a:off x="548640" y="1280160"/>
+            <a:ext cx="10972800" cy="5120640"/>
+          </a:xfrm>
+          <a:prstGeom prst="rect">
+            <a:avLst/>
+          </a:prstGeom>
+          <a:noFill/>
+        </p:spPr>
+        <p:txBody>
+          <a:bodyPr wrap="square">
+            <a:spAutoFit/>
+          </a:bodyPr>
+          <a:lstStyle/>
+          <a:p>
+            <a:pPr>
+              <a:spcAft>
+                <a:spcPts val="500"/>
+              </a:spcAft>
+              <a:defRPr sz="1500">
+                <a:solidFill>
+                  <a:srgbClr val="404040"/>
+                </a:solidFill>
+              </a:defRPr>
+            </a:pPr>
+            <a:r>
+              <a:t>Todo se afinó con los 9 diagramas del modelo del continuo. En KMC la estructura es parecida (mesetas, rampas, acantilado) pero con otra distribución.</a:t>
+            </a:r>
+          </a:p>
+          <a:p>
+            <a:pPr>
+              <a:spcAft>
+                <a:spcPts val="500"/>
+              </a:spcAft>
+              <a:defRPr sz="1500">
+                <a:solidFill>
+                  <a:srgbClr val="404040"/>
+                </a:solidFill>
+              </a:defRPr>
+            </a:pPr>
+            <a:r>
+              <a:t>Cada supuesto se verifica con los propios puntos y, si no se cumple, se apaga:</a:t>
+            </a:r>
+          </a:p>
+          <a:p>
+            <a:pPr lvl="1">
+              <a:spcAft>
+                <a:spcPts val="500"/>
+              </a:spcAft>
+              <a:defRPr sz="1200">
+                <a:solidFill>
+                  <a:srgbClr val="404040"/>
+                </a:solidFill>
+              </a:defRPr>
+            </a:pPr>
+            <a:r>
+              <a:t>Monotonía: solo si ningún par de puntos la viola (más allá del ruido). Si ya la grilla la viola, no se hace bisección y todo el presupuesto va al relleno genérico.</a:t>
+            </a:r>
+          </a:p>
+          <a:p>
+            <a:pPr lvl="1">
+              <a:spcAft>
+                <a:spcPts val="500"/>
+              </a:spcAft>
+              <a:defRPr sz="1200">
+                <a:solidFill>
+                  <a:srgbClr val="404040"/>
+                </a:solidFill>
+              </a:defRPr>
+            </a:pPr>
+            <a:r>
+              <a:t>Acantilado: solo si casi todos los puntos debajo del borde valen 0. Borde recto, curvo (parábola / cúbica por RANSAC) o por tramos, elegido con los propios cruces.</a:t>
+            </a:r>
+          </a:p>
+          <a:p>
+            <a:pPr lvl="1">
+              <a:spcAft>
+                <a:spcPts val="500"/>
+              </a:spcAft>
+              <a:defRPr sz="1200">
+                <a:solidFill>
+                  <a:srgbClr val="404040"/>
+                </a:solidFill>
+              </a:defRPr>
+            </a:pPr>
+            <a:r>
+              <a:t>Compresión vertical: la elige la validación cruzada entre 4 valores.</a:t>
+            </a:r>
+          </a:p>
+          <a:p>
+            <a:pPr>
+              <a:spcAft>
+                <a:spcPts val="500"/>
+              </a:spcAft>
+              <a:defRPr sz="1500">
+                <a:solidFill>
+                  <a:srgbClr val="404040"/>
+                </a:solidFill>
+              </a:defRPr>
+            </a:pPr>
+            <a:r>
+              <a:t>En los 9 diagramas originales no cambia nada (mismos puntos, mismo resultado).</a:t>
+            </a:r>
+          </a:p>
+          <a:p>
+            <a:pPr>
+              <a:spcAft>
+                <a:spcPts val="500"/>
+              </a:spcAft>
+              <a:defRPr sz="1500">
+                <a:solidFill>
+                  <a:srgbClr val="404040"/>
+                </a:solidFill>
+              </a:defRPr>
+            </a:pPr>
+            <a:r>
+              <a:t>Diagramas de fase nuevos (g = +2, +4): 36.6 y 38.4 dB vs 32.4 y 34.5 del baseline. En formas totalmente distintas (Gauss, Rosenbrock, Himmelblau) ya no se rompe: cae a lo genérico.</a:t>
+            </a:r>
+          </a:p>
+        </p:txBody>
+      </p:sp>
+    </p:spTree>
+  </p:cSld>
+  <p:clrMapOvr>
+    <a:masterClrMapping/>
+  </p:clrMapOvr>
+</p:sld>
+</file>
+
+<file path=ppt/slides/slide18.xml><?xml version="1.0" encoding="utf-8"?>
+<p:sld xmlns:a="http://schemas.openxmlformats.org/drawingml/2006/main" xmlns:p="http://schemas.openxmlformats.org/presentationml/2006/main" xmlns:r="http://schemas.openxmlformats.org/officeDocument/2006/relationships">
+  <p:cSld>
+    <p:spTree>
+      <p:nvGrpSpPr>
+        <p:cNvPr id="1" name=""/>
+        <p:cNvGrpSpPr/>
+        <p:nvPr/>
+      </p:nvGrpSpPr>
+      <p:grpSpPr/>
+      <p:sp>
+        <p:nvSpPr>
+          <p:cNvPr id="2" name="TextBox 1"/>
+          <p:cNvSpPr txBox="1"/>
+          <p:nvPr/>
+        </p:nvSpPr>
+        <p:spPr>
+          <a:xfrm>
+            <a:off x="548640" y="320040"/>
+            <a:ext cx="11064240" cy="822960"/>
+          </a:xfrm>
+          <a:prstGeom prst="rect">
+            <a:avLst/>
+          </a:prstGeom>
+          <a:noFill/>
+        </p:spPr>
+        <p:txBody>
+          <a:bodyPr wrap="square">
+            <a:spAutoFit/>
+          </a:bodyPr>
+          <a:lstStyle/>
+          <a:p>
+            <a:pPr>
+              <a:defRPr sz="2600" b="1">
+                <a:solidFill>
+                  <a:srgbClr val="1F3B73"/>
+                </a:solidFill>
+              </a:defRPr>
+            </a:pPr>
+            <a:r>
+              <a:t>Misma estructura, otra geometría</a:t>
+            </a:r>
+          </a:p>
+        </p:txBody>
+      </p:sp>
+      <p:pic>
+        <p:nvPicPr>
+          <p:cNvPr id="3" name="Picture 2" descr="deformados.png"/>
+          <p:cNvPicPr>
+            <a:picLocks noChangeAspect="1"/>
+          </p:cNvPicPr>
+          <p:nvPr/>
+        </p:nvPicPr>
+        <p:blipFill>
+          <a:blip r:embed="rId2"/>
+          <a:stretch>
+            <a:fillRect/>
+          </a:stretch>
+        </p:blipFill>
+        <p:spPr>
+          <a:xfrm>
+            <a:off x="1274281" y="1280160"/>
+            <a:ext cx="9640388" cy="4846320"/>
+          </a:xfrm>
+          <a:prstGeom prst="rect">
+            <a:avLst/>
+          </a:prstGeom>
+        </p:spPr>
+      </p:pic>
+      <p:sp>
+        <p:nvSpPr>
+          <p:cNvPr id="4" name="TextBox 3"/>
+          <p:cNvSpPr txBox="1"/>
+          <p:nvPr/>
+        </p:nvSpPr>
+        <p:spPr>
+          <a:xfrm>
+            <a:off x="548640" y="6172200"/>
+            <a:ext cx="11064240" cy="640080"/>
+          </a:xfrm>
+          <a:prstGeom prst="rect">
+            <a:avLst/>
+          </a:prstGeom>
+          <a:noFill/>
+        </p:spPr>
+        <p:txBody>
+          <a:bodyPr wrap="square">
+            <a:spAutoFit/>
+          </a:bodyPr>
+          <a:lstStyle/>
+          <a:p>
+            <a:pPr algn="ctr">
+              <a:defRPr sz="1200" i="1">
+                <a:solidFill>
+                  <a:srgbClr val="404040"/>
+                </a:solidFill>
+              </a:defRPr>
+            </a:pPr>
+            <a:r>
+              <a:t>Los 3 g (-4, -2, -0.5) deformados: acantilado corrido, con otra inclinación, arqueado o en S. El método le gana al baseline por ~9 dB; lo más difícil es el frente en S.</a:t>
+            </a:r>
+          </a:p>
+        </p:txBody>
+      </p:sp>
+    </p:spTree>
+  </p:cSld>
+  <p:clrMapOvr>
+    <a:masterClrMapping/>
+  </p:clrMapOvr>
+</p:sld>
+</file>
+
+<file path=ppt/slides/slide19.xml><?xml version="1.0" encoding="utf-8"?>
+<p:sld xmlns:a="http://schemas.openxmlformats.org/drawingml/2006/main" xmlns:p="http://schemas.openxmlformats.org/presentationml/2006/main" xmlns:r="http://schemas.openxmlformats.org/officeDocument/2006/relationships">
+  <p:cSld>
+    <p:spTree>
+      <p:nvGrpSpPr>
+        <p:cNvPr id="1" name=""/>
+        <p:cNvGrpSpPr/>
+        <p:nvPr/>
+      </p:nvGrpSpPr>
+      <p:grpSpPr/>
+      <p:sp>
+        <p:nvSpPr>
+          <p:cNvPr id="2" name="TextBox 1"/>
+          <p:cNvSpPr txBox="1"/>
+          <p:nvPr/>
+        </p:nvSpPr>
+        <p:spPr>
+          <a:xfrm>
+            <a:off x="548640" y="320040"/>
+            <a:ext cx="11064240" cy="822960"/>
+          </a:xfrm>
+          <a:prstGeom prst="rect">
+            <a:avLst/>
+          </a:prstGeom>
+          <a:noFill/>
+        </p:spPr>
+        <p:txBody>
+          <a:bodyPr wrap="square">
+            <a:spAutoFit/>
+          </a:bodyPr>
+          <a:lstStyle/>
+          <a:p>
+            <a:pPr>
               <a:defRPr sz="2600" b="1">
                 <a:solidFill>
                   <a:srgbClr val="1F3B73"/>
@@ -4857,7 +5152,119 @@
 </p:sld>
 </file>
 
-<file path=ppt/slides/slide18.xml><?xml version="1.0" encoding="utf-8"?>
+<file path=ppt/slides/slide2.xml><?xml version="1.0" encoding="utf-8"?>
+<p:sld xmlns:a="http://schemas.openxmlformats.org/drawingml/2006/main" xmlns:p="http://schemas.openxmlformats.org/presentationml/2006/main" xmlns:r="http://schemas.openxmlformats.org/officeDocument/2006/relationships">
+  <p:cSld>
+    <p:spTree>
+      <p:nvGrpSpPr>
+        <p:cNvPr id="1" name=""/>
+        <p:cNvGrpSpPr/>
+        <p:nvPr/>
+      </p:nvGrpSpPr>
+      <p:grpSpPr/>
+      <p:sp>
+        <p:nvSpPr>
+          <p:cNvPr id="2" name="TextBox 1"/>
+          <p:cNvSpPr txBox="1"/>
+          <p:nvPr/>
+        </p:nvSpPr>
+        <p:spPr>
+          <a:xfrm>
+            <a:off x="548640" y="320040"/>
+            <a:ext cx="11064240" cy="822960"/>
+          </a:xfrm>
+          <a:prstGeom prst="rect">
+            <a:avLst/>
+          </a:prstGeom>
+          <a:noFill/>
+        </p:spPr>
+        <p:txBody>
+          <a:bodyPr wrap="square">
+            <a:spAutoFit/>
+          </a:bodyPr>
+          <a:lstStyle/>
+          <a:p>
+            <a:pPr>
+              <a:defRPr sz="2600" b="1">
+                <a:solidFill>
+                  <a:srgbClr val="1F3B73"/>
+                </a:solidFill>
+              </a:defRPr>
+            </a:pPr>
+            <a:r>
+              <a:t>Resumen: dónde estamos</a:t>
+            </a:r>
+          </a:p>
+        </p:txBody>
+      </p:sp>
+      <p:pic>
+        <p:nvPicPr>
+          <p:cNvPr id="3" name="Picture 2" descr="resumen.png"/>
+          <p:cNvPicPr>
+            <a:picLocks noChangeAspect="1"/>
+          </p:cNvPicPr>
+          <p:nvPr/>
+        </p:nvPicPr>
+        <p:blipFill>
+          <a:blip r:embed="rId2"/>
+          <a:stretch>
+            <a:fillRect/>
+          </a:stretch>
+        </p:blipFill>
+        <p:spPr>
+          <a:xfrm>
+            <a:off x="1688259" y="1280160"/>
+            <a:ext cx="8812432" cy="4846320"/>
+          </a:xfrm>
+          <a:prstGeom prst="rect">
+            <a:avLst/>
+          </a:prstGeom>
+        </p:spPr>
+      </p:pic>
+      <p:sp>
+        <p:nvSpPr>
+          <p:cNvPr id="4" name="TextBox 3"/>
+          <p:cNvSpPr txBox="1"/>
+          <p:nvPr/>
+        </p:nvSpPr>
+        <p:spPr>
+          <a:xfrm>
+            <a:off x="548640" y="6172200"/>
+            <a:ext cx="11064240" cy="640080"/>
+          </a:xfrm>
+          <a:prstGeom prst="rect">
+            <a:avLst/>
+          </a:prstGeom>
+          <a:noFill/>
+        </p:spPr>
+        <p:txBody>
+          <a:bodyPr wrap="square">
+            <a:spAutoFit/>
+          </a:bodyPr>
+          <a:lstStyle/>
+          <a:p>
+            <a:pPr algn="ctr">
+              <a:defRPr sz="1200" i="1">
+                <a:solidFill>
+                  <a:srgbClr val="404040"/>
+                </a:solidFill>
+              </a:defRPr>
+            </a:pPr>
+            <a:r>
+              <a:t>Arriba: cada paso, con el mismo presupuesto de 64 puntos. Abajo: original vs. reconstrucción de 64 puntos, sin DIP, en 4 de los 9 g.</a:t>
+            </a:r>
+          </a:p>
+        </p:txBody>
+      </p:sp>
+    </p:spTree>
+  </p:cSld>
+  <p:clrMapOvr>
+    <a:masterClrMapping/>
+  </p:clrMapOvr>
+</p:sld>
+</file>
+
+<file path=ppt/slides/slide20.xml><?xml version="1.0" encoding="utf-8"?>
 <p:sld xmlns:a="http://schemas.openxmlformats.org/drawingml/2006/main" xmlns:p="http://schemas.openxmlformats.org/presentationml/2006/main" xmlns:r="http://schemas.openxmlformats.org/officeDocument/2006/relationships">
   <p:cSld>
     <p:spTree>
@@ -5282,7 +5689,7 @@
 </p:sld>
 </file>
 
-<file path=ppt/slides/slide19.xml><?xml version="1.0" encoding="utf-8"?>
+<file path=ppt/slides/slide21.xml><?xml version="1.0" encoding="utf-8"?>
 <p:sld xmlns:a="http://schemas.openxmlformats.org/drawingml/2006/main" xmlns:p="http://schemas.openxmlformats.org/presentationml/2006/main" xmlns:r="http://schemas.openxmlformats.org/officeDocument/2006/relationships">
   <p:cSld>
     <p:spTree>
@@ -5382,450 +5789,6 @@
             </a:pPr>
             <a:r>
               <a:t>Con 1 % DIP recupera la forma pero la cresta angosta queda ondulada; con 5 % queda fiel. Con 64 puntos la TPS da una superficie reconocible pero con bultos.</a:t>
-            </a:r>
-          </a:p>
-        </p:txBody>
-      </p:sp>
-    </p:spTree>
-  </p:cSld>
-  <p:clrMapOvr>
-    <a:masterClrMapping/>
-  </p:clrMapOvr>
-</p:sld>
-</file>
-
-<file path=ppt/slides/slide2.xml><?xml version="1.0" encoding="utf-8"?>
-<p:sld xmlns:a="http://schemas.openxmlformats.org/drawingml/2006/main" xmlns:p="http://schemas.openxmlformats.org/presentationml/2006/main" xmlns:r="http://schemas.openxmlformats.org/officeDocument/2006/relationships">
-  <p:cSld>
-    <p:spTree>
-      <p:nvGrpSpPr>
-        <p:cNvPr id="1" name=""/>
-        <p:cNvGrpSpPr/>
-        <p:nvPr/>
-      </p:nvGrpSpPr>
-      <p:grpSpPr/>
-      <p:sp>
-        <p:nvSpPr>
-          <p:cNvPr id="2" name="TextBox 1"/>
-          <p:cNvSpPr txBox="1"/>
-          <p:nvPr/>
-        </p:nvSpPr>
-        <p:spPr>
-          <a:xfrm>
-            <a:off x="548640" y="320040"/>
-            <a:ext cx="11064240" cy="822960"/>
-          </a:xfrm>
-          <a:prstGeom prst="rect">
-            <a:avLst/>
-          </a:prstGeom>
-          <a:noFill/>
-        </p:spPr>
-        <p:txBody>
-          <a:bodyPr wrap="square">
-            <a:spAutoFit/>
-          </a:bodyPr>
-          <a:lstStyle/>
-          <a:p>
-            <a:pPr>
-              <a:defRPr sz="2600" b="1">
-                <a:solidFill>
-                  <a:srgbClr val="1F3B73"/>
-                </a:solidFill>
-              </a:defRPr>
-            </a:pPr>
-            <a:r>
-              <a:t>Resumen: dónde estamos</a:t>
-            </a:r>
-          </a:p>
-        </p:txBody>
-      </p:sp>
-      <p:pic>
-        <p:nvPicPr>
-          <p:cNvPr id="3" name="Picture 2" descr="resumen.png"/>
-          <p:cNvPicPr>
-            <a:picLocks noChangeAspect="1"/>
-          </p:cNvPicPr>
-          <p:nvPr/>
-        </p:nvPicPr>
-        <p:blipFill>
-          <a:blip r:embed="rId2"/>
-          <a:stretch>
-            <a:fillRect/>
-          </a:stretch>
-        </p:blipFill>
-        <p:spPr>
-          <a:xfrm>
-            <a:off x="1688259" y="1280160"/>
-            <a:ext cx="8812432" cy="4846320"/>
-          </a:xfrm>
-          <a:prstGeom prst="rect">
-            <a:avLst/>
-          </a:prstGeom>
-        </p:spPr>
-      </p:pic>
-      <p:sp>
-        <p:nvSpPr>
-          <p:cNvPr id="4" name="TextBox 3"/>
-          <p:cNvSpPr txBox="1"/>
-          <p:nvPr/>
-        </p:nvSpPr>
-        <p:spPr>
-          <a:xfrm>
-            <a:off x="548640" y="6172200"/>
-            <a:ext cx="11064240" cy="640080"/>
-          </a:xfrm>
-          <a:prstGeom prst="rect">
-            <a:avLst/>
-          </a:prstGeom>
-          <a:noFill/>
-        </p:spPr>
-        <p:txBody>
-          <a:bodyPr wrap="square">
-            <a:spAutoFit/>
-          </a:bodyPr>
-          <a:lstStyle/>
-          <a:p>
-            <a:pPr algn="ctr">
-              <a:defRPr sz="1200" i="1">
-                <a:solidFill>
-                  <a:srgbClr val="404040"/>
-                </a:solidFill>
-              </a:defRPr>
-            </a:pPr>
-            <a:r>
-              <a:t>Arriba: cada paso, con el mismo presupuesto de 64 puntos. Abajo: original vs. reconstrucción de 64 puntos, sin DIP, en 4 de los 9 g.</a:t>
-            </a:r>
-          </a:p>
-        </p:txBody>
-      </p:sp>
-    </p:spTree>
-  </p:cSld>
-  <p:clrMapOvr>
-    <a:masterClrMapping/>
-  </p:clrMapOvr>
-</p:sld>
-</file>
-
-<file path=ppt/slides/slide20.xml><?xml version="1.0" encoding="utf-8"?>
-<p:sld xmlns:a="http://schemas.openxmlformats.org/drawingml/2006/main" xmlns:p="http://schemas.openxmlformats.org/presentationml/2006/main" xmlns:r="http://schemas.openxmlformats.org/officeDocument/2006/relationships">
-  <p:cSld>
-    <p:spTree>
-      <p:nvGrpSpPr>
-        <p:cNvPr id="1" name=""/>
-        <p:cNvGrpSpPr/>
-        <p:nvPr/>
-      </p:nvGrpSpPr>
-      <p:grpSpPr/>
-      <p:sp>
-        <p:nvSpPr>
-          <p:cNvPr id="2" name="TextBox 1"/>
-          <p:cNvSpPr txBox="1"/>
-          <p:nvPr/>
-        </p:nvSpPr>
-        <p:spPr>
-          <a:xfrm>
-            <a:off x="548640" y="320040"/>
-            <a:ext cx="11064240" cy="822960"/>
-          </a:xfrm>
-          <a:prstGeom prst="rect">
-            <a:avLst/>
-          </a:prstGeom>
-          <a:noFill/>
-        </p:spPr>
-        <p:txBody>
-          <a:bodyPr wrap="square">
-            <a:spAutoFit/>
-          </a:bodyPr>
-          <a:lstStyle/>
-          <a:p>
-            <a:pPr>
-              <a:defRPr sz="2700" b="1">
-                <a:solidFill>
-                  <a:srgbClr val="1F3B73"/>
-                </a:solidFill>
-              </a:defRPr>
-            </a:pPr>
-            <a:r>
-              <a:t>Pedidos de la reunión: estado</a:t>
-            </a:r>
-          </a:p>
-        </p:txBody>
-      </p:sp>
-      <p:sp>
-        <p:nvSpPr>
-          <p:cNvPr id="3" name="TextBox 2"/>
-          <p:cNvSpPr txBox="1"/>
-          <p:nvPr/>
-        </p:nvSpPr>
-        <p:spPr>
-          <a:xfrm>
-            <a:off x="548640" y="1280160"/>
-            <a:ext cx="10972800" cy="5120640"/>
-          </a:xfrm>
-          <a:prstGeom prst="rect">
-            <a:avLst/>
-          </a:prstGeom>
-          <a:noFill/>
-        </p:spPr>
-        <p:txBody>
-          <a:bodyPr wrap="square">
-            <a:spAutoFit/>
-          </a:bodyPr>
-          <a:lstStyle/>
-          <a:p>
-            <a:pPr>
-              <a:spcAft>
-                <a:spcPts val="500"/>
-              </a:spcAft>
-              <a:defRPr sz="1600">
-                <a:solidFill>
-                  <a:srgbClr val="404040"/>
-                </a:solidFill>
-              </a:defRPr>
-            </a:pPr>
-            <a:r>
-              <a:t>1–3) Optuna + grid/uniform con hiperparámetros + la grilla como hiperparámetro: 181 trials en Mendieta. Mejor DIP con 64 puntos en grilla: 29.9 dB (config 'vase' del paper afinada); uniform siempre peor. En el muestreo nuevo, la grilla (6 columnas × 5 filas) es el parámetro más sensible.</a:t>
-            </a:r>
-          </a:p>
-          <a:p>
-            <a:pPr>
-              <a:spcAft>
-                <a:spcPts val="500"/>
-              </a:spcAft>
-              <a:defRPr sz="1600">
-                <a:solidFill>
-                  <a:srgbClr val="404040"/>
-                </a:solidFill>
-              </a:defRPr>
-            </a:pPr>
-            <a:r>
-              <a:t>4) Ventana: la bisección ya concentra ~25 de los 64 puntos en una franja angosta alrededor del frente (ventana adaptativa).</a:t>
-            </a:r>
-          </a:p>
-          <a:p>
-            <a:pPr>
-              <a:spcAft>
-                <a:spcPts val="500"/>
-              </a:spcAft>
-              <a:defRPr sz="1600">
-                <a:solidFill>
-                  <a:srgbClr val="404040"/>
-                </a:solidFill>
-              </a:defRPr>
-            </a:pPr>
-            <a:r>
-              <a:t>5) Rosenbrock en 3D: hecho (diapositiva anterior).</a:t>
-            </a:r>
-          </a:p>
-          <a:p>
-            <a:pPr>
-              <a:spcAft>
-                <a:spcPts val="500"/>
-              </a:spcAft>
-              <a:defRPr sz="1600">
-                <a:solidFill>
-                  <a:srgbClr val="404040"/>
-                </a:solidFill>
-              </a:defRPr>
-            </a:pPr>
-            <a:r>
-              <a:t>6) Interpolación de scipy vs. DIP: con los mismos puntos empatan con la receta de la tesis (24.4 vs. 25.0); DIP con la config del paper gana (28.5).</a:t>
-            </a:r>
-          </a:p>
-        </p:txBody>
-      </p:sp>
-    </p:spTree>
-  </p:cSld>
-  <p:clrMapOvr>
-    <a:masterClrMapping/>
-  </p:clrMapOvr>
-</p:sld>
-</file>
-
-<file path=ppt/slides/slide21.xml><?xml version="1.0" encoding="utf-8"?>
-<p:sld xmlns:a="http://schemas.openxmlformats.org/drawingml/2006/main" xmlns:p="http://schemas.openxmlformats.org/presentationml/2006/main" xmlns:r="http://schemas.openxmlformats.org/officeDocument/2006/relationships">
-  <p:cSld>
-    <p:spTree>
-      <p:nvGrpSpPr>
-        <p:cNvPr id="1" name=""/>
-        <p:cNvGrpSpPr/>
-        <p:nvPr/>
-      </p:nvGrpSpPr>
-      <p:grpSpPr/>
-      <p:sp>
-        <p:nvSpPr>
-          <p:cNvPr id="2" name="TextBox 1"/>
-          <p:cNvSpPr txBox="1"/>
-          <p:nvPr/>
-        </p:nvSpPr>
-        <p:spPr>
-          <a:xfrm>
-            <a:off x="548640" y="320040"/>
-            <a:ext cx="11064240" cy="822960"/>
-          </a:xfrm>
-          <a:prstGeom prst="rect">
-            <a:avLst/>
-          </a:prstGeom>
-          <a:noFill/>
-        </p:spPr>
-        <p:txBody>
-          <a:bodyPr wrap="square">
-            <a:spAutoFit/>
-          </a:bodyPr>
-          <a:lstStyle/>
-          <a:p>
-            <a:pPr>
-              <a:defRPr sz="2700" b="1">
-                <a:solidFill>
-                  <a:srgbClr val="1F3B73"/>
-                </a:solidFill>
-              </a:defRPr>
-            </a:pPr>
-            <a:r>
-              <a:t>Lo que se probó y NO funcionó (para no repetirlo)</a:t>
-            </a:r>
-          </a:p>
-        </p:txBody>
-      </p:sp>
-      <p:sp>
-        <p:nvSpPr>
-          <p:cNvPr id="3" name="TextBox 2"/>
-          <p:cNvSpPr txBox="1"/>
-          <p:nvPr/>
-        </p:nvSpPr>
-        <p:spPr>
-          <a:xfrm>
-            <a:off x="548640" y="1280160"/>
-            <a:ext cx="10972800" cy="5120640"/>
-          </a:xfrm>
-          <a:prstGeom prst="rect">
-            <a:avLst/>
-          </a:prstGeom>
-          <a:noFill/>
-        </p:spPr>
-        <p:txBody>
-          <a:bodyPr wrap="square">
-            <a:spAutoFit/>
-          </a:bodyPr>
-          <a:lstStyle/>
-          <a:p>
-            <a:pPr>
-              <a:spcAft>
-                <a:spcPts val="500"/>
-              </a:spcAft>
-              <a:defRPr sz="1500">
-                <a:solidFill>
-                  <a:srgbClr val="404040"/>
-                </a:solidFill>
-              </a:defRPr>
-            </a:pPr>
-            <a:r>
-              <a:t>Frente como parábola por puntos medios de pares con salto: inestable, dejaba una costura.</a:t>
-            </a:r>
-          </a:p>
-          <a:p>
-            <a:pPr>
-              <a:spcAft>
-                <a:spcPts val="500"/>
-              </a:spcAft>
-              <a:defRPr sz="1500">
-                <a:solidFill>
-                  <a:srgbClr val="404040"/>
-                </a:solidFill>
-              </a:defRPr>
-            </a:pPr>
-            <a:r>
-              <a:t>Bisección al nivel medio: en los g suaves caía dentro de la rampa, no en el acantilado.</a:t>
-            </a:r>
-          </a:p>
-          <a:p>
-            <a:pPr>
-              <a:spcAft>
-                <a:spcPts val="500"/>
-              </a:spcAft>
-              <a:defRPr sz="1500">
-                <a:solidFill>
-                  <a:srgbClr val="404040"/>
-                </a:solidFill>
-              </a:defRPr>
-            </a:pPr>
-            <a:r>
-              <a:t>Sondas del perfil de la rampa (3-7-14 px sobre el borde): le quitan presupuesto al relleno.</a:t>
-            </a:r>
-          </a:p>
-          <a:p>
-            <a:pPr>
-              <a:spcAft>
-                <a:spcPts val="500"/>
-              </a:spcAft>
-              <a:defRPr sz="1500">
-                <a:solidFill>
-                  <a:srgbClr val="404040"/>
-                </a:solidFill>
-              </a:defRPr>
-            </a:pPr>
-            <a:r>
-              <a:t>Proceso gaussiano en lugar de la TPS: con tan pocos puntos, las escalas aprendidas quedan mal (g=-2: 22 dB vs. 36).</a:t>
-            </a:r>
-          </a:p>
-          <a:p>
-            <a:pPr>
-              <a:spcAft>
-                <a:spcPts val="500"/>
-              </a:spcAft>
-              <a:defRPr sz="1500">
-                <a:solidFill>
-                  <a:srgbClr val="404040"/>
-                </a:solidFill>
-              </a:defRPr>
-            </a:pPr>
-            <a:r>
-              <a:t>Relleno por ancho de las cotas de monotonía: mejor peor g, pero −2.7 dB en g=-4.</a:t>
-            </a:r>
-          </a:p>
-          <a:p>
-            <a:pPr>
-              <a:spcAft>
-                <a:spcPts val="500"/>
-              </a:spcAft>
-              <a:defRPr sz="1500">
-                <a:solidFill>
-                  <a:srgbClr val="404040"/>
-                </a:solidFill>
-              </a:defRPr>
-            </a:pPr>
-            <a:r>
-              <a:t>Grilla de 7-8 columnas: no falla el detector, se acaba el presupuesto en la bisección.</a:t>
-            </a:r>
-          </a:p>
-          <a:p>
-            <a:pPr>
-              <a:spcAft>
-                <a:spcPts val="500"/>
-              </a:spcAft>
-              <a:defRPr sz="1500">
-                <a:solidFill>
-                  <a:srgbClr val="404040"/>
-                </a:solidFill>
-              </a:defRPr>
-            </a:pPr>
-            <a:r>
-              <a:t>DIP 'kate' del paper con 64 puntos (18 dB): pensado para imágenes casi completas.</a:t>
-            </a:r>
-          </a:p>
-          <a:p>
-            <a:pPr>
-              <a:spcAft>
-                <a:spcPts val="500"/>
-              </a:spcAft>
-              <a:defRPr sz="1500">
-                <a:solidFill>
-                  <a:srgbClr val="404040"/>
-                </a:solidFill>
-              </a:defRPr>
-            </a:pPr>
-            <a:r>
-              <a:t>Fusión sin guarda en 9 g: cuando DIP falla en un g (-4 dB), arrastra el promedio.</a:t>
             </a:r>
           </a:p>
         </p:txBody>
@@ -5878,7 +5841,7 @@
               </a:defRPr>
             </a:pPr>
             <a:r>
-              <a:t>Listo para KMC: planificador de tandas (autoexp/kmc_planner.py)</a:t>
+              <a:t>Pedidos de la reunión: estado</a:t>
             </a:r>
           </a:p>
         </p:txBody>
@@ -5909,14 +5872,14 @@
               <a:spcAft>
                 <a:spcPts val="500"/>
               </a:spcAft>
-              <a:defRPr sz="1700">
+              <a:defRPr sz="1600">
                 <a:solidFill>
                   <a:srgbClr val="404040"/>
                 </a:solidFill>
               </a:defRPr>
             </a:pPr>
             <a:r>
-              <a:t>init --budget 64 --sigma σ  →  next  →  (correr KMC)  →  add resultados.csv  →  next ...  →  reconstruct</a:t>
+              <a:t>1–3) Optuna + grid/uniform con hiperparámetros + la grilla como hiperparámetro: 181 trials en Mendieta. Mejor DIP con 64 puntos en grilla: 29.9 dB (config 'vase' del paper afinada); uniform siempre peor. En el muestreo nuevo, la grilla (6 columnas × 5 filas) es el parámetro más sensible.</a:t>
             </a:r>
           </a:p>
           <a:p>
@@ -5924,14 +5887,14 @@
               <a:spcAft>
                 <a:spcPts val="500"/>
               </a:spcAft>
-              <a:defRPr sz="1700">
+              <a:defRPr sz="1600">
                 <a:solidFill>
                   <a:srgbClr val="404040"/>
                 </a:solidFill>
               </a:defRPr>
             </a:pPr>
             <a:r>
-              <a:t>Cada 'next' devuelve la tanda siguiente en (log Ξ, log ℓ), para correr en paralelo en el cluster.</a:t>
+              <a:t>4) Ventana: la bisección ya concentra ~25 de los 64 puntos en una franja angosta alrededor del frente (ventana adaptativa).</a:t>
             </a:r>
           </a:p>
           <a:p>
@@ -5939,14 +5902,14 @@
               <a:spcAft>
                 <a:spcPts val="500"/>
               </a:spcAft>
-              <a:defRPr sz="1700">
+              <a:defRPr sz="1600">
                 <a:solidFill>
                   <a:srgbClr val="404040"/>
                 </a:solidFill>
               </a:defRPr>
             </a:pPr>
             <a:r>
-              <a:t>Con 64 puntos: 9 tandas = 30 (grilla) + 4-5 rondas de ~5 (bisección) + 3-4 rondas de 4 (relleno).</a:t>
+              <a:t>5) Rosenbrock en 3D: hecho (diapositiva anterior).</a:t>
             </a:r>
           </a:p>
           <a:p>
@@ -5954,29 +5917,14 @@
               <a:spcAft>
                 <a:spcPts val="500"/>
               </a:spcAft>
-              <a:defRPr sz="1700">
+              <a:defRPr sz="1600">
                 <a:solidFill>
                   <a:srgbClr val="404040"/>
                 </a:solidFill>
               </a:defRPr>
             </a:pPr>
             <a:r>
-              <a:t>Probado de punta a punta contra el modelo del continuo (simulate): g=-4 46.2 dB, g=-2 38.6, g=-0.5 39.4; g=-2 con ruido σ=0.01: 37.6.</a:t>
-            </a:r>
-          </a:p>
-          <a:p>
-            <a:pPr>
-              <a:spcAft>
-                <a:spcPts val="500"/>
-              </a:spcAft>
-              <a:defRPr sz="1700">
-                <a:solidFill>
-                  <a:srgbClr val="404040"/>
-                </a:solidFill>
-              </a:defRPr>
-            </a:pPr>
-            <a:r>
-              <a:t>σ se estima con corridas repetidas de KMC (NRUNS) y fija todos los umbrales solo.</a:t>
+              <a:t>6) Interpolación de scipy vs. DIP: con los mismos puntos empatan con la receta de la tesis (24.4 vs. 25.0); DIP con la config del paper gana (28.5).</a:t>
             </a:r>
           </a:p>
         </p:txBody>
@@ -5990,6 +5938,353 @@
 </file>
 
 <file path=ppt/slides/slide23.xml><?xml version="1.0" encoding="utf-8"?>
+<p:sld xmlns:a="http://schemas.openxmlformats.org/drawingml/2006/main" xmlns:p="http://schemas.openxmlformats.org/presentationml/2006/main" xmlns:r="http://schemas.openxmlformats.org/officeDocument/2006/relationships">
+  <p:cSld>
+    <p:spTree>
+      <p:nvGrpSpPr>
+        <p:cNvPr id="1" name=""/>
+        <p:cNvGrpSpPr/>
+        <p:nvPr/>
+      </p:nvGrpSpPr>
+      <p:grpSpPr/>
+      <p:sp>
+        <p:nvSpPr>
+          <p:cNvPr id="2" name="TextBox 1"/>
+          <p:cNvSpPr txBox="1"/>
+          <p:nvPr/>
+        </p:nvSpPr>
+        <p:spPr>
+          <a:xfrm>
+            <a:off x="548640" y="320040"/>
+            <a:ext cx="11064240" cy="822960"/>
+          </a:xfrm>
+          <a:prstGeom prst="rect">
+            <a:avLst/>
+          </a:prstGeom>
+          <a:noFill/>
+        </p:spPr>
+        <p:txBody>
+          <a:bodyPr wrap="square">
+            <a:spAutoFit/>
+          </a:bodyPr>
+          <a:lstStyle/>
+          <a:p>
+            <a:pPr>
+              <a:defRPr sz="2700" b="1">
+                <a:solidFill>
+                  <a:srgbClr val="1F3B73"/>
+                </a:solidFill>
+              </a:defRPr>
+            </a:pPr>
+            <a:r>
+              <a:t>Lo que se probó y NO funcionó (para no repetirlo)</a:t>
+            </a:r>
+          </a:p>
+        </p:txBody>
+      </p:sp>
+      <p:sp>
+        <p:nvSpPr>
+          <p:cNvPr id="3" name="TextBox 2"/>
+          <p:cNvSpPr txBox="1"/>
+          <p:nvPr/>
+        </p:nvSpPr>
+        <p:spPr>
+          <a:xfrm>
+            <a:off x="548640" y="1280160"/>
+            <a:ext cx="10972800" cy="5120640"/>
+          </a:xfrm>
+          <a:prstGeom prst="rect">
+            <a:avLst/>
+          </a:prstGeom>
+          <a:noFill/>
+        </p:spPr>
+        <p:txBody>
+          <a:bodyPr wrap="square">
+            <a:spAutoFit/>
+          </a:bodyPr>
+          <a:lstStyle/>
+          <a:p>
+            <a:pPr>
+              <a:spcAft>
+                <a:spcPts val="500"/>
+              </a:spcAft>
+              <a:defRPr sz="1500">
+                <a:solidFill>
+                  <a:srgbClr val="404040"/>
+                </a:solidFill>
+              </a:defRPr>
+            </a:pPr>
+            <a:r>
+              <a:t>Frente como parábola por puntos medios de pares con salto: inestable, dejaba una costura.</a:t>
+            </a:r>
+          </a:p>
+          <a:p>
+            <a:pPr>
+              <a:spcAft>
+                <a:spcPts val="500"/>
+              </a:spcAft>
+              <a:defRPr sz="1500">
+                <a:solidFill>
+                  <a:srgbClr val="404040"/>
+                </a:solidFill>
+              </a:defRPr>
+            </a:pPr>
+            <a:r>
+              <a:t>Bisección al nivel medio: en los g suaves caía dentro de la rampa, no en el acantilado.</a:t>
+            </a:r>
+          </a:p>
+          <a:p>
+            <a:pPr>
+              <a:spcAft>
+                <a:spcPts val="500"/>
+              </a:spcAft>
+              <a:defRPr sz="1500">
+                <a:solidFill>
+                  <a:srgbClr val="404040"/>
+                </a:solidFill>
+              </a:defRPr>
+            </a:pPr>
+            <a:r>
+              <a:t>Sondas del perfil de la rampa (3-7-14 px sobre el borde): le quitan presupuesto al relleno.</a:t>
+            </a:r>
+          </a:p>
+          <a:p>
+            <a:pPr>
+              <a:spcAft>
+                <a:spcPts val="500"/>
+              </a:spcAft>
+              <a:defRPr sz="1500">
+                <a:solidFill>
+                  <a:srgbClr val="404040"/>
+                </a:solidFill>
+              </a:defRPr>
+            </a:pPr>
+            <a:r>
+              <a:t>Proceso gaussiano en lugar de la TPS: con tan pocos puntos, las escalas aprendidas quedan mal (g=-2: 22 dB vs. 36).</a:t>
+            </a:r>
+          </a:p>
+          <a:p>
+            <a:pPr>
+              <a:spcAft>
+                <a:spcPts val="500"/>
+              </a:spcAft>
+              <a:defRPr sz="1500">
+                <a:solidFill>
+                  <a:srgbClr val="404040"/>
+                </a:solidFill>
+              </a:defRPr>
+            </a:pPr>
+            <a:r>
+              <a:t>Relleno por ancho de las cotas de monotonía: mejor peor g, pero −2.7 dB en g=-4.</a:t>
+            </a:r>
+          </a:p>
+          <a:p>
+            <a:pPr>
+              <a:spcAft>
+                <a:spcPts val="500"/>
+              </a:spcAft>
+              <a:defRPr sz="1500">
+                <a:solidFill>
+                  <a:srgbClr val="404040"/>
+                </a:solidFill>
+              </a:defRPr>
+            </a:pPr>
+            <a:r>
+              <a:t>Grilla de 7-8 columnas: no falla el detector, se acaba el presupuesto en la bisección.</a:t>
+            </a:r>
+          </a:p>
+          <a:p>
+            <a:pPr>
+              <a:spcAft>
+                <a:spcPts val="500"/>
+              </a:spcAft>
+              <a:defRPr sz="1500">
+                <a:solidFill>
+                  <a:srgbClr val="404040"/>
+                </a:solidFill>
+              </a:defRPr>
+            </a:pPr>
+            <a:r>
+              <a:t>DIP 'kate' del paper con 64 puntos (18 dB): pensado para imágenes casi completas.</a:t>
+            </a:r>
+          </a:p>
+          <a:p>
+            <a:pPr>
+              <a:spcAft>
+                <a:spcPts val="500"/>
+              </a:spcAft>
+              <a:defRPr sz="1500">
+                <a:solidFill>
+                  <a:srgbClr val="404040"/>
+                </a:solidFill>
+              </a:defRPr>
+            </a:pPr>
+            <a:r>
+              <a:t>Fusión sin guarda en 9 g: cuando DIP falla en un g (-4 dB), arrastra el promedio.</a:t>
+            </a:r>
+          </a:p>
+        </p:txBody>
+      </p:sp>
+    </p:spTree>
+  </p:cSld>
+  <p:clrMapOvr>
+    <a:masterClrMapping/>
+  </p:clrMapOvr>
+</p:sld>
+</file>
+
+<file path=ppt/slides/slide24.xml><?xml version="1.0" encoding="utf-8"?>
+<p:sld xmlns:a="http://schemas.openxmlformats.org/drawingml/2006/main" xmlns:p="http://schemas.openxmlformats.org/presentationml/2006/main" xmlns:r="http://schemas.openxmlformats.org/officeDocument/2006/relationships">
+  <p:cSld>
+    <p:spTree>
+      <p:nvGrpSpPr>
+        <p:cNvPr id="1" name=""/>
+        <p:cNvGrpSpPr/>
+        <p:nvPr/>
+      </p:nvGrpSpPr>
+      <p:grpSpPr/>
+      <p:sp>
+        <p:nvSpPr>
+          <p:cNvPr id="2" name="TextBox 1"/>
+          <p:cNvSpPr txBox="1"/>
+          <p:nvPr/>
+        </p:nvSpPr>
+        <p:spPr>
+          <a:xfrm>
+            <a:off x="548640" y="320040"/>
+            <a:ext cx="11064240" cy="822960"/>
+          </a:xfrm>
+          <a:prstGeom prst="rect">
+            <a:avLst/>
+          </a:prstGeom>
+          <a:noFill/>
+        </p:spPr>
+        <p:txBody>
+          <a:bodyPr wrap="square">
+            <a:spAutoFit/>
+          </a:bodyPr>
+          <a:lstStyle/>
+          <a:p>
+            <a:pPr>
+              <a:defRPr sz="2700" b="1">
+                <a:solidFill>
+                  <a:srgbClr val="1F3B73"/>
+                </a:solidFill>
+              </a:defRPr>
+            </a:pPr>
+            <a:r>
+              <a:t>Listo para KMC: planificador de tandas (autoexp/kmc_planner.py)</a:t>
+            </a:r>
+          </a:p>
+        </p:txBody>
+      </p:sp>
+      <p:sp>
+        <p:nvSpPr>
+          <p:cNvPr id="3" name="TextBox 2"/>
+          <p:cNvSpPr txBox="1"/>
+          <p:nvPr/>
+        </p:nvSpPr>
+        <p:spPr>
+          <a:xfrm>
+            <a:off x="548640" y="1280160"/>
+            <a:ext cx="10972800" cy="5120640"/>
+          </a:xfrm>
+          <a:prstGeom prst="rect">
+            <a:avLst/>
+          </a:prstGeom>
+          <a:noFill/>
+        </p:spPr>
+        <p:txBody>
+          <a:bodyPr wrap="square">
+            <a:spAutoFit/>
+          </a:bodyPr>
+          <a:lstStyle/>
+          <a:p>
+            <a:pPr>
+              <a:spcAft>
+                <a:spcPts val="500"/>
+              </a:spcAft>
+              <a:defRPr sz="1700">
+                <a:solidFill>
+                  <a:srgbClr val="404040"/>
+                </a:solidFill>
+              </a:defRPr>
+            </a:pPr>
+            <a:r>
+              <a:t>init --budget 64 --sigma σ  →  next  →  (correr KMC)  →  add resultados.csv  →  next ...  →  reconstruct</a:t>
+            </a:r>
+          </a:p>
+          <a:p>
+            <a:pPr>
+              <a:spcAft>
+                <a:spcPts val="500"/>
+              </a:spcAft>
+              <a:defRPr sz="1700">
+                <a:solidFill>
+                  <a:srgbClr val="404040"/>
+                </a:solidFill>
+              </a:defRPr>
+            </a:pPr>
+            <a:r>
+              <a:t>Cada 'next' devuelve la tanda siguiente en (log Ξ, log ℓ), para correr en paralelo en el cluster.</a:t>
+            </a:r>
+          </a:p>
+          <a:p>
+            <a:pPr>
+              <a:spcAft>
+                <a:spcPts val="500"/>
+              </a:spcAft>
+              <a:defRPr sz="1700">
+                <a:solidFill>
+                  <a:srgbClr val="404040"/>
+                </a:solidFill>
+              </a:defRPr>
+            </a:pPr>
+            <a:r>
+              <a:t>Con 64 puntos: 9 tandas = 30 (grilla) + 4-5 rondas de ~5 (bisección) + 3-4 rondas de 4 (relleno).</a:t>
+            </a:r>
+          </a:p>
+          <a:p>
+            <a:pPr>
+              <a:spcAft>
+                <a:spcPts val="500"/>
+              </a:spcAft>
+              <a:defRPr sz="1700">
+                <a:solidFill>
+                  <a:srgbClr val="404040"/>
+                </a:solidFill>
+              </a:defRPr>
+            </a:pPr>
+            <a:r>
+              <a:t>Probado de punta a punta contra el modelo del continuo (simulate): g=-4 46.2 dB, g=-2 38.6, g=-0.5 39.4; g=-2 con ruido σ=0.01: 37.6.</a:t>
+            </a:r>
+          </a:p>
+          <a:p>
+            <a:pPr>
+              <a:spcAft>
+                <a:spcPts val="500"/>
+              </a:spcAft>
+              <a:defRPr sz="1700">
+                <a:solidFill>
+                  <a:srgbClr val="404040"/>
+                </a:solidFill>
+              </a:defRPr>
+            </a:pPr>
+            <a:r>
+              <a:t>σ se estima con corridas repetidas de KMC (NRUNS) y fija todos los umbrales solo.</a:t>
+            </a:r>
+          </a:p>
+        </p:txBody>
+      </p:sp>
+    </p:spTree>
+  </p:cSld>
+  <p:clrMapOvr>
+    <a:masterClrMapping/>
+  </p:clrMapOvr>
+</p:sld>
+</file>
+
+<file path=ppt/slides/slide25.xml><?xml version="1.0" encoding="utf-8"?>
 <p:sld xmlns:a="http://schemas.openxmlformats.org/drawingml/2006/main" xmlns:p="http://schemas.openxmlformats.org/presentationml/2006/main" xmlns:r="http://schemas.openxmlformats.org/officeDocument/2006/relationships">
   <p:cSld>
     <p:spTree>

</xml_diff>

<commit_message>
Presentacion 4: etiquetas de la figura de deformados
</commit_message>
<xml_diff>
--- a/presentaciones/presentacion4_autoexp/presentacion4_autoexp.pptx
+++ b/presentaciones/presentacion4_autoexp/presentacion4_autoexp.pptx
@@ -4989,8 +4989,8 @@
         </p:blipFill>
         <p:spPr>
           <a:xfrm>
-            <a:off x="1274281" y="1280160"/>
-            <a:ext cx="9640388" cy="4846320"/>
+            <a:off x="1280769" y="1280160"/>
+            <a:ext cx="9627413" cy="4846320"/>
           </a:xfrm>
           <a:prstGeom prst="rect">
             <a:avLst/>

</xml_diff>

<commit_message>
Presentacion 4: figura de las mejores reconstrucciones en 9 g
</commit_message>
<xml_diff>
--- a/presentaciones/presentacion4_autoexp/presentacion4_autoexp.pptx
+++ b/presentaciones/presentacion4_autoexp/presentacion4_autoexp.pptx
@@ -30,6 +30,7 @@
     <p:sldId id="278" r:id="rId29"/>
     <p:sldId id="279" r:id="rId30"/>
     <p:sldId id="280" r:id="rId31"/>
+    <p:sldId id="281" r:id="rId32"/>
   </p:sldIdLst>
   <p:sldSz cx="12188952" cy="6858000" type="screen4x3"/>
   <p:notesSz cx="6858000" cy="9144000"/>
@@ -3342,14 +3343,14 @@
               </a:defRPr>
             </a:pPr>
             <a:r>
-              <a:t>Comparación visual con el mejor DIP previo</a:t>
+              <a:t>Las mejores reconstrucciones hasta ahora (64 puntos, 9 g)</a:t>
             </a:r>
           </a:p>
         </p:txBody>
       </p:sp>
       <p:pic>
         <p:nvPicPr>
-          <p:cNvPr id="3" name="Picture 2" descr="comparacion_rec.png"/>
+          <p:cNvPr id="3" name="Picture 2" descr="mejores_9g.png"/>
           <p:cNvPicPr>
             <a:picLocks noChangeAspect="1"/>
           </p:cNvPicPr>
@@ -3363,14 +3364,49 @@
         </p:blipFill>
         <p:spPr>
           <a:xfrm>
-            <a:off x="4608576" y="1280160"/>
-            <a:ext cx="2971800" cy="5349240"/>
+            <a:off x="662303" y="1280160"/>
+            <a:ext cx="10864345" cy="4846320"/>
           </a:xfrm>
           <a:prstGeom prst="rect">
             <a:avLst/>
           </a:prstGeom>
         </p:spPr>
       </p:pic>
+      <p:sp>
+        <p:nvSpPr>
+          <p:cNvPr id="4" name="TextBox 3"/>
+          <p:cNvSpPr txBox="1"/>
+          <p:nvPr/>
+        </p:nvSpPr>
+        <p:spPr>
+          <a:xfrm>
+            <a:off x="548640" y="6172200"/>
+            <a:ext cx="11064240" cy="640080"/>
+          </a:xfrm>
+          <a:prstGeom prst="rect">
+            <a:avLst/>
+          </a:prstGeom>
+          <a:noFill/>
+        </p:spPr>
+        <p:txBody>
+          <a:bodyPr wrap="square">
+            <a:spAutoFit/>
+          </a:bodyPr>
+          <a:lstStyle/>
+          <a:p>
+            <a:pPr algn="ctr">
+              <a:defRPr sz="1200" i="1">
+                <a:solidFill>
+                  <a:srgbClr val="404040"/>
+                </a:solidFill>
+              </a:defRPr>
+            </a:pPr>
+            <a:r>
+              <a:t>Arriba: original. Medio: reconstrucción con los 64 puntos consultados (en blanco). Abajo: |error|. El error que queda está en la rampa de los g suaves (-2.5, -2, -1.5).</a:t>
+            </a:r>
+          </a:p>
+        </p:txBody>
+      </p:sp>
     </p:spTree>
   </p:cSld>
   <p:clrMapOvr>
@@ -3419,6 +3455,83 @@
               </a:defRPr>
             </a:pPr>
             <a:r>
+              <a:t>Comparación visual con el mejor DIP previo</a:t>
+            </a:r>
+          </a:p>
+        </p:txBody>
+      </p:sp>
+      <p:pic>
+        <p:nvPicPr>
+          <p:cNvPr id="3" name="Picture 2" descr="comparacion_rec.png"/>
+          <p:cNvPicPr>
+            <a:picLocks noChangeAspect="1"/>
+          </p:cNvPicPr>
+          <p:nvPr/>
+        </p:nvPicPr>
+        <p:blipFill>
+          <a:blip r:embed="rId2"/>
+          <a:stretch>
+            <a:fillRect/>
+          </a:stretch>
+        </p:blipFill>
+        <p:spPr>
+          <a:xfrm>
+            <a:off x="4608576" y="1280160"/>
+            <a:ext cx="2971800" cy="5349240"/>
+          </a:xfrm>
+          <a:prstGeom prst="rect">
+            <a:avLst/>
+          </a:prstGeom>
+        </p:spPr>
+      </p:pic>
+    </p:spTree>
+  </p:cSld>
+  <p:clrMapOvr>
+    <a:masterClrMapping/>
+  </p:clrMapOvr>
+</p:sld>
+</file>
+
+<file path=ppt/slides/slide13.xml><?xml version="1.0" encoding="utf-8"?>
+<p:sld xmlns:a="http://schemas.openxmlformats.org/drawingml/2006/main" xmlns:p="http://schemas.openxmlformats.org/presentationml/2006/main" xmlns:r="http://schemas.openxmlformats.org/officeDocument/2006/relationships">
+  <p:cSld>
+    <p:spTree>
+      <p:nvGrpSpPr>
+        <p:cNvPr id="1" name=""/>
+        <p:cNvGrpSpPr/>
+        <p:nvPr/>
+      </p:nvGrpSpPr>
+      <p:grpSpPr/>
+      <p:sp>
+        <p:nvSpPr>
+          <p:cNvPr id="2" name="TextBox 1"/>
+          <p:cNvSpPr txBox="1"/>
+          <p:nvPr/>
+        </p:nvSpPr>
+        <p:spPr>
+          <a:xfrm>
+            <a:off x="548640" y="320040"/>
+            <a:ext cx="11064240" cy="822960"/>
+          </a:xfrm>
+          <a:prstGeom prst="rect">
+            <a:avLst/>
+          </a:prstGeom>
+          <a:noFill/>
+        </p:spPr>
+        <p:txBody>
+          <a:bodyPr wrap="square">
+            <a:spAutoFit/>
+          </a:bodyPr>
+          <a:lstStyle/>
+          <a:p>
+            <a:pPr>
+              <a:defRPr sz="2600" b="1">
+                <a:solidFill>
+                  <a:srgbClr val="1F3B73"/>
+                </a:solidFill>
+              </a:defRPr>
+            </a:pPr>
+            <a:r>
               <a:t>Mapas de error (misma grilla)</a:t>
             </a:r>
           </a:p>
@@ -3456,7 +3569,7 @@
 </p:sld>
 </file>
 
-<file path=ppt/slides/slide13.xml><?xml version="1.0" encoding="utf-8"?>
+<file path=ppt/slides/slide14.xml><?xml version="1.0" encoding="utf-8"?>
 <p:sld xmlns:a="http://schemas.openxmlformats.org/drawingml/2006/main" xmlns:p="http://schemas.openxmlformats.org/presentationml/2006/main" xmlns:r="http://schemas.openxmlformats.org/officeDocument/2006/relationships">
   <p:cSld>
     <p:spTree>
@@ -3759,7 +3872,7 @@
 </p:sld>
 </file>
 
-<file path=ppt/slides/slide14.xml><?xml version="1.0" encoding="utf-8"?>
+<file path=ppt/slides/slide15.xml><?xml version="1.0" encoding="utf-8"?>
 <p:sld xmlns:a="http://schemas.openxmlformats.org/drawingml/2006/main" xmlns:p="http://schemas.openxmlformats.org/presentationml/2006/main" xmlns:r="http://schemas.openxmlformats.org/officeDocument/2006/relationships">
   <p:cSld>
     <p:spTree>
@@ -4203,7 +4316,7 @@
 </p:sld>
 </file>
 
-<file path=ppt/slides/slide15.xml><?xml version="1.0" encoding="utf-8"?>
+<file path=ppt/slides/slide16.xml><?xml version="1.0" encoding="utf-8"?>
 <p:sld xmlns:a="http://schemas.openxmlformats.org/drawingml/2006/main" xmlns:p="http://schemas.openxmlformats.org/presentationml/2006/main" xmlns:r="http://schemas.openxmlformats.org/officeDocument/2006/relationships">
   <p:cSld>
     <p:spTree>
@@ -4635,7 +4748,7 @@
 </p:sld>
 </file>
 
-<file path=ppt/slides/slide16.xml><?xml version="1.0" encoding="utf-8"?>
+<file path=ppt/slides/slide17.xml><?xml version="1.0" encoding="utf-8"?>
 <p:sld xmlns:a="http://schemas.openxmlformats.org/drawingml/2006/main" xmlns:p="http://schemas.openxmlformats.org/presentationml/2006/main" xmlns:r="http://schemas.openxmlformats.org/officeDocument/2006/relationships">
   <p:cSld>
     <p:spTree>
@@ -4735,187 +4848,6 @@
             </a:pPr>
             <a:r>
               <a:t>Debajo del borde (salto a 0): 0 directo. Pegado al borde: interpolación TPS. Lejos del borde, en la zona lisa: DIP. El paso entre TPS y DIP es gradual (peso exp(−(d/20)²)).</a:t>
-            </a:r>
-          </a:p>
-        </p:txBody>
-      </p:sp>
-    </p:spTree>
-  </p:cSld>
-  <p:clrMapOvr>
-    <a:masterClrMapping/>
-  </p:clrMapOvr>
-</p:sld>
-</file>
-
-<file path=ppt/slides/slide17.xml><?xml version="1.0" encoding="utf-8"?>
-<p:sld xmlns:a="http://schemas.openxmlformats.org/drawingml/2006/main" xmlns:p="http://schemas.openxmlformats.org/presentationml/2006/main" xmlns:r="http://schemas.openxmlformats.org/officeDocument/2006/relationships">
-  <p:cSld>
-    <p:spTree>
-      <p:nvGrpSpPr>
-        <p:cNvPr id="1" name=""/>
-        <p:cNvGrpSpPr/>
-        <p:nvPr/>
-      </p:nvGrpSpPr>
-      <p:grpSpPr/>
-      <p:sp>
-        <p:nvSpPr>
-          <p:cNvPr id="2" name="TextBox 1"/>
-          <p:cNvSpPr txBox="1"/>
-          <p:nvPr/>
-        </p:nvSpPr>
-        <p:spPr>
-          <a:xfrm>
-            <a:off x="548640" y="320040"/>
-            <a:ext cx="11064240" cy="822960"/>
-          </a:xfrm>
-          <a:prstGeom prst="rect">
-            <a:avLst/>
-          </a:prstGeom>
-          <a:noFill/>
-        </p:spPr>
-        <p:txBody>
-          <a:bodyPr wrap="square">
-            <a:spAutoFit/>
-          </a:bodyPr>
-          <a:lstStyle/>
-          <a:p>
-            <a:pPr>
-              <a:defRPr sz="2700" b="1">
-                <a:solidFill>
-                  <a:srgbClr val="1F3B73"/>
-                </a:solidFill>
-              </a:defRPr>
-            </a:pPr>
-            <a:r>
-              <a:t>En KMC no sabemos la forma exacta: el método chequea sus supuestos</a:t>
-            </a:r>
-          </a:p>
-        </p:txBody>
-      </p:sp>
-      <p:sp>
-        <p:nvSpPr>
-          <p:cNvPr id="3" name="TextBox 2"/>
-          <p:cNvSpPr txBox="1"/>
-          <p:nvPr/>
-        </p:nvSpPr>
-        <p:spPr>
-          <a:xfrm>
-            <a:off x="548640" y="1280160"/>
-            <a:ext cx="10972800" cy="5120640"/>
-          </a:xfrm>
-          <a:prstGeom prst="rect">
-            <a:avLst/>
-          </a:prstGeom>
-          <a:noFill/>
-        </p:spPr>
-        <p:txBody>
-          <a:bodyPr wrap="square">
-            <a:spAutoFit/>
-          </a:bodyPr>
-          <a:lstStyle/>
-          <a:p>
-            <a:pPr>
-              <a:spcAft>
-                <a:spcPts val="500"/>
-              </a:spcAft>
-              <a:defRPr sz="1500">
-                <a:solidFill>
-                  <a:srgbClr val="404040"/>
-                </a:solidFill>
-              </a:defRPr>
-            </a:pPr>
-            <a:r>
-              <a:t>Todo se afinó con los 9 diagramas del modelo del continuo. En KMC la estructura es parecida (mesetas, rampas, acantilado) pero con otra distribución.</a:t>
-            </a:r>
-          </a:p>
-          <a:p>
-            <a:pPr>
-              <a:spcAft>
-                <a:spcPts val="500"/>
-              </a:spcAft>
-              <a:defRPr sz="1500">
-                <a:solidFill>
-                  <a:srgbClr val="404040"/>
-                </a:solidFill>
-              </a:defRPr>
-            </a:pPr>
-            <a:r>
-              <a:t>Cada supuesto se verifica con los propios puntos y, si no se cumple, se apaga:</a:t>
-            </a:r>
-          </a:p>
-          <a:p>
-            <a:pPr lvl="1">
-              <a:spcAft>
-                <a:spcPts val="500"/>
-              </a:spcAft>
-              <a:defRPr sz="1200">
-                <a:solidFill>
-                  <a:srgbClr val="404040"/>
-                </a:solidFill>
-              </a:defRPr>
-            </a:pPr>
-            <a:r>
-              <a:t>Monotonía: solo si ningún par de puntos la viola (más allá del ruido). Si ya la grilla la viola, no se hace bisección y todo el presupuesto va al relleno genérico.</a:t>
-            </a:r>
-          </a:p>
-          <a:p>
-            <a:pPr lvl="1">
-              <a:spcAft>
-                <a:spcPts val="500"/>
-              </a:spcAft>
-              <a:defRPr sz="1200">
-                <a:solidFill>
-                  <a:srgbClr val="404040"/>
-                </a:solidFill>
-              </a:defRPr>
-            </a:pPr>
-            <a:r>
-              <a:t>Acantilado: solo si casi todos los puntos debajo del borde valen 0. Borde recto, curvo (parábola / cúbica por RANSAC) o por tramos, elegido con los propios cruces.</a:t>
-            </a:r>
-          </a:p>
-          <a:p>
-            <a:pPr lvl="1">
-              <a:spcAft>
-                <a:spcPts val="500"/>
-              </a:spcAft>
-              <a:defRPr sz="1200">
-                <a:solidFill>
-                  <a:srgbClr val="404040"/>
-                </a:solidFill>
-              </a:defRPr>
-            </a:pPr>
-            <a:r>
-              <a:t>Compresión vertical: la elige la validación cruzada entre 4 valores.</a:t>
-            </a:r>
-          </a:p>
-          <a:p>
-            <a:pPr>
-              <a:spcAft>
-                <a:spcPts val="500"/>
-              </a:spcAft>
-              <a:defRPr sz="1500">
-                <a:solidFill>
-                  <a:srgbClr val="404040"/>
-                </a:solidFill>
-              </a:defRPr>
-            </a:pPr>
-            <a:r>
-              <a:t>En los 9 diagramas originales no cambia nada (mismos puntos, mismo resultado).</a:t>
-            </a:r>
-          </a:p>
-          <a:p>
-            <a:pPr>
-              <a:spcAft>
-                <a:spcPts val="500"/>
-              </a:spcAft>
-              <a:defRPr sz="1500">
-                <a:solidFill>
-                  <a:srgbClr val="404040"/>
-                </a:solidFill>
-              </a:defRPr>
-            </a:pPr>
-            <a:r>
-              <a:t>Diagramas de fase nuevos (g = +2, +4): 36.6 y 38.4 dB vs 32.4 y 34.5 del baseline. En formas totalmente distintas (Gauss, Rosenbrock, Himmelblau) ya no se rompe: cae a lo genérico.</a:t>
             </a:r>
           </a:p>
         </p:txBody>
@@ -4961,52 +4893,28 @@
           <a:lstStyle/>
           <a:p>
             <a:pPr>
-              <a:defRPr sz="2600" b="1">
+              <a:defRPr sz="2700" b="1">
                 <a:solidFill>
                   <a:srgbClr val="1F3B73"/>
                 </a:solidFill>
               </a:defRPr>
             </a:pPr>
             <a:r>
-              <a:t>Misma estructura, otra geometría</a:t>
-            </a:r>
-          </a:p>
-        </p:txBody>
-      </p:sp>
-      <p:pic>
-        <p:nvPicPr>
-          <p:cNvPr id="3" name="Picture 2" descr="deformados.png"/>
-          <p:cNvPicPr>
-            <a:picLocks noChangeAspect="1"/>
-          </p:cNvPicPr>
-          <p:nvPr/>
-        </p:nvPicPr>
-        <p:blipFill>
-          <a:blip r:embed="rId2"/>
-          <a:stretch>
-            <a:fillRect/>
-          </a:stretch>
-        </p:blipFill>
-        <p:spPr>
-          <a:xfrm>
-            <a:off x="1280769" y="1280160"/>
-            <a:ext cx="9627413" cy="4846320"/>
-          </a:xfrm>
-          <a:prstGeom prst="rect">
-            <a:avLst/>
-          </a:prstGeom>
-        </p:spPr>
-      </p:pic>
-      <p:sp>
-        <p:nvSpPr>
-          <p:cNvPr id="4" name="TextBox 3"/>
+              <a:t>En KMC no sabemos la forma exacta: el método chequea sus supuestos</a:t>
+            </a:r>
+          </a:p>
+        </p:txBody>
+      </p:sp>
+      <p:sp>
+        <p:nvSpPr>
+          <p:cNvPr id="3" name="TextBox 2"/>
           <p:cNvSpPr txBox="1"/>
           <p:nvPr/>
         </p:nvSpPr>
         <p:spPr>
           <a:xfrm>
-            <a:off x="548640" y="6172200"/>
-            <a:ext cx="11064240" cy="640080"/>
+            <a:off x="548640" y="1280160"/>
+            <a:ext cx="10972800" cy="5120640"/>
           </a:xfrm>
           <a:prstGeom prst="rect">
             <a:avLst/>
@@ -5019,15 +4927,108 @@
           </a:bodyPr>
           <a:lstStyle/>
           <a:p>
-            <a:pPr algn="ctr">
-              <a:defRPr sz="1200" i="1">
+            <a:pPr>
+              <a:spcAft>
+                <a:spcPts val="500"/>
+              </a:spcAft>
+              <a:defRPr sz="1500">
                 <a:solidFill>
                   <a:srgbClr val="404040"/>
                 </a:solidFill>
               </a:defRPr>
             </a:pPr>
             <a:r>
-              <a:t>Los 3 g (-4, -2, -0.5) deformados: acantilado corrido, con otra inclinación, arqueado o en S. El método le gana al baseline por ~9 dB; lo más difícil es el frente en S.</a:t>
+              <a:t>Todo se afinó con los 9 diagramas del modelo del continuo. En KMC la estructura es parecida (mesetas, rampas, acantilado) pero con otra distribución.</a:t>
+            </a:r>
+          </a:p>
+          <a:p>
+            <a:pPr>
+              <a:spcAft>
+                <a:spcPts val="500"/>
+              </a:spcAft>
+              <a:defRPr sz="1500">
+                <a:solidFill>
+                  <a:srgbClr val="404040"/>
+                </a:solidFill>
+              </a:defRPr>
+            </a:pPr>
+            <a:r>
+              <a:t>Cada supuesto se verifica con los propios puntos y, si no se cumple, se apaga:</a:t>
+            </a:r>
+          </a:p>
+          <a:p>
+            <a:pPr lvl="1">
+              <a:spcAft>
+                <a:spcPts val="500"/>
+              </a:spcAft>
+              <a:defRPr sz="1200">
+                <a:solidFill>
+                  <a:srgbClr val="404040"/>
+                </a:solidFill>
+              </a:defRPr>
+            </a:pPr>
+            <a:r>
+              <a:t>Monotonía: solo si ningún par de puntos la viola (más allá del ruido). Si ya la grilla la viola, no se hace bisección y todo el presupuesto va al relleno genérico.</a:t>
+            </a:r>
+          </a:p>
+          <a:p>
+            <a:pPr lvl="1">
+              <a:spcAft>
+                <a:spcPts val="500"/>
+              </a:spcAft>
+              <a:defRPr sz="1200">
+                <a:solidFill>
+                  <a:srgbClr val="404040"/>
+                </a:solidFill>
+              </a:defRPr>
+            </a:pPr>
+            <a:r>
+              <a:t>Acantilado: solo si casi todos los puntos debajo del borde valen 0. Borde recto, curvo (parábola / cúbica por RANSAC) o por tramos, elegido con los propios cruces.</a:t>
+            </a:r>
+          </a:p>
+          <a:p>
+            <a:pPr lvl="1">
+              <a:spcAft>
+                <a:spcPts val="500"/>
+              </a:spcAft>
+              <a:defRPr sz="1200">
+                <a:solidFill>
+                  <a:srgbClr val="404040"/>
+                </a:solidFill>
+              </a:defRPr>
+            </a:pPr>
+            <a:r>
+              <a:t>Compresión vertical: la elige la validación cruzada entre 4 valores.</a:t>
+            </a:r>
+          </a:p>
+          <a:p>
+            <a:pPr>
+              <a:spcAft>
+                <a:spcPts val="500"/>
+              </a:spcAft>
+              <a:defRPr sz="1500">
+                <a:solidFill>
+                  <a:srgbClr val="404040"/>
+                </a:solidFill>
+              </a:defRPr>
+            </a:pPr>
+            <a:r>
+              <a:t>En los 9 diagramas originales no cambia nada (mismos puntos, mismo resultado).</a:t>
+            </a:r>
+          </a:p>
+          <a:p>
+            <a:pPr>
+              <a:spcAft>
+                <a:spcPts val="500"/>
+              </a:spcAft>
+              <a:defRPr sz="1500">
+                <a:solidFill>
+                  <a:srgbClr val="404040"/>
+                </a:solidFill>
+              </a:defRPr>
+            </a:pPr>
+            <a:r>
+              <a:t>Diagramas de fase nuevos (g = +2, +4): 36.6 y 38.4 dB vs 32.4 y 34.5 del baseline. En formas totalmente distintas (Gauss, Rosenbrock, Himmelblau) ya no se rompe: cae a lo genérico.</a:t>
             </a:r>
           </a:p>
         </p:txBody>
@@ -5080,14 +5081,14 @@
               </a:defRPr>
             </a:pPr>
             <a:r>
-              <a:t>Ruido tipo KMC: la receta se puede hacer robusta</a:t>
+              <a:t>Misma estructura, otra geometría</a:t>
             </a:r>
           </a:p>
         </p:txBody>
       </p:sp>
       <p:pic>
         <p:nvPicPr>
-          <p:cNvPr id="3" name="Picture 2" descr="ruido.png"/>
+          <p:cNvPr id="3" name="Picture 2" descr="deformados.png"/>
           <p:cNvPicPr>
             <a:picLocks noChangeAspect="1"/>
           </p:cNvPicPr>
@@ -5101,8 +5102,8 @@
         </p:blipFill>
         <p:spPr>
           <a:xfrm>
-            <a:off x="1751076" y="1300495"/>
-            <a:ext cx="8686800" cy="4805649"/>
+            <a:off x="1280769" y="1280160"/>
+            <a:ext cx="9627413" cy="4846320"/>
           </a:xfrm>
           <a:prstGeom prst="rect">
             <a:avLst/>
@@ -5139,7 +5140,7 @@
               </a:defRPr>
             </a:pPr>
             <a:r>
-              <a:t>Cada punto con ruido gaussiano de desvío σ (fijo por punto). Umbral de 'vale 0' = 3σ, salto mínimo ~5σ y recta del acantilado por RANSAC. σ hay que estimarlo en KMC con corridas repetidas.</a:t>
+              <a:t>Los 3 g (-4, -2, -0.5) deformados: acantilado corrido, con otra inclinación, arqueado o en S. El método le gana al baseline por ~9 dB; lo más difícil es el frente en S.</a:t>
             </a:r>
           </a:p>
         </p:txBody>
@@ -5265,6 +5266,118 @@
 </file>
 
 <file path=ppt/slides/slide20.xml><?xml version="1.0" encoding="utf-8"?>
+<p:sld xmlns:a="http://schemas.openxmlformats.org/drawingml/2006/main" xmlns:p="http://schemas.openxmlformats.org/presentationml/2006/main" xmlns:r="http://schemas.openxmlformats.org/officeDocument/2006/relationships">
+  <p:cSld>
+    <p:spTree>
+      <p:nvGrpSpPr>
+        <p:cNvPr id="1" name=""/>
+        <p:cNvGrpSpPr/>
+        <p:nvPr/>
+      </p:nvGrpSpPr>
+      <p:grpSpPr/>
+      <p:sp>
+        <p:nvSpPr>
+          <p:cNvPr id="2" name="TextBox 1"/>
+          <p:cNvSpPr txBox="1"/>
+          <p:nvPr/>
+        </p:nvSpPr>
+        <p:spPr>
+          <a:xfrm>
+            <a:off x="548640" y="320040"/>
+            <a:ext cx="11064240" cy="822960"/>
+          </a:xfrm>
+          <a:prstGeom prst="rect">
+            <a:avLst/>
+          </a:prstGeom>
+          <a:noFill/>
+        </p:spPr>
+        <p:txBody>
+          <a:bodyPr wrap="square">
+            <a:spAutoFit/>
+          </a:bodyPr>
+          <a:lstStyle/>
+          <a:p>
+            <a:pPr>
+              <a:defRPr sz="2600" b="1">
+                <a:solidFill>
+                  <a:srgbClr val="1F3B73"/>
+                </a:solidFill>
+              </a:defRPr>
+            </a:pPr>
+            <a:r>
+              <a:t>Ruido tipo KMC: la receta se puede hacer robusta</a:t>
+            </a:r>
+          </a:p>
+        </p:txBody>
+      </p:sp>
+      <p:pic>
+        <p:nvPicPr>
+          <p:cNvPr id="3" name="Picture 2" descr="ruido.png"/>
+          <p:cNvPicPr>
+            <a:picLocks noChangeAspect="1"/>
+          </p:cNvPicPr>
+          <p:nvPr/>
+        </p:nvPicPr>
+        <p:blipFill>
+          <a:blip r:embed="rId2"/>
+          <a:stretch>
+            <a:fillRect/>
+          </a:stretch>
+        </p:blipFill>
+        <p:spPr>
+          <a:xfrm>
+            <a:off x="1751076" y="1300495"/>
+            <a:ext cx="8686800" cy="4805649"/>
+          </a:xfrm>
+          <a:prstGeom prst="rect">
+            <a:avLst/>
+          </a:prstGeom>
+        </p:spPr>
+      </p:pic>
+      <p:sp>
+        <p:nvSpPr>
+          <p:cNvPr id="4" name="TextBox 3"/>
+          <p:cNvSpPr txBox="1"/>
+          <p:nvPr/>
+        </p:nvSpPr>
+        <p:spPr>
+          <a:xfrm>
+            <a:off x="548640" y="6172200"/>
+            <a:ext cx="11064240" cy="640080"/>
+          </a:xfrm>
+          <a:prstGeom prst="rect">
+            <a:avLst/>
+          </a:prstGeom>
+          <a:noFill/>
+        </p:spPr>
+        <p:txBody>
+          <a:bodyPr wrap="square">
+            <a:spAutoFit/>
+          </a:bodyPr>
+          <a:lstStyle/>
+          <a:p>
+            <a:pPr algn="ctr">
+              <a:defRPr sz="1200" i="1">
+                <a:solidFill>
+                  <a:srgbClr val="404040"/>
+                </a:solidFill>
+              </a:defRPr>
+            </a:pPr>
+            <a:r>
+              <a:t>Cada punto con ruido gaussiano de desvío σ (fijo por punto). Umbral de 'vale 0' = 3σ, salto mínimo ~5σ y recta del acantilado por RANSAC. σ hay que estimarlo en KMC con corridas repetidas.</a:t>
+            </a:r>
+          </a:p>
+        </p:txBody>
+      </p:sp>
+    </p:spTree>
+  </p:cSld>
+  <p:clrMapOvr>
+    <a:masterClrMapping/>
+  </p:clrMapOvr>
+</p:sld>
+</file>
+
+<file path=ppt/slides/slide21.xml><?xml version="1.0" encoding="utf-8"?>
 <p:sld xmlns:a="http://schemas.openxmlformats.org/drawingml/2006/main" xmlns:p="http://schemas.openxmlformats.org/presentationml/2006/main" xmlns:r="http://schemas.openxmlformats.org/officeDocument/2006/relationships">
   <p:cSld>
     <p:spTree>
@@ -5689,7 +5802,7 @@
 </p:sld>
 </file>
 
-<file path=ppt/slides/slide21.xml><?xml version="1.0" encoding="utf-8"?>
+<file path=ppt/slides/slide22.xml><?xml version="1.0" encoding="utf-8"?>
 <p:sld xmlns:a="http://schemas.openxmlformats.org/drawingml/2006/main" xmlns:p="http://schemas.openxmlformats.org/presentationml/2006/main" xmlns:r="http://schemas.openxmlformats.org/officeDocument/2006/relationships">
   <p:cSld>
     <p:spTree>
@@ -5789,142 +5902,6 @@
             </a:pPr>
             <a:r>
               <a:t>Con 1 % DIP recupera la forma pero la cresta angosta queda ondulada; con 5 % queda fiel. Con 64 puntos la TPS da una superficie reconocible pero con bultos.</a:t>
-            </a:r>
-          </a:p>
-        </p:txBody>
-      </p:sp>
-    </p:spTree>
-  </p:cSld>
-  <p:clrMapOvr>
-    <a:masterClrMapping/>
-  </p:clrMapOvr>
-</p:sld>
-</file>
-
-<file path=ppt/slides/slide22.xml><?xml version="1.0" encoding="utf-8"?>
-<p:sld xmlns:a="http://schemas.openxmlformats.org/drawingml/2006/main" xmlns:p="http://schemas.openxmlformats.org/presentationml/2006/main" xmlns:r="http://schemas.openxmlformats.org/officeDocument/2006/relationships">
-  <p:cSld>
-    <p:spTree>
-      <p:nvGrpSpPr>
-        <p:cNvPr id="1" name=""/>
-        <p:cNvGrpSpPr/>
-        <p:nvPr/>
-      </p:nvGrpSpPr>
-      <p:grpSpPr/>
-      <p:sp>
-        <p:nvSpPr>
-          <p:cNvPr id="2" name="TextBox 1"/>
-          <p:cNvSpPr txBox="1"/>
-          <p:nvPr/>
-        </p:nvSpPr>
-        <p:spPr>
-          <a:xfrm>
-            <a:off x="548640" y="320040"/>
-            <a:ext cx="11064240" cy="822960"/>
-          </a:xfrm>
-          <a:prstGeom prst="rect">
-            <a:avLst/>
-          </a:prstGeom>
-          <a:noFill/>
-        </p:spPr>
-        <p:txBody>
-          <a:bodyPr wrap="square">
-            <a:spAutoFit/>
-          </a:bodyPr>
-          <a:lstStyle/>
-          <a:p>
-            <a:pPr>
-              <a:defRPr sz="2700" b="1">
-                <a:solidFill>
-                  <a:srgbClr val="1F3B73"/>
-                </a:solidFill>
-              </a:defRPr>
-            </a:pPr>
-            <a:r>
-              <a:t>Pedidos de la reunión: estado</a:t>
-            </a:r>
-          </a:p>
-        </p:txBody>
-      </p:sp>
-      <p:sp>
-        <p:nvSpPr>
-          <p:cNvPr id="3" name="TextBox 2"/>
-          <p:cNvSpPr txBox="1"/>
-          <p:nvPr/>
-        </p:nvSpPr>
-        <p:spPr>
-          <a:xfrm>
-            <a:off x="548640" y="1280160"/>
-            <a:ext cx="10972800" cy="5120640"/>
-          </a:xfrm>
-          <a:prstGeom prst="rect">
-            <a:avLst/>
-          </a:prstGeom>
-          <a:noFill/>
-        </p:spPr>
-        <p:txBody>
-          <a:bodyPr wrap="square">
-            <a:spAutoFit/>
-          </a:bodyPr>
-          <a:lstStyle/>
-          <a:p>
-            <a:pPr>
-              <a:spcAft>
-                <a:spcPts val="500"/>
-              </a:spcAft>
-              <a:defRPr sz="1600">
-                <a:solidFill>
-                  <a:srgbClr val="404040"/>
-                </a:solidFill>
-              </a:defRPr>
-            </a:pPr>
-            <a:r>
-              <a:t>1–3) Optuna + grid/uniform con hiperparámetros + la grilla como hiperparámetro: 181 trials en Mendieta. Mejor DIP con 64 puntos en grilla: 29.9 dB (config 'vase' del paper afinada); uniform siempre peor. En el muestreo nuevo, la grilla (6 columnas × 5 filas) es el parámetro más sensible.</a:t>
-            </a:r>
-          </a:p>
-          <a:p>
-            <a:pPr>
-              <a:spcAft>
-                <a:spcPts val="500"/>
-              </a:spcAft>
-              <a:defRPr sz="1600">
-                <a:solidFill>
-                  <a:srgbClr val="404040"/>
-                </a:solidFill>
-              </a:defRPr>
-            </a:pPr>
-            <a:r>
-              <a:t>4) Ventana: la bisección ya concentra ~25 de los 64 puntos en una franja angosta alrededor del frente (ventana adaptativa).</a:t>
-            </a:r>
-          </a:p>
-          <a:p>
-            <a:pPr>
-              <a:spcAft>
-                <a:spcPts val="500"/>
-              </a:spcAft>
-              <a:defRPr sz="1600">
-                <a:solidFill>
-                  <a:srgbClr val="404040"/>
-                </a:solidFill>
-              </a:defRPr>
-            </a:pPr>
-            <a:r>
-              <a:t>5) Rosenbrock en 3D: hecho (diapositiva anterior).</a:t>
-            </a:r>
-          </a:p>
-          <a:p>
-            <a:pPr>
-              <a:spcAft>
-                <a:spcPts val="500"/>
-              </a:spcAft>
-              <a:defRPr sz="1600">
-                <a:solidFill>
-                  <a:srgbClr val="404040"/>
-                </a:solidFill>
-              </a:defRPr>
-            </a:pPr>
-            <a:r>
-              <a:t>6) Interpolación de scipy vs. DIP: con los mismos puntos empatan con la receta de la tesis (24.4 vs. 25.0); DIP con la config del paper gana (28.5).</a:t>
             </a:r>
           </a:p>
         </p:txBody>
@@ -5977,7 +5954,7 @@
               </a:defRPr>
             </a:pPr>
             <a:r>
-              <a:t>Lo que se probó y NO funcionó (para no repetirlo)</a:t>
+              <a:t>Pedidos de la reunión: estado</a:t>
             </a:r>
           </a:p>
         </p:txBody>
@@ -6008,14 +5985,14 @@
               <a:spcAft>
                 <a:spcPts val="500"/>
               </a:spcAft>
-              <a:defRPr sz="1500">
+              <a:defRPr sz="1600">
                 <a:solidFill>
                   <a:srgbClr val="404040"/>
                 </a:solidFill>
               </a:defRPr>
             </a:pPr>
             <a:r>
-              <a:t>Frente como parábola por puntos medios de pares con salto: inestable, dejaba una costura.</a:t>
+              <a:t>1–3) Optuna + grid/uniform con hiperparámetros + la grilla como hiperparámetro: 181 trials en Mendieta. Mejor DIP con 64 puntos en grilla: 29.9 dB (config 'vase' del paper afinada); uniform siempre peor. En el muestreo nuevo, la grilla (6 columnas × 5 filas) es el parámetro más sensible.</a:t>
             </a:r>
           </a:p>
           <a:p>
@@ -6023,14 +6000,14 @@
               <a:spcAft>
                 <a:spcPts val="500"/>
               </a:spcAft>
-              <a:defRPr sz="1500">
+              <a:defRPr sz="1600">
                 <a:solidFill>
                   <a:srgbClr val="404040"/>
                 </a:solidFill>
               </a:defRPr>
             </a:pPr>
             <a:r>
-              <a:t>Bisección al nivel medio: en los g suaves caía dentro de la rampa, no en el acantilado.</a:t>
+              <a:t>4) Ventana: la bisección ya concentra ~25 de los 64 puntos en una franja angosta alrededor del frente (ventana adaptativa).</a:t>
             </a:r>
           </a:p>
           <a:p>
@@ -6038,14 +6015,14 @@
               <a:spcAft>
                 <a:spcPts val="500"/>
               </a:spcAft>
-              <a:defRPr sz="1500">
+              <a:defRPr sz="1600">
                 <a:solidFill>
                   <a:srgbClr val="404040"/>
                 </a:solidFill>
               </a:defRPr>
             </a:pPr>
             <a:r>
-              <a:t>Sondas del perfil de la rampa (3-7-14 px sobre el borde): le quitan presupuesto al relleno.</a:t>
+              <a:t>5) Rosenbrock en 3D: hecho (diapositiva anterior).</a:t>
             </a:r>
           </a:p>
           <a:p>
@@ -6053,74 +6030,14 @@
               <a:spcAft>
                 <a:spcPts val="500"/>
               </a:spcAft>
-              <a:defRPr sz="1500">
+              <a:defRPr sz="1600">
                 <a:solidFill>
                   <a:srgbClr val="404040"/>
                 </a:solidFill>
               </a:defRPr>
             </a:pPr>
             <a:r>
-              <a:t>Proceso gaussiano en lugar de la TPS: con tan pocos puntos, las escalas aprendidas quedan mal (g=-2: 22 dB vs. 36).</a:t>
-            </a:r>
-          </a:p>
-          <a:p>
-            <a:pPr>
-              <a:spcAft>
-                <a:spcPts val="500"/>
-              </a:spcAft>
-              <a:defRPr sz="1500">
-                <a:solidFill>
-                  <a:srgbClr val="404040"/>
-                </a:solidFill>
-              </a:defRPr>
-            </a:pPr>
-            <a:r>
-              <a:t>Relleno por ancho de las cotas de monotonía: mejor peor g, pero −2.7 dB en g=-4.</a:t>
-            </a:r>
-          </a:p>
-          <a:p>
-            <a:pPr>
-              <a:spcAft>
-                <a:spcPts val="500"/>
-              </a:spcAft>
-              <a:defRPr sz="1500">
-                <a:solidFill>
-                  <a:srgbClr val="404040"/>
-                </a:solidFill>
-              </a:defRPr>
-            </a:pPr>
-            <a:r>
-              <a:t>Grilla de 7-8 columnas: no falla el detector, se acaba el presupuesto en la bisección.</a:t>
-            </a:r>
-          </a:p>
-          <a:p>
-            <a:pPr>
-              <a:spcAft>
-                <a:spcPts val="500"/>
-              </a:spcAft>
-              <a:defRPr sz="1500">
-                <a:solidFill>
-                  <a:srgbClr val="404040"/>
-                </a:solidFill>
-              </a:defRPr>
-            </a:pPr>
-            <a:r>
-              <a:t>DIP 'kate' del paper con 64 puntos (18 dB): pensado para imágenes casi completas.</a:t>
-            </a:r>
-          </a:p>
-          <a:p>
-            <a:pPr>
-              <a:spcAft>
-                <a:spcPts val="500"/>
-              </a:spcAft>
-              <a:defRPr sz="1500">
-                <a:solidFill>
-                  <a:srgbClr val="404040"/>
-                </a:solidFill>
-              </a:defRPr>
-            </a:pPr>
-            <a:r>
-              <a:t>Fusión sin guarda en 9 g: cuando DIP falla en un g (-4 dB), arrastra el promedio.</a:t>
+              <a:t>6) Interpolación de scipy vs. DIP: con los mismos puntos empatan con la receta de la tesis (24.4 vs. 25.0); DIP con la config del paper gana (28.5).</a:t>
             </a:r>
           </a:p>
         </p:txBody>
@@ -6173,7 +6090,7 @@
               </a:defRPr>
             </a:pPr>
             <a:r>
-              <a:t>Listo para KMC: planificador de tandas (autoexp/kmc_planner.py)</a:t>
+              <a:t>Lo que se probó y NO funcionó (para no repetirlo)</a:t>
             </a:r>
           </a:p>
         </p:txBody>
@@ -6204,14 +6121,14 @@
               <a:spcAft>
                 <a:spcPts val="500"/>
               </a:spcAft>
-              <a:defRPr sz="1700">
+              <a:defRPr sz="1500">
                 <a:solidFill>
                   <a:srgbClr val="404040"/>
                 </a:solidFill>
               </a:defRPr>
             </a:pPr>
             <a:r>
-              <a:t>init --budget 64 --sigma σ  →  next  →  (correr KMC)  →  add resultados.csv  →  next ...  →  reconstruct</a:t>
+              <a:t>Frente como parábola por puntos medios de pares con salto: inestable, dejaba una costura.</a:t>
             </a:r>
           </a:p>
           <a:p>
@@ -6219,14 +6136,14 @@
               <a:spcAft>
                 <a:spcPts val="500"/>
               </a:spcAft>
-              <a:defRPr sz="1700">
+              <a:defRPr sz="1500">
                 <a:solidFill>
                   <a:srgbClr val="404040"/>
                 </a:solidFill>
               </a:defRPr>
             </a:pPr>
             <a:r>
-              <a:t>Cada 'next' devuelve la tanda siguiente en (log Ξ, log ℓ), para correr en paralelo en el cluster.</a:t>
+              <a:t>Bisección al nivel medio: en los g suaves caía dentro de la rampa, no en el acantilado.</a:t>
             </a:r>
           </a:p>
           <a:p>
@@ -6234,14 +6151,14 @@
               <a:spcAft>
                 <a:spcPts val="500"/>
               </a:spcAft>
-              <a:defRPr sz="1700">
+              <a:defRPr sz="1500">
                 <a:solidFill>
                   <a:srgbClr val="404040"/>
                 </a:solidFill>
               </a:defRPr>
             </a:pPr>
             <a:r>
-              <a:t>Con 64 puntos: 9 tandas = 30 (grilla) + 4-5 rondas de ~5 (bisección) + 3-4 rondas de 4 (relleno).</a:t>
+              <a:t>Sondas del perfil de la rampa (3-7-14 px sobre el borde): le quitan presupuesto al relleno.</a:t>
             </a:r>
           </a:p>
           <a:p>
@@ -6249,14 +6166,14 @@
               <a:spcAft>
                 <a:spcPts val="500"/>
               </a:spcAft>
-              <a:defRPr sz="1700">
+              <a:defRPr sz="1500">
                 <a:solidFill>
                   <a:srgbClr val="404040"/>
                 </a:solidFill>
               </a:defRPr>
             </a:pPr>
             <a:r>
-              <a:t>Probado de punta a punta contra el modelo del continuo (simulate): g=-4 46.2 dB, g=-2 38.6, g=-0.5 39.4; g=-2 con ruido σ=0.01: 37.6.</a:t>
+              <a:t>Proceso gaussiano en lugar de la TPS: con tan pocos puntos, las escalas aprendidas quedan mal (g=-2: 22 dB vs. 36).</a:t>
             </a:r>
           </a:p>
           <a:p>
@@ -6264,14 +6181,59 @@
               <a:spcAft>
                 <a:spcPts val="500"/>
               </a:spcAft>
-              <a:defRPr sz="1700">
+              <a:defRPr sz="1500">
                 <a:solidFill>
                   <a:srgbClr val="404040"/>
                 </a:solidFill>
               </a:defRPr>
             </a:pPr>
             <a:r>
-              <a:t>σ se estima con corridas repetidas de KMC (NRUNS) y fija todos los umbrales solo.</a:t>
+              <a:t>Relleno por ancho de las cotas de monotonía: mejor peor g, pero −2.7 dB en g=-4.</a:t>
+            </a:r>
+          </a:p>
+          <a:p>
+            <a:pPr>
+              <a:spcAft>
+                <a:spcPts val="500"/>
+              </a:spcAft>
+              <a:defRPr sz="1500">
+                <a:solidFill>
+                  <a:srgbClr val="404040"/>
+                </a:solidFill>
+              </a:defRPr>
+            </a:pPr>
+            <a:r>
+              <a:t>Grilla de 7-8 columnas: no falla el detector, se acaba el presupuesto en la bisección.</a:t>
+            </a:r>
+          </a:p>
+          <a:p>
+            <a:pPr>
+              <a:spcAft>
+                <a:spcPts val="500"/>
+              </a:spcAft>
+              <a:defRPr sz="1500">
+                <a:solidFill>
+                  <a:srgbClr val="404040"/>
+                </a:solidFill>
+              </a:defRPr>
+            </a:pPr>
+            <a:r>
+              <a:t>DIP 'kate' del paper con 64 puntos (18 dB): pensado para imágenes casi completas.</a:t>
+            </a:r>
+          </a:p>
+          <a:p>
+            <a:pPr>
+              <a:spcAft>
+                <a:spcPts val="500"/>
+              </a:spcAft>
+              <a:defRPr sz="1500">
+                <a:solidFill>
+                  <a:srgbClr val="404040"/>
+                </a:solidFill>
+              </a:defRPr>
+            </a:pPr>
+            <a:r>
+              <a:t>Fusión sin guarda en 9 g: cuando DIP falla en un g (-4 dB), arrastra el promedio.</a:t>
             </a:r>
           </a:p>
         </p:txBody>
@@ -6285,6 +6247,157 @@
 </file>
 
 <file path=ppt/slides/slide25.xml><?xml version="1.0" encoding="utf-8"?>
+<p:sld xmlns:a="http://schemas.openxmlformats.org/drawingml/2006/main" xmlns:p="http://schemas.openxmlformats.org/presentationml/2006/main" xmlns:r="http://schemas.openxmlformats.org/officeDocument/2006/relationships">
+  <p:cSld>
+    <p:spTree>
+      <p:nvGrpSpPr>
+        <p:cNvPr id="1" name=""/>
+        <p:cNvGrpSpPr/>
+        <p:nvPr/>
+      </p:nvGrpSpPr>
+      <p:grpSpPr/>
+      <p:sp>
+        <p:nvSpPr>
+          <p:cNvPr id="2" name="TextBox 1"/>
+          <p:cNvSpPr txBox="1"/>
+          <p:nvPr/>
+        </p:nvSpPr>
+        <p:spPr>
+          <a:xfrm>
+            <a:off x="548640" y="320040"/>
+            <a:ext cx="11064240" cy="822960"/>
+          </a:xfrm>
+          <a:prstGeom prst="rect">
+            <a:avLst/>
+          </a:prstGeom>
+          <a:noFill/>
+        </p:spPr>
+        <p:txBody>
+          <a:bodyPr wrap="square">
+            <a:spAutoFit/>
+          </a:bodyPr>
+          <a:lstStyle/>
+          <a:p>
+            <a:pPr>
+              <a:defRPr sz="2700" b="1">
+                <a:solidFill>
+                  <a:srgbClr val="1F3B73"/>
+                </a:solidFill>
+              </a:defRPr>
+            </a:pPr>
+            <a:r>
+              <a:t>Listo para KMC: planificador de tandas (autoexp/kmc_planner.py)</a:t>
+            </a:r>
+          </a:p>
+        </p:txBody>
+      </p:sp>
+      <p:sp>
+        <p:nvSpPr>
+          <p:cNvPr id="3" name="TextBox 2"/>
+          <p:cNvSpPr txBox="1"/>
+          <p:nvPr/>
+        </p:nvSpPr>
+        <p:spPr>
+          <a:xfrm>
+            <a:off x="548640" y="1280160"/>
+            <a:ext cx="10972800" cy="5120640"/>
+          </a:xfrm>
+          <a:prstGeom prst="rect">
+            <a:avLst/>
+          </a:prstGeom>
+          <a:noFill/>
+        </p:spPr>
+        <p:txBody>
+          <a:bodyPr wrap="square">
+            <a:spAutoFit/>
+          </a:bodyPr>
+          <a:lstStyle/>
+          <a:p>
+            <a:pPr>
+              <a:spcAft>
+                <a:spcPts val="500"/>
+              </a:spcAft>
+              <a:defRPr sz="1700">
+                <a:solidFill>
+                  <a:srgbClr val="404040"/>
+                </a:solidFill>
+              </a:defRPr>
+            </a:pPr>
+            <a:r>
+              <a:t>init --budget 64 --sigma σ  →  next  →  (correr KMC)  →  add resultados.csv  →  next ...  →  reconstruct</a:t>
+            </a:r>
+          </a:p>
+          <a:p>
+            <a:pPr>
+              <a:spcAft>
+                <a:spcPts val="500"/>
+              </a:spcAft>
+              <a:defRPr sz="1700">
+                <a:solidFill>
+                  <a:srgbClr val="404040"/>
+                </a:solidFill>
+              </a:defRPr>
+            </a:pPr>
+            <a:r>
+              <a:t>Cada 'next' devuelve la tanda siguiente en (log Ξ, log ℓ), para correr en paralelo en el cluster.</a:t>
+            </a:r>
+          </a:p>
+          <a:p>
+            <a:pPr>
+              <a:spcAft>
+                <a:spcPts val="500"/>
+              </a:spcAft>
+              <a:defRPr sz="1700">
+                <a:solidFill>
+                  <a:srgbClr val="404040"/>
+                </a:solidFill>
+              </a:defRPr>
+            </a:pPr>
+            <a:r>
+              <a:t>Con 64 puntos: 9 tandas = 30 (grilla) + 4-5 rondas de ~5 (bisección) + 3-4 rondas de 4 (relleno).</a:t>
+            </a:r>
+          </a:p>
+          <a:p>
+            <a:pPr>
+              <a:spcAft>
+                <a:spcPts val="500"/>
+              </a:spcAft>
+              <a:defRPr sz="1700">
+                <a:solidFill>
+                  <a:srgbClr val="404040"/>
+                </a:solidFill>
+              </a:defRPr>
+            </a:pPr>
+            <a:r>
+              <a:t>Probado de punta a punta contra el modelo del continuo (simulate): g=-4 46.2 dB, g=-2 38.6, g=-0.5 39.4; g=-2 con ruido σ=0.01: 37.6.</a:t>
+            </a:r>
+          </a:p>
+          <a:p>
+            <a:pPr>
+              <a:spcAft>
+                <a:spcPts val="500"/>
+              </a:spcAft>
+              <a:defRPr sz="1700">
+                <a:solidFill>
+                  <a:srgbClr val="404040"/>
+                </a:solidFill>
+              </a:defRPr>
+            </a:pPr>
+            <a:r>
+              <a:t>σ se estima con corridas repetidas de KMC (NRUNS) y fija todos los umbrales solo.</a:t>
+            </a:r>
+          </a:p>
+        </p:txBody>
+      </p:sp>
+    </p:spTree>
+  </p:cSld>
+  <p:clrMapOvr>
+    <a:masterClrMapping/>
+  </p:clrMapOvr>
+</p:sld>
+</file>
+
+<file path=ppt/slides/slide26.xml><?xml version="1.0" encoding="utf-8"?>
 <p:sld xmlns:a="http://schemas.openxmlformats.org/drawingml/2006/main" xmlns:p="http://schemas.openxmlformats.org/presentationml/2006/main" xmlns:r="http://schemas.openxmlformats.org/officeDocument/2006/relationships">
   <p:cSld>
     <p:spTree>

</xml_diff>

<commit_message>
Rosenbrock 3D: agregar el metodo nuevo con 64 puntos
</commit_message>
<xml_diff>
--- a/presentaciones/presentacion4_autoexp/presentacion4_autoexp.pptx
+++ b/presentaciones/presentacion4_autoexp/presentacion4_autoexp.pptx
@@ -5863,8 +5863,8 @@
         </p:blipFill>
         <p:spPr>
           <a:xfrm>
-            <a:off x="333756" y="1399032"/>
-            <a:ext cx="11521440" cy="4608576"/>
+            <a:off x="333756" y="1783080"/>
+            <a:ext cx="11521440" cy="3840480"/>
           </a:xfrm>
           <a:prstGeom prst="rect">
             <a:avLst/>

</xml_diff>

<commit_message>
autoexp: presupuesto para 40 dB en todos los g (96 pts sin DIP); Optuna v2 cerrado; analisis TPS vs DIP por franja; presentacion
</commit_message>
<xml_diff>
--- a/presentaciones/presentacion4_autoexp/presentacion4_autoexp.pptx
+++ b/presentaciones/presentacion4_autoexp/presentacion4_autoexp.pptx
@@ -31,6 +31,7 @@
     <p:sldId id="279" r:id="rId30"/>
     <p:sldId id="280" r:id="rId31"/>
     <p:sldId id="281" r:id="rId32"/>
+    <p:sldId id="282" r:id="rId33"/>
   </p:sldIdLst>
   <p:sldSz cx="12188952" cy="6858000" type="screen4x3"/>
   <p:notesSz cx="6858000" cy="9144000"/>
@@ -5947,28 +5948,366 @@
           <a:lstStyle/>
           <a:p>
             <a:pPr>
-              <a:defRPr sz="2700" b="1">
+              <a:defRPr sz="2600" b="1">
                 <a:solidFill>
                   <a:srgbClr val="1F3B73"/>
                 </a:solidFill>
               </a:defRPr>
             </a:pPr>
             <a:r>
-              <a:t>Pedidos de la reunión: estado</a:t>
-            </a:r>
-          </a:p>
-        </p:txBody>
-      </p:sp>
-      <p:sp>
-        <p:nvSpPr>
-          <p:cNvPr id="3" name="TextBox 2"/>
+              <a:t>¿Cuántos puntos hacen falta para 40 dB en todos los g?</a:t>
+            </a:r>
+          </a:p>
+        </p:txBody>
+      </p:sp>
+      <p:graphicFrame>
+        <p:nvGraphicFramePr>
+          <p:cNvPr id="3" name="Table 2"/>
+          <p:cNvGraphicFramePr>
+            <a:graphicFrameLocks noGrp="1"/>
+          </p:cNvGraphicFramePr>
+          <p:nvPr/>
+        </p:nvGraphicFramePr>
+        <p:xfrm>
+          <a:off x="731520" y="1371600"/>
+          <a:ext cx="9875520" cy="1920240"/>
+        </p:xfrm>
+        <a:graphic>
+          <a:graphicData uri="http://schemas.openxmlformats.org/drawingml/2006/table">
+            <a:tbl>
+              <a:tblPr firstRow="1" bandRow="1">
+                <a:tableStyleId>{5C22544A-7EE6-4342-B048-85BDC9FD1C3A}</a:tableStyleId>
+              </a:tblPr>
+              <a:tblGrid>
+                <a:gridCol w="2926080"/>
+                <a:gridCol w="2926080"/>
+                <a:gridCol w="2011680"/>
+                <a:gridCol w="2011680"/>
+              </a:tblGrid>
+              <a:tr h="384048">
+                <a:tc>
+                  <a:txBody>
+                    <a:bodyPr/>
+                    <a:lstStyle/>
+                    <a:p>
+                      <a:pPr>
+                        <a:defRPr sz="1300" b="1"/>
+                      </a:pPr>
+                      <a:r>
+                        <a:t>presupuesto</a:t>
+                      </a:r>
+                    </a:p>
+                  </a:txBody>
+                  <a:tcPr/>
+                </a:tc>
+                <a:tc>
+                  <a:txBody>
+                    <a:bodyPr/>
+                    <a:lstStyle/>
+                    <a:p>
+                      <a:pPr>
+                        <a:defRPr sz="1300" b="1"/>
+                      </a:pPr>
+                      <a:r>
+                        <a:t>media (4 g más difíciles)</a:t>
+                      </a:r>
+                    </a:p>
+                  </a:txBody>
+                  <a:tcPr/>
+                </a:tc>
+                <a:tc>
+                  <a:txBody>
+                    <a:bodyPr/>
+                    <a:lstStyle/>
+                    <a:p>
+                      <a:pPr>
+                        <a:defRPr sz="1300" b="1"/>
+                      </a:pPr>
+                      <a:r>
+                        <a:t>peor g</a:t>
+                      </a:r>
+                    </a:p>
+                  </a:txBody>
+                  <a:tcPr/>
+                </a:tc>
+                <a:tc>
+                  <a:txBody>
+                    <a:bodyPr/>
+                    <a:lstStyle/>
+                    <a:p>
+                      <a:pPr>
+                        <a:defRPr sz="1300" b="1"/>
+                      </a:pPr>
+                      <a:r>
+                        <a:t>g ≥ 40 dB</a:t>
+                      </a:r>
+                    </a:p>
+                  </a:txBody>
+                  <a:tcPr/>
+                </a:tc>
+              </a:tr>
+              <a:tr h="384048">
+                <a:tc>
+                  <a:txBody>
+                    <a:bodyPr/>
+                    <a:lstStyle/>
+                    <a:p>
+                      <a:pPr>
+                        <a:defRPr sz="1200" b="1"/>
+                      </a:pPr>
+                      <a:r>
+                        <a:t>64 puntos (0.39 %)</a:t>
+                      </a:r>
+                    </a:p>
+                  </a:txBody>
+                  <a:tcPr/>
+                </a:tc>
+                <a:tc>
+                  <a:txBody>
+                    <a:bodyPr/>
+                    <a:lstStyle/>
+                    <a:p>
+                      <a:pPr>
+                        <a:defRPr sz="1200" b="0"/>
+                      </a:pPr>
+                      <a:r>
+                        <a:t>38.7</a:t>
+                      </a:r>
+                    </a:p>
+                  </a:txBody>
+                  <a:tcPr/>
+                </a:tc>
+                <a:tc>
+                  <a:txBody>
+                    <a:bodyPr/>
+                    <a:lstStyle/>
+                    <a:p>
+                      <a:pPr>
+                        <a:defRPr sz="1200" b="0"/>
+                      </a:pPr>
+                      <a:r>
+                        <a:t>37.7</a:t>
+                      </a:r>
+                    </a:p>
+                  </a:txBody>
+                  <a:tcPr/>
+                </a:tc>
+                <a:tc>
+                  <a:txBody>
+                    <a:bodyPr/>
+                    <a:lstStyle/>
+                    <a:p>
+                      <a:pPr>
+                        <a:defRPr sz="1200" b="0"/>
+                      </a:pPr>
+                      <a:r>
+                        <a:t>0 de 4</a:t>
+                      </a:r>
+                    </a:p>
+                  </a:txBody>
+                  <a:tcPr/>
+                </a:tc>
+              </a:tr>
+              <a:tr h="384048">
+                <a:tc>
+                  <a:txBody>
+                    <a:bodyPr/>
+                    <a:lstStyle/>
+                    <a:p>
+                      <a:pPr>
+                        <a:defRPr sz="1200" b="1"/>
+                      </a:pPr>
+                      <a:r>
+                        <a:t>72 puntos</a:t>
+                      </a:r>
+                    </a:p>
+                  </a:txBody>
+                  <a:tcPr/>
+                </a:tc>
+                <a:tc>
+                  <a:txBody>
+                    <a:bodyPr/>
+                    <a:lstStyle/>
+                    <a:p>
+                      <a:pPr>
+                        <a:defRPr sz="1200" b="0"/>
+                      </a:pPr>
+                      <a:r>
+                        <a:t>38.9</a:t>
+                      </a:r>
+                    </a:p>
+                  </a:txBody>
+                  <a:tcPr/>
+                </a:tc>
+                <a:tc>
+                  <a:txBody>
+                    <a:bodyPr/>
+                    <a:lstStyle/>
+                    <a:p>
+                      <a:pPr>
+                        <a:defRPr sz="1200" b="0"/>
+                      </a:pPr>
+                      <a:r>
+                        <a:t>37.6</a:t>
+                      </a:r>
+                    </a:p>
+                  </a:txBody>
+                  <a:tcPr/>
+                </a:tc>
+                <a:tc>
+                  <a:txBody>
+                    <a:bodyPr/>
+                    <a:lstStyle/>
+                    <a:p>
+                      <a:pPr>
+                        <a:defRPr sz="1200" b="0"/>
+                      </a:pPr>
+                      <a:r>
+                        <a:t>0 de 4</a:t>
+                      </a:r>
+                    </a:p>
+                  </a:txBody>
+                  <a:tcPr/>
+                </a:tc>
+              </a:tr>
+              <a:tr h="384048">
+                <a:tc>
+                  <a:txBody>
+                    <a:bodyPr/>
+                    <a:lstStyle/>
+                    <a:p>
+                      <a:pPr>
+                        <a:defRPr sz="1200" b="1"/>
+                      </a:pPr>
+                      <a:r>
+                        <a:t>80 puntos</a:t>
+                      </a:r>
+                    </a:p>
+                  </a:txBody>
+                  <a:tcPr/>
+                </a:tc>
+                <a:tc>
+                  <a:txBody>
+                    <a:bodyPr/>
+                    <a:lstStyle/>
+                    <a:p>
+                      <a:pPr>
+                        <a:defRPr sz="1200" b="0"/>
+                      </a:pPr>
+                      <a:r>
+                        <a:t>39.9</a:t>
+                      </a:r>
+                    </a:p>
+                  </a:txBody>
+                  <a:tcPr/>
+                </a:tc>
+                <a:tc>
+                  <a:txBody>
+                    <a:bodyPr/>
+                    <a:lstStyle/>
+                    <a:p>
+                      <a:pPr>
+                        <a:defRPr sz="1200" b="0"/>
+                      </a:pPr>
+                      <a:r>
+                        <a:t>39.0</a:t>
+                      </a:r>
+                    </a:p>
+                  </a:txBody>
+                  <a:tcPr/>
+                </a:tc>
+                <a:tc>
+                  <a:txBody>
+                    <a:bodyPr/>
+                    <a:lstStyle/>
+                    <a:p>
+                      <a:pPr>
+                        <a:defRPr sz="1200" b="0"/>
+                      </a:pPr>
+                      <a:r>
+                        <a:t>1 de 4</a:t>
+                      </a:r>
+                    </a:p>
+                  </a:txBody>
+                  <a:tcPr/>
+                </a:tc>
+              </a:tr>
+              <a:tr h="384048">
+                <a:tc>
+                  <a:txBody>
+                    <a:bodyPr/>
+                    <a:lstStyle/>
+                    <a:p>
+                      <a:pPr>
+                        <a:defRPr sz="1200" b="1"/>
+                      </a:pPr>
+                      <a:r>
+                        <a:t>96 puntos (0.59 %)</a:t>
+                      </a:r>
+                    </a:p>
+                  </a:txBody>
+                  <a:tcPr/>
+                </a:tc>
+                <a:tc>
+                  <a:txBody>
+                    <a:bodyPr/>
+                    <a:lstStyle/>
+                    <a:p>
+                      <a:pPr>
+                        <a:defRPr sz="1200" b="0"/>
+                      </a:pPr>
+                      <a:r>
+                        <a:t>41.8</a:t>
+                      </a:r>
+                    </a:p>
+                  </a:txBody>
+                  <a:tcPr/>
+                </a:tc>
+                <a:tc>
+                  <a:txBody>
+                    <a:bodyPr/>
+                    <a:lstStyle/>
+                    <a:p>
+                      <a:pPr>
+                        <a:defRPr sz="1200" b="0"/>
+                      </a:pPr>
+                      <a:r>
+                        <a:t>40.2</a:t>
+                      </a:r>
+                    </a:p>
+                  </a:txBody>
+                  <a:tcPr/>
+                </a:tc>
+                <a:tc>
+                  <a:txBody>
+                    <a:bodyPr/>
+                    <a:lstStyle/>
+                    <a:p>
+                      <a:pPr>
+                        <a:defRPr sz="1200" b="0"/>
+                      </a:pPr>
+                      <a:r>
+                        <a:t>4 de 4</a:t>
+                      </a:r>
+                    </a:p>
+                  </a:txBody>
+                  <a:tcPr/>
+                </a:tc>
+              </a:tr>
+            </a:tbl>
+          </a:graphicData>
+        </a:graphic>
+      </p:graphicFrame>
+      <p:sp>
+        <p:nvSpPr>
+          <p:cNvPr id="4" name="TextBox 3"/>
           <p:cNvSpPr txBox="1"/>
           <p:nvPr/>
         </p:nvSpPr>
         <p:spPr>
           <a:xfrm>
-            <a:off x="548640" y="1280160"/>
-            <a:ext cx="10972800" cy="5120640"/>
+            <a:off x="731520" y="3383280"/>
+            <a:ext cx="10698480" cy="1280160"/>
           </a:xfrm>
           <a:prstGeom prst="rect">
             <a:avLst/>
@@ -5982,62 +6321,14 @@
           <a:lstStyle/>
           <a:p>
             <a:pPr>
-              <a:spcAft>
-                <a:spcPts val="500"/>
-              </a:spcAft>
-              <a:defRPr sz="1600">
+              <a:defRPr sz="1200" i="1">
                 <a:solidFill>
                   <a:srgbClr val="404040"/>
                 </a:solidFill>
               </a:defRPr>
             </a:pPr>
             <a:r>
-              <a:t>1–3) Optuna + grid/uniform con hiperparámetros + la grilla como hiperparámetro: 181 trials en Mendieta. Mejor DIP con 64 puntos en grilla: 29.9 dB (config 'vase' del paper afinada); uniform siempre peor. En el muestreo nuevo, la grilla (6 columnas × 5 filas) es el parámetro más sensible.</a:t>
-            </a:r>
-          </a:p>
-          <a:p>
-            <a:pPr>
-              <a:spcAft>
-                <a:spcPts val="500"/>
-              </a:spcAft>
-              <a:defRPr sz="1600">
-                <a:solidFill>
-                  <a:srgbClr val="404040"/>
-                </a:solidFill>
-              </a:defRPr>
-            </a:pPr>
-            <a:r>
-              <a:t>4) Ventana: la bisección ya concentra ~25 de los 64 puntos en una franja angosta alrededor del frente (ventana adaptativa).</a:t>
-            </a:r>
-          </a:p>
-          <a:p>
-            <a:pPr>
-              <a:spcAft>
-                <a:spcPts val="500"/>
-              </a:spcAft>
-              <a:defRPr sz="1600">
-                <a:solidFill>
-                  <a:srgbClr val="404040"/>
-                </a:solidFill>
-              </a:defRPr>
-            </a:pPr>
-            <a:r>
-              <a:t>5) Rosenbrock en 3D: hecho (diapositiva anterior).</a:t>
-            </a:r>
-          </a:p>
-          <a:p>
-            <a:pPr>
-              <a:spcAft>
-                <a:spcPts val="500"/>
-              </a:spcAft>
-              <a:defRPr sz="1600">
-                <a:solidFill>
-                  <a:srgbClr val="404040"/>
-                </a:solidFill>
-              </a:defRPr>
-            </a:pPr>
-            <a:r>
-              <a:t>6) Interpolación de scipy vs. DIP: con los mismos puntos empatan con la receta de la tesis (24.4 vs. 25.0); DIP con la config del paper gana (28.5).</a:t>
+              <a:t>Sin DIP, en los g -2.5, -2, -1.5 y -1 (los otros 5 ya pasan los 40 con 64). Con 96 puntos, los 9 g superan los 40 dB. Lo que limita a los g suaves es la rampa pegada al borde (0-12 px), donde ni la TPS ni DIP tienen datos: falta información, no un mejor reconstructor.</a:t>
             </a:r>
           </a:p>
         </p:txBody>
@@ -6090,7 +6381,7 @@
               </a:defRPr>
             </a:pPr>
             <a:r>
-              <a:t>Lo que se probó y NO funcionó (para no repetirlo)</a:t>
+              <a:t>Pedidos de la reunión: estado</a:t>
             </a:r>
           </a:p>
         </p:txBody>
@@ -6121,14 +6412,14 @@
               <a:spcAft>
                 <a:spcPts val="500"/>
               </a:spcAft>
-              <a:defRPr sz="1500">
+              <a:defRPr sz="1600">
                 <a:solidFill>
                   <a:srgbClr val="404040"/>
                 </a:solidFill>
               </a:defRPr>
             </a:pPr>
             <a:r>
-              <a:t>Frente como parábola por puntos medios de pares con salto: inestable, dejaba una costura.</a:t>
+              <a:t>1–3) Optuna + grid/uniform con hiperparámetros + la grilla como hiperparámetro: 181 trials en Mendieta. Mejor DIP con 64 puntos en grilla: 29.9 dB (config 'vase' del paper afinada); uniform siempre peor. En el muestreo nuevo, la grilla (6 columnas × 5 filas) es el parámetro más sensible.</a:t>
             </a:r>
           </a:p>
           <a:p>
@@ -6136,14 +6427,14 @@
               <a:spcAft>
                 <a:spcPts val="500"/>
               </a:spcAft>
-              <a:defRPr sz="1500">
+              <a:defRPr sz="1600">
                 <a:solidFill>
                   <a:srgbClr val="404040"/>
                 </a:solidFill>
               </a:defRPr>
             </a:pPr>
             <a:r>
-              <a:t>Bisección al nivel medio: en los g suaves caía dentro de la rampa, no en el acantilado.</a:t>
+              <a:t>4) Ventana: la bisección ya concentra ~25 de los 64 puntos en una franja angosta alrededor del frente (ventana adaptativa).</a:t>
             </a:r>
           </a:p>
           <a:p>
@@ -6151,14 +6442,14 @@
               <a:spcAft>
                 <a:spcPts val="500"/>
               </a:spcAft>
-              <a:defRPr sz="1500">
+              <a:defRPr sz="1600">
                 <a:solidFill>
                   <a:srgbClr val="404040"/>
                 </a:solidFill>
               </a:defRPr>
             </a:pPr>
             <a:r>
-              <a:t>Sondas del perfil de la rampa (3-7-14 px sobre el borde): le quitan presupuesto al relleno.</a:t>
+              <a:t>5) Rosenbrock en 3D: hecho (diapositiva anterior).</a:t>
             </a:r>
           </a:p>
           <a:p>
@@ -6166,74 +6457,14 @@
               <a:spcAft>
                 <a:spcPts val="500"/>
               </a:spcAft>
-              <a:defRPr sz="1500">
+              <a:defRPr sz="1600">
                 <a:solidFill>
                   <a:srgbClr val="404040"/>
                 </a:solidFill>
               </a:defRPr>
             </a:pPr>
             <a:r>
-              <a:t>Proceso gaussiano en lugar de la TPS: con tan pocos puntos, las escalas aprendidas quedan mal (g=-2: 22 dB vs. 36).</a:t>
-            </a:r>
-          </a:p>
-          <a:p>
-            <a:pPr>
-              <a:spcAft>
-                <a:spcPts val="500"/>
-              </a:spcAft>
-              <a:defRPr sz="1500">
-                <a:solidFill>
-                  <a:srgbClr val="404040"/>
-                </a:solidFill>
-              </a:defRPr>
-            </a:pPr>
-            <a:r>
-              <a:t>Relleno por ancho de las cotas de monotonía: mejor peor g, pero −2.7 dB en g=-4.</a:t>
-            </a:r>
-          </a:p>
-          <a:p>
-            <a:pPr>
-              <a:spcAft>
-                <a:spcPts val="500"/>
-              </a:spcAft>
-              <a:defRPr sz="1500">
-                <a:solidFill>
-                  <a:srgbClr val="404040"/>
-                </a:solidFill>
-              </a:defRPr>
-            </a:pPr>
-            <a:r>
-              <a:t>Grilla de 7-8 columnas: no falla el detector, se acaba el presupuesto en la bisección.</a:t>
-            </a:r>
-          </a:p>
-          <a:p>
-            <a:pPr>
-              <a:spcAft>
-                <a:spcPts val="500"/>
-              </a:spcAft>
-              <a:defRPr sz="1500">
-                <a:solidFill>
-                  <a:srgbClr val="404040"/>
-                </a:solidFill>
-              </a:defRPr>
-            </a:pPr>
-            <a:r>
-              <a:t>DIP 'kate' del paper con 64 puntos (18 dB): pensado para imágenes casi completas.</a:t>
-            </a:r>
-          </a:p>
-          <a:p>
-            <a:pPr>
-              <a:spcAft>
-                <a:spcPts val="500"/>
-              </a:spcAft>
-              <a:defRPr sz="1500">
-                <a:solidFill>
-                  <a:srgbClr val="404040"/>
-                </a:solidFill>
-              </a:defRPr>
-            </a:pPr>
-            <a:r>
-              <a:t>Fusión sin guarda en 9 g: cuando DIP falla en un g (-4 dB), arrastra el promedio.</a:t>
+              <a:t>6) Interpolación de scipy vs. DIP: con los mismos puntos empatan con la receta de la tesis (24.4 vs. 25.0); DIP con la config del paper gana (28.5).</a:t>
             </a:r>
           </a:p>
         </p:txBody>
@@ -6286,7 +6517,7 @@
               </a:defRPr>
             </a:pPr>
             <a:r>
-              <a:t>Listo para KMC: planificador de tandas (autoexp/kmc_planner.py)</a:t>
+              <a:t>Lo que se probó y NO funcionó (para no repetirlo)</a:t>
             </a:r>
           </a:p>
         </p:txBody>
@@ -6317,14 +6548,14 @@
               <a:spcAft>
                 <a:spcPts val="500"/>
               </a:spcAft>
-              <a:defRPr sz="1700">
+              <a:defRPr sz="1500">
                 <a:solidFill>
                   <a:srgbClr val="404040"/>
                 </a:solidFill>
               </a:defRPr>
             </a:pPr>
             <a:r>
-              <a:t>init --budget 64 --sigma σ  →  next  →  (correr KMC)  →  add resultados.csv  →  next ...  →  reconstruct</a:t>
+              <a:t>Frente como parábola por puntos medios de pares con salto: inestable, dejaba una costura.</a:t>
             </a:r>
           </a:p>
           <a:p>
@@ -6332,14 +6563,14 @@
               <a:spcAft>
                 <a:spcPts val="500"/>
               </a:spcAft>
-              <a:defRPr sz="1700">
+              <a:defRPr sz="1500">
                 <a:solidFill>
                   <a:srgbClr val="404040"/>
                 </a:solidFill>
               </a:defRPr>
             </a:pPr>
             <a:r>
-              <a:t>Cada 'next' devuelve la tanda siguiente en (log Ξ, log ℓ), para correr en paralelo en el cluster.</a:t>
+              <a:t>Bisección al nivel medio: en los g suaves caía dentro de la rampa, no en el acantilado.</a:t>
             </a:r>
           </a:p>
           <a:p>
@@ -6347,14 +6578,14 @@
               <a:spcAft>
                 <a:spcPts val="500"/>
               </a:spcAft>
-              <a:defRPr sz="1700">
+              <a:defRPr sz="1500">
                 <a:solidFill>
                   <a:srgbClr val="404040"/>
                 </a:solidFill>
               </a:defRPr>
             </a:pPr>
             <a:r>
-              <a:t>Con 64 puntos: 9 tandas = 30 (grilla) + 4-5 rondas de ~5 (bisección) + 3-4 rondas de 4 (relleno).</a:t>
+              <a:t>Sondas del perfil de la rampa (3-7-14 px sobre el borde): le quitan presupuesto al relleno.</a:t>
             </a:r>
           </a:p>
           <a:p>
@@ -6362,14 +6593,14 @@
               <a:spcAft>
                 <a:spcPts val="500"/>
               </a:spcAft>
-              <a:defRPr sz="1700">
+              <a:defRPr sz="1500">
                 <a:solidFill>
                   <a:srgbClr val="404040"/>
                 </a:solidFill>
               </a:defRPr>
             </a:pPr>
             <a:r>
-              <a:t>Probado de punta a punta contra el modelo del continuo (simulate): g=-4 46.2 dB, g=-2 38.6, g=-0.5 39.4; g=-2 con ruido σ=0.01: 37.6.</a:t>
+              <a:t>Proceso gaussiano en lugar de la TPS: con tan pocos puntos, las escalas aprendidas quedan mal (g=-2: 22 dB vs. 36).</a:t>
             </a:r>
           </a:p>
           <a:p>
@@ -6377,14 +6608,59 @@
               <a:spcAft>
                 <a:spcPts val="500"/>
               </a:spcAft>
-              <a:defRPr sz="1700">
+              <a:defRPr sz="1500">
                 <a:solidFill>
                   <a:srgbClr val="404040"/>
                 </a:solidFill>
               </a:defRPr>
             </a:pPr>
             <a:r>
-              <a:t>σ se estima con corridas repetidas de KMC (NRUNS) y fija todos los umbrales solo.</a:t>
+              <a:t>Relleno por ancho de las cotas de monotonía: mejor peor g, pero −2.7 dB en g=-4.</a:t>
+            </a:r>
+          </a:p>
+          <a:p>
+            <a:pPr>
+              <a:spcAft>
+                <a:spcPts val="500"/>
+              </a:spcAft>
+              <a:defRPr sz="1500">
+                <a:solidFill>
+                  <a:srgbClr val="404040"/>
+                </a:solidFill>
+              </a:defRPr>
+            </a:pPr>
+            <a:r>
+              <a:t>Grilla de 7-8 columnas: no falla el detector, se acaba el presupuesto en la bisección.</a:t>
+            </a:r>
+          </a:p>
+          <a:p>
+            <a:pPr>
+              <a:spcAft>
+                <a:spcPts val="500"/>
+              </a:spcAft>
+              <a:defRPr sz="1500">
+                <a:solidFill>
+                  <a:srgbClr val="404040"/>
+                </a:solidFill>
+              </a:defRPr>
+            </a:pPr>
+            <a:r>
+              <a:t>DIP 'kate' del paper con 64 puntos (18 dB): pensado para imágenes casi completas.</a:t>
+            </a:r>
+          </a:p>
+          <a:p>
+            <a:pPr>
+              <a:spcAft>
+                <a:spcPts val="500"/>
+              </a:spcAft>
+              <a:defRPr sz="1500">
+                <a:solidFill>
+                  <a:srgbClr val="404040"/>
+                </a:solidFill>
+              </a:defRPr>
+            </a:pPr>
+            <a:r>
+              <a:t>Fusión sin guarda en 9 g: cuando DIP falla en un g (-4 dB), arrastra el promedio.</a:t>
             </a:r>
           </a:p>
         </p:txBody>
@@ -6398,6 +6674,157 @@
 </file>
 
 <file path=ppt/slides/slide26.xml><?xml version="1.0" encoding="utf-8"?>
+<p:sld xmlns:a="http://schemas.openxmlformats.org/drawingml/2006/main" xmlns:p="http://schemas.openxmlformats.org/presentationml/2006/main" xmlns:r="http://schemas.openxmlformats.org/officeDocument/2006/relationships">
+  <p:cSld>
+    <p:spTree>
+      <p:nvGrpSpPr>
+        <p:cNvPr id="1" name=""/>
+        <p:cNvGrpSpPr/>
+        <p:nvPr/>
+      </p:nvGrpSpPr>
+      <p:grpSpPr/>
+      <p:sp>
+        <p:nvSpPr>
+          <p:cNvPr id="2" name="TextBox 1"/>
+          <p:cNvSpPr txBox="1"/>
+          <p:nvPr/>
+        </p:nvSpPr>
+        <p:spPr>
+          <a:xfrm>
+            <a:off x="548640" y="320040"/>
+            <a:ext cx="11064240" cy="822960"/>
+          </a:xfrm>
+          <a:prstGeom prst="rect">
+            <a:avLst/>
+          </a:prstGeom>
+          <a:noFill/>
+        </p:spPr>
+        <p:txBody>
+          <a:bodyPr wrap="square">
+            <a:spAutoFit/>
+          </a:bodyPr>
+          <a:lstStyle/>
+          <a:p>
+            <a:pPr>
+              <a:defRPr sz="2700" b="1">
+                <a:solidFill>
+                  <a:srgbClr val="1F3B73"/>
+                </a:solidFill>
+              </a:defRPr>
+            </a:pPr>
+            <a:r>
+              <a:t>Listo para KMC: planificador de tandas (autoexp/kmc_planner.py)</a:t>
+            </a:r>
+          </a:p>
+        </p:txBody>
+      </p:sp>
+      <p:sp>
+        <p:nvSpPr>
+          <p:cNvPr id="3" name="TextBox 2"/>
+          <p:cNvSpPr txBox="1"/>
+          <p:nvPr/>
+        </p:nvSpPr>
+        <p:spPr>
+          <a:xfrm>
+            <a:off x="548640" y="1280160"/>
+            <a:ext cx="10972800" cy="5120640"/>
+          </a:xfrm>
+          <a:prstGeom prst="rect">
+            <a:avLst/>
+          </a:prstGeom>
+          <a:noFill/>
+        </p:spPr>
+        <p:txBody>
+          <a:bodyPr wrap="square">
+            <a:spAutoFit/>
+          </a:bodyPr>
+          <a:lstStyle/>
+          <a:p>
+            <a:pPr>
+              <a:spcAft>
+                <a:spcPts val="500"/>
+              </a:spcAft>
+              <a:defRPr sz="1700">
+                <a:solidFill>
+                  <a:srgbClr val="404040"/>
+                </a:solidFill>
+              </a:defRPr>
+            </a:pPr>
+            <a:r>
+              <a:t>init --budget 64 --sigma σ  →  next  →  (correr KMC)  →  add resultados.csv  →  next ...  →  reconstruct</a:t>
+            </a:r>
+          </a:p>
+          <a:p>
+            <a:pPr>
+              <a:spcAft>
+                <a:spcPts val="500"/>
+              </a:spcAft>
+              <a:defRPr sz="1700">
+                <a:solidFill>
+                  <a:srgbClr val="404040"/>
+                </a:solidFill>
+              </a:defRPr>
+            </a:pPr>
+            <a:r>
+              <a:t>Cada 'next' devuelve la tanda siguiente en (log Ξ, log ℓ), para correr en paralelo en el cluster.</a:t>
+            </a:r>
+          </a:p>
+          <a:p>
+            <a:pPr>
+              <a:spcAft>
+                <a:spcPts val="500"/>
+              </a:spcAft>
+              <a:defRPr sz="1700">
+                <a:solidFill>
+                  <a:srgbClr val="404040"/>
+                </a:solidFill>
+              </a:defRPr>
+            </a:pPr>
+            <a:r>
+              <a:t>Con 64 puntos: 9 tandas = 30 (grilla) + 4-5 rondas de ~5 (bisección) + 3-4 rondas de 4 (relleno).</a:t>
+            </a:r>
+          </a:p>
+          <a:p>
+            <a:pPr>
+              <a:spcAft>
+                <a:spcPts val="500"/>
+              </a:spcAft>
+              <a:defRPr sz="1700">
+                <a:solidFill>
+                  <a:srgbClr val="404040"/>
+                </a:solidFill>
+              </a:defRPr>
+            </a:pPr>
+            <a:r>
+              <a:t>Probado de punta a punta contra el modelo del continuo (simulate): g=-4 46.2 dB, g=-2 38.6, g=-0.5 39.4; g=-2 con ruido σ=0.01: 37.6.</a:t>
+            </a:r>
+          </a:p>
+          <a:p>
+            <a:pPr>
+              <a:spcAft>
+                <a:spcPts val="500"/>
+              </a:spcAft>
+              <a:defRPr sz="1700">
+                <a:solidFill>
+                  <a:srgbClr val="404040"/>
+                </a:solidFill>
+              </a:defRPr>
+            </a:pPr>
+            <a:r>
+              <a:t>σ se estima con corridas repetidas de KMC (NRUNS) y fija todos los umbrales solo.</a:t>
+            </a:r>
+          </a:p>
+        </p:txBody>
+      </p:sp>
+    </p:spTree>
+  </p:cSld>
+  <p:clrMapOvr>
+    <a:masterClrMapping/>
+  </p:clrMapOvr>
+</p:sld>
+</file>
+
+<file path=ppt/slides/slide27.xml><?xml version="1.0" encoding="utf-8"?>
 <p:sld xmlns:a="http://schemas.openxmlformats.org/drawingml/2006/main" xmlns:p="http://schemas.openxmlformats.org/presentationml/2006/main" xmlns:r="http://schemas.openxmlformats.org/officeDocument/2006/relationships">
   <p:cSld>
     <p:spTree>

</xml_diff>

<commit_message>
Presentacion 4: figura de 96 puntos sin DIP
</commit_message>
<xml_diff>
--- a/presentaciones/presentacion4_autoexp/presentacion4_autoexp.pptx
+++ b/presentaciones/presentacion4_autoexp/presentacion4_autoexp.pptx
@@ -32,6 +32,7 @@
     <p:sldId id="280" r:id="rId31"/>
     <p:sldId id="281" r:id="rId32"/>
     <p:sldId id="282" r:id="rId33"/>
+    <p:sldId id="283" r:id="rId34"/>
   </p:sldIdLst>
   <p:sldSz cx="12188952" cy="6858000" type="screen4x3"/>
   <p:notesSz cx="6858000" cy="9144000"/>
@@ -6374,28 +6375,52 @@
           <a:lstStyle/>
           <a:p>
             <a:pPr>
-              <a:defRPr sz="2700" b="1">
+              <a:defRPr sz="2600" b="1">
                 <a:solidFill>
                   <a:srgbClr val="1F3B73"/>
                 </a:solidFill>
               </a:defRPr>
             </a:pPr>
             <a:r>
-              <a:t>Pedidos de la reunión: estado</a:t>
-            </a:r>
-          </a:p>
-        </p:txBody>
-      </p:sp>
-      <p:sp>
-        <p:nvSpPr>
-          <p:cNvPr id="3" name="TextBox 2"/>
+              <a:t>Con 96 puntos, sin DIP: los 9 g sobre 40 dB</a:t>
+            </a:r>
+          </a:p>
+        </p:txBody>
+      </p:sp>
+      <p:pic>
+        <p:nvPicPr>
+          <p:cNvPr id="3" name="Picture 2" descr="mejores_9g_96pts.png"/>
+          <p:cNvPicPr>
+            <a:picLocks noChangeAspect="1"/>
+          </p:cNvPicPr>
+          <p:nvPr/>
+        </p:nvPicPr>
+        <p:blipFill>
+          <a:blip r:embed="rId2"/>
+          <a:stretch>
+            <a:fillRect/>
+          </a:stretch>
+        </p:blipFill>
+        <p:spPr>
+          <a:xfrm>
+            <a:off x="662303" y="1280160"/>
+            <a:ext cx="10864345" cy="4846320"/>
+          </a:xfrm>
+          <a:prstGeom prst="rect">
+            <a:avLst/>
+          </a:prstGeom>
+        </p:spPr>
+      </p:pic>
+      <p:sp>
+        <p:nvSpPr>
+          <p:cNvPr id="4" name="TextBox 3"/>
           <p:cNvSpPr txBox="1"/>
           <p:nvPr/>
         </p:nvSpPr>
         <p:spPr>
           <a:xfrm>
-            <a:off x="548640" y="1280160"/>
-            <a:ext cx="10972800" cy="5120640"/>
+            <a:off x="548640" y="6172200"/>
+            <a:ext cx="11064240" cy="640080"/>
           </a:xfrm>
           <a:prstGeom prst="rect">
             <a:avLst/>
@@ -6408,63 +6433,15 @@
           </a:bodyPr>
           <a:lstStyle/>
           <a:p>
-            <a:pPr>
-              <a:spcAft>
-                <a:spcPts val="500"/>
-              </a:spcAft>
-              <a:defRPr sz="1600">
+            <a:pPr algn="ctr">
+              <a:defRPr sz="1200" i="1">
                 <a:solidFill>
                   <a:srgbClr val="404040"/>
                 </a:solidFill>
               </a:defRPr>
             </a:pPr>
             <a:r>
-              <a:t>1–3) Optuna + grid/uniform con hiperparámetros + la grilla como hiperparámetro: 181 trials en Mendieta. Mejor DIP con 64 puntos en grilla: 29.9 dB (config 'vase' del paper afinada); uniform siempre peor. En el muestreo nuevo, la grilla (6 columnas × 5 filas) es el parámetro más sensible.</a:t>
-            </a:r>
-          </a:p>
-          <a:p>
-            <a:pPr>
-              <a:spcAft>
-                <a:spcPts val="500"/>
-              </a:spcAft>
-              <a:defRPr sz="1600">
-                <a:solidFill>
-                  <a:srgbClr val="404040"/>
-                </a:solidFill>
-              </a:defRPr>
-            </a:pPr>
-            <a:r>
-              <a:t>4) Ventana: la bisección ya concentra ~25 de los 64 puntos en una franja angosta alrededor del frente (ventana adaptativa).</a:t>
-            </a:r>
-          </a:p>
-          <a:p>
-            <a:pPr>
-              <a:spcAft>
-                <a:spcPts val="500"/>
-              </a:spcAft>
-              <a:defRPr sz="1600">
-                <a:solidFill>
-                  <a:srgbClr val="404040"/>
-                </a:solidFill>
-              </a:defRPr>
-            </a:pPr>
-            <a:r>
-              <a:t>5) Rosenbrock en 3D: hecho (diapositiva anterior).</a:t>
-            </a:r>
-          </a:p>
-          <a:p>
-            <a:pPr>
-              <a:spcAft>
-                <a:spcPts val="500"/>
-              </a:spcAft>
-              <a:defRPr sz="1600">
-                <a:solidFill>
-                  <a:srgbClr val="404040"/>
-                </a:solidFill>
-              </a:defRPr>
-            </a:pPr>
-            <a:r>
-              <a:t>6) Interpolación de scipy vs. DIP: con los mismos puntos empatan con la receta de la tesis (24.4 vs. 25.0); DIP con la config del paper gana (28.5).</a:t>
+              <a:t>Mismo método que con 64 puntos: los 32 puntos extra van al relleno por validación cruzada, que los pone en la rampa pegada al borde de los g suaves (donde faltaba información).</a:t>
             </a:r>
           </a:p>
         </p:txBody>
@@ -6517,7 +6494,7 @@
               </a:defRPr>
             </a:pPr>
             <a:r>
-              <a:t>Lo que se probó y NO funcionó (para no repetirlo)</a:t>
+              <a:t>Pedidos de la reunión: estado</a:t>
             </a:r>
           </a:p>
         </p:txBody>
@@ -6548,14 +6525,14 @@
               <a:spcAft>
                 <a:spcPts val="500"/>
               </a:spcAft>
-              <a:defRPr sz="1500">
+              <a:defRPr sz="1600">
                 <a:solidFill>
                   <a:srgbClr val="404040"/>
                 </a:solidFill>
               </a:defRPr>
             </a:pPr>
             <a:r>
-              <a:t>Frente como parábola por puntos medios de pares con salto: inestable, dejaba una costura.</a:t>
+              <a:t>1–3) Optuna + grid/uniform con hiperparámetros + la grilla como hiperparámetro: 181 trials en Mendieta. Mejor DIP con 64 puntos en grilla: 29.9 dB (config 'vase' del paper afinada); uniform siempre peor. En el muestreo nuevo, la grilla (6 columnas × 5 filas) es el parámetro más sensible.</a:t>
             </a:r>
           </a:p>
           <a:p>
@@ -6563,14 +6540,14 @@
               <a:spcAft>
                 <a:spcPts val="500"/>
               </a:spcAft>
-              <a:defRPr sz="1500">
+              <a:defRPr sz="1600">
                 <a:solidFill>
                   <a:srgbClr val="404040"/>
                 </a:solidFill>
               </a:defRPr>
             </a:pPr>
             <a:r>
-              <a:t>Bisección al nivel medio: en los g suaves caía dentro de la rampa, no en el acantilado.</a:t>
+              <a:t>4) Ventana: la bisección ya concentra ~25 de los 64 puntos en una franja angosta alrededor del frente (ventana adaptativa).</a:t>
             </a:r>
           </a:p>
           <a:p>
@@ -6578,14 +6555,14 @@
               <a:spcAft>
                 <a:spcPts val="500"/>
               </a:spcAft>
-              <a:defRPr sz="1500">
+              <a:defRPr sz="1600">
                 <a:solidFill>
                   <a:srgbClr val="404040"/>
                 </a:solidFill>
               </a:defRPr>
             </a:pPr>
             <a:r>
-              <a:t>Sondas del perfil de la rampa (3-7-14 px sobre el borde): le quitan presupuesto al relleno.</a:t>
+              <a:t>5) Rosenbrock en 3D: hecho (diapositiva anterior).</a:t>
             </a:r>
           </a:p>
           <a:p>
@@ -6593,74 +6570,14 @@
               <a:spcAft>
                 <a:spcPts val="500"/>
               </a:spcAft>
-              <a:defRPr sz="1500">
+              <a:defRPr sz="1600">
                 <a:solidFill>
                   <a:srgbClr val="404040"/>
                 </a:solidFill>
               </a:defRPr>
             </a:pPr>
             <a:r>
-              <a:t>Proceso gaussiano en lugar de la TPS: con tan pocos puntos, las escalas aprendidas quedan mal (g=-2: 22 dB vs. 36).</a:t>
-            </a:r>
-          </a:p>
-          <a:p>
-            <a:pPr>
-              <a:spcAft>
-                <a:spcPts val="500"/>
-              </a:spcAft>
-              <a:defRPr sz="1500">
-                <a:solidFill>
-                  <a:srgbClr val="404040"/>
-                </a:solidFill>
-              </a:defRPr>
-            </a:pPr>
-            <a:r>
-              <a:t>Relleno por ancho de las cotas de monotonía: mejor peor g, pero −2.7 dB en g=-4.</a:t>
-            </a:r>
-          </a:p>
-          <a:p>
-            <a:pPr>
-              <a:spcAft>
-                <a:spcPts val="500"/>
-              </a:spcAft>
-              <a:defRPr sz="1500">
-                <a:solidFill>
-                  <a:srgbClr val="404040"/>
-                </a:solidFill>
-              </a:defRPr>
-            </a:pPr>
-            <a:r>
-              <a:t>Grilla de 7-8 columnas: no falla el detector, se acaba el presupuesto en la bisección.</a:t>
-            </a:r>
-          </a:p>
-          <a:p>
-            <a:pPr>
-              <a:spcAft>
-                <a:spcPts val="500"/>
-              </a:spcAft>
-              <a:defRPr sz="1500">
-                <a:solidFill>
-                  <a:srgbClr val="404040"/>
-                </a:solidFill>
-              </a:defRPr>
-            </a:pPr>
-            <a:r>
-              <a:t>DIP 'kate' del paper con 64 puntos (18 dB): pensado para imágenes casi completas.</a:t>
-            </a:r>
-          </a:p>
-          <a:p>
-            <a:pPr>
-              <a:spcAft>
-                <a:spcPts val="500"/>
-              </a:spcAft>
-              <a:defRPr sz="1500">
-                <a:solidFill>
-                  <a:srgbClr val="404040"/>
-                </a:solidFill>
-              </a:defRPr>
-            </a:pPr>
-            <a:r>
-              <a:t>Fusión sin guarda en 9 g: cuando DIP falla en un g (-4 dB), arrastra el promedio.</a:t>
+              <a:t>6) Interpolación de scipy vs. DIP: con los mismos puntos empatan con la receta de la tesis (24.4 vs. 25.0); DIP con la config del paper gana (28.5).</a:t>
             </a:r>
           </a:p>
         </p:txBody>
@@ -6713,7 +6630,7 @@
               </a:defRPr>
             </a:pPr>
             <a:r>
-              <a:t>Listo para KMC: planificador de tandas (autoexp/kmc_planner.py)</a:t>
+              <a:t>Lo que se probó y NO funcionó (para no repetirlo)</a:t>
             </a:r>
           </a:p>
         </p:txBody>
@@ -6744,14 +6661,14 @@
               <a:spcAft>
                 <a:spcPts val="500"/>
               </a:spcAft>
-              <a:defRPr sz="1700">
+              <a:defRPr sz="1500">
                 <a:solidFill>
                   <a:srgbClr val="404040"/>
                 </a:solidFill>
               </a:defRPr>
             </a:pPr>
             <a:r>
-              <a:t>init --budget 64 --sigma σ  →  next  →  (correr KMC)  →  add resultados.csv  →  next ...  →  reconstruct</a:t>
+              <a:t>Frente como parábola por puntos medios de pares con salto: inestable, dejaba una costura.</a:t>
             </a:r>
           </a:p>
           <a:p>
@@ -6759,14 +6676,14 @@
               <a:spcAft>
                 <a:spcPts val="500"/>
               </a:spcAft>
-              <a:defRPr sz="1700">
+              <a:defRPr sz="1500">
                 <a:solidFill>
                   <a:srgbClr val="404040"/>
                 </a:solidFill>
               </a:defRPr>
             </a:pPr>
             <a:r>
-              <a:t>Cada 'next' devuelve la tanda siguiente en (log Ξ, log ℓ), para correr en paralelo en el cluster.</a:t>
+              <a:t>Bisección al nivel medio: en los g suaves caía dentro de la rampa, no en el acantilado.</a:t>
             </a:r>
           </a:p>
           <a:p>
@@ -6774,14 +6691,14 @@
               <a:spcAft>
                 <a:spcPts val="500"/>
               </a:spcAft>
-              <a:defRPr sz="1700">
+              <a:defRPr sz="1500">
                 <a:solidFill>
                   <a:srgbClr val="404040"/>
                 </a:solidFill>
               </a:defRPr>
             </a:pPr>
             <a:r>
-              <a:t>Con 64 puntos: 9 tandas = 30 (grilla) + 4-5 rondas de ~5 (bisección) + 3-4 rondas de 4 (relleno).</a:t>
+              <a:t>Sondas del perfil de la rampa (3-7-14 px sobre el borde): le quitan presupuesto al relleno.</a:t>
             </a:r>
           </a:p>
           <a:p>
@@ -6789,14 +6706,14 @@
               <a:spcAft>
                 <a:spcPts val="500"/>
               </a:spcAft>
-              <a:defRPr sz="1700">
+              <a:defRPr sz="1500">
                 <a:solidFill>
                   <a:srgbClr val="404040"/>
                 </a:solidFill>
               </a:defRPr>
             </a:pPr>
             <a:r>
-              <a:t>Probado de punta a punta contra el modelo del continuo (simulate): g=-4 46.2 dB, g=-2 38.6, g=-0.5 39.4; g=-2 con ruido σ=0.01: 37.6.</a:t>
+              <a:t>Proceso gaussiano en lugar de la TPS: con tan pocos puntos, las escalas aprendidas quedan mal (g=-2: 22 dB vs. 36).</a:t>
             </a:r>
           </a:p>
           <a:p>
@@ -6804,14 +6721,59 @@
               <a:spcAft>
                 <a:spcPts val="500"/>
               </a:spcAft>
-              <a:defRPr sz="1700">
+              <a:defRPr sz="1500">
                 <a:solidFill>
                   <a:srgbClr val="404040"/>
                 </a:solidFill>
               </a:defRPr>
             </a:pPr>
             <a:r>
-              <a:t>σ se estima con corridas repetidas de KMC (NRUNS) y fija todos los umbrales solo.</a:t>
+              <a:t>Relleno por ancho de las cotas de monotonía: mejor peor g, pero −2.7 dB en g=-4.</a:t>
+            </a:r>
+          </a:p>
+          <a:p>
+            <a:pPr>
+              <a:spcAft>
+                <a:spcPts val="500"/>
+              </a:spcAft>
+              <a:defRPr sz="1500">
+                <a:solidFill>
+                  <a:srgbClr val="404040"/>
+                </a:solidFill>
+              </a:defRPr>
+            </a:pPr>
+            <a:r>
+              <a:t>Grilla de 7-8 columnas: no falla el detector, se acaba el presupuesto en la bisección.</a:t>
+            </a:r>
+          </a:p>
+          <a:p>
+            <a:pPr>
+              <a:spcAft>
+                <a:spcPts val="500"/>
+              </a:spcAft>
+              <a:defRPr sz="1500">
+                <a:solidFill>
+                  <a:srgbClr val="404040"/>
+                </a:solidFill>
+              </a:defRPr>
+            </a:pPr>
+            <a:r>
+              <a:t>DIP 'kate' del paper con 64 puntos (18 dB): pensado para imágenes casi completas.</a:t>
+            </a:r>
+          </a:p>
+          <a:p>
+            <a:pPr>
+              <a:spcAft>
+                <a:spcPts val="500"/>
+              </a:spcAft>
+              <a:defRPr sz="1500">
+                <a:solidFill>
+                  <a:srgbClr val="404040"/>
+                </a:solidFill>
+              </a:defRPr>
+            </a:pPr>
+            <a:r>
+              <a:t>Fusión sin guarda en 9 g: cuando DIP falla en un g (-4 dB), arrastra el promedio.</a:t>
             </a:r>
           </a:p>
         </p:txBody>
@@ -6825,6 +6787,157 @@
 </file>
 
 <file path=ppt/slides/slide27.xml><?xml version="1.0" encoding="utf-8"?>
+<p:sld xmlns:a="http://schemas.openxmlformats.org/drawingml/2006/main" xmlns:p="http://schemas.openxmlformats.org/presentationml/2006/main" xmlns:r="http://schemas.openxmlformats.org/officeDocument/2006/relationships">
+  <p:cSld>
+    <p:spTree>
+      <p:nvGrpSpPr>
+        <p:cNvPr id="1" name=""/>
+        <p:cNvGrpSpPr/>
+        <p:nvPr/>
+      </p:nvGrpSpPr>
+      <p:grpSpPr/>
+      <p:sp>
+        <p:nvSpPr>
+          <p:cNvPr id="2" name="TextBox 1"/>
+          <p:cNvSpPr txBox="1"/>
+          <p:nvPr/>
+        </p:nvSpPr>
+        <p:spPr>
+          <a:xfrm>
+            <a:off x="548640" y="320040"/>
+            <a:ext cx="11064240" cy="822960"/>
+          </a:xfrm>
+          <a:prstGeom prst="rect">
+            <a:avLst/>
+          </a:prstGeom>
+          <a:noFill/>
+        </p:spPr>
+        <p:txBody>
+          <a:bodyPr wrap="square">
+            <a:spAutoFit/>
+          </a:bodyPr>
+          <a:lstStyle/>
+          <a:p>
+            <a:pPr>
+              <a:defRPr sz="2700" b="1">
+                <a:solidFill>
+                  <a:srgbClr val="1F3B73"/>
+                </a:solidFill>
+              </a:defRPr>
+            </a:pPr>
+            <a:r>
+              <a:t>Listo para KMC: planificador de tandas (autoexp/kmc_planner.py)</a:t>
+            </a:r>
+          </a:p>
+        </p:txBody>
+      </p:sp>
+      <p:sp>
+        <p:nvSpPr>
+          <p:cNvPr id="3" name="TextBox 2"/>
+          <p:cNvSpPr txBox="1"/>
+          <p:nvPr/>
+        </p:nvSpPr>
+        <p:spPr>
+          <a:xfrm>
+            <a:off x="548640" y="1280160"/>
+            <a:ext cx="10972800" cy="5120640"/>
+          </a:xfrm>
+          <a:prstGeom prst="rect">
+            <a:avLst/>
+          </a:prstGeom>
+          <a:noFill/>
+        </p:spPr>
+        <p:txBody>
+          <a:bodyPr wrap="square">
+            <a:spAutoFit/>
+          </a:bodyPr>
+          <a:lstStyle/>
+          <a:p>
+            <a:pPr>
+              <a:spcAft>
+                <a:spcPts val="500"/>
+              </a:spcAft>
+              <a:defRPr sz="1700">
+                <a:solidFill>
+                  <a:srgbClr val="404040"/>
+                </a:solidFill>
+              </a:defRPr>
+            </a:pPr>
+            <a:r>
+              <a:t>init --budget 64 --sigma σ  →  next  →  (correr KMC)  →  add resultados.csv  →  next ...  →  reconstruct</a:t>
+            </a:r>
+          </a:p>
+          <a:p>
+            <a:pPr>
+              <a:spcAft>
+                <a:spcPts val="500"/>
+              </a:spcAft>
+              <a:defRPr sz="1700">
+                <a:solidFill>
+                  <a:srgbClr val="404040"/>
+                </a:solidFill>
+              </a:defRPr>
+            </a:pPr>
+            <a:r>
+              <a:t>Cada 'next' devuelve la tanda siguiente en (log Ξ, log ℓ), para correr en paralelo en el cluster.</a:t>
+            </a:r>
+          </a:p>
+          <a:p>
+            <a:pPr>
+              <a:spcAft>
+                <a:spcPts val="500"/>
+              </a:spcAft>
+              <a:defRPr sz="1700">
+                <a:solidFill>
+                  <a:srgbClr val="404040"/>
+                </a:solidFill>
+              </a:defRPr>
+            </a:pPr>
+            <a:r>
+              <a:t>Con 64 puntos: 9 tandas = 30 (grilla) + 4-5 rondas de ~5 (bisección) + 3-4 rondas de 4 (relleno).</a:t>
+            </a:r>
+          </a:p>
+          <a:p>
+            <a:pPr>
+              <a:spcAft>
+                <a:spcPts val="500"/>
+              </a:spcAft>
+              <a:defRPr sz="1700">
+                <a:solidFill>
+                  <a:srgbClr val="404040"/>
+                </a:solidFill>
+              </a:defRPr>
+            </a:pPr>
+            <a:r>
+              <a:t>Probado de punta a punta contra el modelo del continuo (simulate): g=-4 46.2 dB, g=-2 38.6, g=-0.5 39.4; g=-2 con ruido σ=0.01: 37.6.</a:t>
+            </a:r>
+          </a:p>
+          <a:p>
+            <a:pPr>
+              <a:spcAft>
+                <a:spcPts val="500"/>
+              </a:spcAft>
+              <a:defRPr sz="1700">
+                <a:solidFill>
+                  <a:srgbClr val="404040"/>
+                </a:solidFill>
+              </a:defRPr>
+            </a:pPr>
+            <a:r>
+              <a:t>σ se estima con corridas repetidas de KMC (NRUNS) y fija todos los umbrales solo.</a:t>
+            </a:r>
+          </a:p>
+        </p:txBody>
+      </p:sp>
+    </p:spTree>
+  </p:cSld>
+  <p:clrMapOvr>
+    <a:masterClrMapping/>
+  </p:clrMapOvr>
+</p:sld>
+</file>
+
+<file path=ppt/slides/slide28.xml><?xml version="1.0" encoding="utf-8"?>
 <p:sld xmlns:a="http://schemas.openxmlformats.org/drawingml/2006/main" xmlns:p="http://schemas.openxmlformats.org/presentationml/2006/main" xmlns:r="http://schemas.openxmlformats.org/officeDocument/2006/relationships">
   <p:cSld>
     <p:spTree>

</xml_diff>

<commit_message>
Presentacion 4: TPS vs DIP en imagenes sinteticas (tabla + 3D)
</commit_message>
<xml_diff>
--- a/presentaciones/presentacion4_autoexp/presentacion4_autoexp.pptx
+++ b/presentaciones/presentacion4_autoexp/presentacion4_autoexp.pptx
@@ -33,6 +33,8 @@
     <p:sldId id="281" r:id="rId32"/>
     <p:sldId id="282" r:id="rId33"/>
     <p:sldId id="283" r:id="rId34"/>
+    <p:sldId id="284" r:id="rId35"/>
+    <p:sldId id="285" r:id="rId36"/>
   </p:sldIdLst>
   <p:sldSz cx="12188952" cy="6858000" type="screen4x3"/>
   <p:notesSz cx="6858000" cy="9144000"/>
@@ -6487,28 +6489,428 @@
           <a:lstStyle/>
           <a:p>
             <a:pPr>
-              <a:defRPr sz="2700" b="1">
+              <a:defRPr sz="2600" b="1">
                 <a:solidFill>
                   <a:srgbClr val="1F3B73"/>
                 </a:solidFill>
               </a:defRPr>
             </a:pPr>
             <a:r>
-              <a:t>Pedidos de la reunión: estado</a:t>
-            </a:r>
-          </a:p>
-        </p:txBody>
-      </p:sp>
-      <p:sp>
-        <p:nvSpPr>
-          <p:cNvPr id="3" name="TextBox 2"/>
+              <a:t>TPS vs DIP en otras formas (misma cantidad de puntos, al azar)</a:t>
+            </a:r>
+          </a:p>
+        </p:txBody>
+      </p:sp>
+      <p:graphicFrame>
+        <p:nvGraphicFramePr>
+          <p:cNvPr id="3" name="Table 2"/>
+          <p:cNvGraphicFramePr>
+            <a:graphicFrameLocks noGrp="1"/>
+          </p:cNvGraphicFramePr>
+          <p:nvPr/>
+        </p:nvGraphicFramePr>
+        <p:xfrm>
+          <a:off x="731520" y="1371600"/>
+          <a:ext cx="10607039" cy="2304288"/>
+        </p:xfrm>
+        <a:graphic>
+          <a:graphicData uri="http://schemas.openxmlformats.org/drawingml/2006/table">
+            <a:tbl>
+              <a:tblPr firstRow="1" bandRow="1">
+                <a:tableStyleId>{5C22544A-7EE6-4342-B048-85BDC9FD1C3A}</a:tableStyleId>
+              </a:tblPr>
+              <a:tblGrid>
+                <a:gridCol w="3749039"/>
+                <a:gridCol w="2286000"/>
+                <a:gridCol w="2286000"/>
+                <a:gridCol w="2286000"/>
+              </a:tblGrid>
+              <a:tr h="384048">
+                <a:tc>
+                  <a:txBody>
+                    <a:bodyPr/>
+                    <a:lstStyle/>
+                    <a:p>
+                      <a:pPr>
+                        <a:defRPr sz="1300" b="1"/>
+                      </a:pPr>
+                      <a:r>
+                        <a:t>imagen</a:t>
+                      </a:r>
+                    </a:p>
+                  </a:txBody>
+                  <a:tcPr/>
+                </a:tc>
+                <a:tc>
+                  <a:txBody>
+                    <a:bodyPr/>
+                    <a:lstStyle/>
+                    <a:p>
+                      <a:pPr>
+                        <a:defRPr sz="1300" b="1"/>
+                      </a:pPr>
+                      <a:r>
+                        <a:t>1 %: TPS / DIP</a:t>
+                      </a:r>
+                    </a:p>
+                  </a:txBody>
+                  <a:tcPr/>
+                </a:tc>
+                <a:tc>
+                  <a:txBody>
+                    <a:bodyPr/>
+                    <a:lstStyle/>
+                    <a:p>
+                      <a:pPr>
+                        <a:defRPr sz="1300" b="1"/>
+                      </a:pPr>
+                      <a:r>
+                        <a:t>5 %: TPS / DIP</a:t>
+                      </a:r>
+                    </a:p>
+                  </a:txBody>
+                  <a:tcPr/>
+                </a:tc>
+                <a:tc>
+                  <a:txBody>
+                    <a:bodyPr/>
+                    <a:lstStyle/>
+                    <a:p>
+                      <a:pPr>
+                        <a:defRPr sz="1300" b="1"/>
+                      </a:pPr>
+                      <a:r>
+                        <a:t>10 %: TPS / DIP</a:t>
+                      </a:r>
+                    </a:p>
+                  </a:txBody>
+                  <a:tcPr/>
+                </a:tc>
+              </a:tr>
+              <a:tr h="384048">
+                <a:tc>
+                  <a:txBody>
+                    <a:bodyPr/>
+                    <a:lstStyle/>
+                    <a:p>
+                      <a:pPr>
+                        <a:defRPr sz="1200" b="1"/>
+                      </a:pPr>
+                      <a:r>
+                        <a:t>Gauss (suave)</a:t>
+                      </a:r>
+                    </a:p>
+                  </a:txBody>
+                  <a:tcPr/>
+                </a:tc>
+                <a:tc>
+                  <a:txBody>
+                    <a:bodyPr/>
+                    <a:lstStyle/>
+                    <a:p>
+                      <a:pPr>
+                        <a:defRPr sz="1200" b="0"/>
+                      </a:pPr>
+                      <a:r>
+                        <a:t>51.0 / 11.7</a:t>
+                      </a:r>
+                    </a:p>
+                  </a:txBody>
+                  <a:tcPr/>
+                </a:tc>
+                <a:tc>
+                  <a:txBody>
+                    <a:bodyPr/>
+                    <a:lstStyle/>
+                    <a:p>
+                      <a:pPr>
+                        <a:defRPr sz="1200" b="0"/>
+                      </a:pPr>
+                      <a:r>
+                        <a:t>56.7 / 51.6</a:t>
+                      </a:r>
+                    </a:p>
+                  </a:txBody>
+                  <a:tcPr/>
+                </a:tc>
+                <a:tc>
+                  <a:txBody>
+                    <a:bodyPr/>
+                    <a:lstStyle/>
+                    <a:p>
+                      <a:pPr>
+                        <a:defRPr sz="1200" b="0"/>
+                      </a:pPr>
+                      <a:r>
+                        <a:t>57.1 / 53.3</a:t>
+                      </a:r>
+                    </a:p>
+                  </a:txBody>
+                  <a:tcPr/>
+                </a:tc>
+              </a:tr>
+              <a:tr h="384048">
+                <a:tc>
+                  <a:txBody>
+                    <a:bodyPr/>
+                    <a:lstStyle/>
+                    <a:p>
+                      <a:pPr>
+                        <a:defRPr sz="1200" b="1"/>
+                      </a:pPr>
+                      <a:r>
+                        <a:t>Himmelblau (suave, 4 pozos)</a:t>
+                      </a:r>
+                    </a:p>
+                  </a:txBody>
+                  <a:tcPr/>
+                </a:tc>
+                <a:tc>
+                  <a:txBody>
+                    <a:bodyPr/>
+                    <a:lstStyle/>
+                    <a:p>
+                      <a:pPr>
+                        <a:defRPr sz="1200" b="0"/>
+                      </a:pPr>
+                      <a:r>
+                        <a:t>29.6 / 29.1</a:t>
+                      </a:r>
+                    </a:p>
+                  </a:txBody>
+                  <a:tcPr/>
+                </a:tc>
+                <a:tc>
+                  <a:txBody>
+                    <a:bodyPr/>
+                    <a:lstStyle/>
+                    <a:p>
+                      <a:pPr>
+                        <a:defRPr sz="1200" b="0"/>
+                      </a:pPr>
+                      <a:r>
+                        <a:t>42.7 / 41.4</a:t>
+                      </a:r>
+                    </a:p>
+                  </a:txBody>
+                  <a:tcPr/>
+                </a:tc>
+                <a:tc>
+                  <a:txBody>
+                    <a:bodyPr/>
+                    <a:lstStyle/>
+                    <a:p>
+                      <a:pPr>
+                        <a:defRPr sz="1200" b="0"/>
+                      </a:pPr>
+                      <a:r>
+                        <a:t>48.7 / 47.6</a:t>
+                      </a:r>
+                    </a:p>
+                  </a:txBody>
+                  <a:tcPr/>
+                </a:tc>
+              </a:tr>
+              <a:tr h="384048">
+                <a:tc>
+                  <a:txBody>
+                    <a:bodyPr/>
+                    <a:lstStyle/>
+                    <a:p>
+                      <a:pPr>
+                        <a:defRPr sz="1200" b="1"/>
+                      </a:pPr>
+                      <a:r>
+                        <a:t>Rosenbrock (cresta angosta)</a:t>
+                      </a:r>
+                    </a:p>
+                  </a:txBody>
+                  <a:tcPr/>
+                </a:tc>
+                <a:tc>
+                  <a:txBody>
+                    <a:bodyPr/>
+                    <a:lstStyle/>
+                    <a:p>
+                      <a:pPr>
+                        <a:defRPr sz="1200" b="0"/>
+                      </a:pPr>
+                      <a:r>
+                        <a:t>26.3 / 25.7</a:t>
+                      </a:r>
+                    </a:p>
+                  </a:txBody>
+                  <a:tcPr/>
+                </a:tc>
+                <a:tc>
+                  <a:txBody>
+                    <a:bodyPr/>
+                    <a:lstStyle/>
+                    <a:p>
+                      <a:pPr>
+                        <a:defRPr sz="1200" b="0"/>
+                      </a:pPr>
+                      <a:r>
+                        <a:t>35.7 / 38.3</a:t>
+                      </a:r>
+                    </a:p>
+                  </a:txBody>
+                  <a:tcPr/>
+                </a:tc>
+                <a:tc>
+                  <a:txBody>
+                    <a:bodyPr/>
+                    <a:lstStyle/>
+                    <a:p>
+                      <a:pPr>
+                        <a:defRPr sz="1200" b="0"/>
+                      </a:pPr>
+                      <a:r>
+                        <a:t>40.9 / 46.1</a:t>
+                      </a:r>
+                    </a:p>
+                  </a:txBody>
+                  <a:tcPr/>
+                </a:tc>
+              </a:tr>
+              <a:tr h="384048">
+                <a:tc>
+                  <a:txBody>
+                    <a:bodyPr/>
+                    <a:lstStyle/>
+                    <a:p>
+                      <a:pPr>
+                        <a:defRPr sz="1200" b="1"/>
+                      </a:pPr>
+                      <a:r>
+                        <a:t>Tablero (saltos)</a:t>
+                      </a:r>
+                    </a:p>
+                  </a:txBody>
+                  <a:tcPr/>
+                </a:tc>
+                <a:tc>
+                  <a:txBody>
+                    <a:bodyPr/>
+                    <a:lstStyle/>
+                    <a:p>
+                      <a:pPr>
+                        <a:defRPr sz="1200" b="0"/>
+                      </a:pPr>
+                      <a:r>
+                        <a:t>6.5 / 5.7</a:t>
+                      </a:r>
+                    </a:p>
+                  </a:txBody>
+                  <a:tcPr/>
+                </a:tc>
+                <a:tc>
+                  <a:txBody>
+                    <a:bodyPr/>
+                    <a:lstStyle/>
+                    <a:p>
+                      <a:pPr>
+                        <a:defRPr sz="1200" b="0"/>
+                      </a:pPr>
+                      <a:r>
+                        <a:t>10.6 / 16.0</a:t>
+                      </a:r>
+                    </a:p>
+                  </a:txBody>
+                  <a:tcPr/>
+                </a:tc>
+                <a:tc>
+                  <a:txBody>
+                    <a:bodyPr/>
+                    <a:lstStyle/>
+                    <a:p>
+                      <a:pPr>
+                        <a:defRPr sz="1200" b="0"/>
+                      </a:pPr>
+                      <a:r>
+                        <a:t>12.4 / 20.0</a:t>
+                      </a:r>
+                    </a:p>
+                  </a:txBody>
+                  <a:tcPr/>
+                </a:tc>
+              </a:tr>
+              <a:tr h="384048">
+                <a:tc>
+                  <a:txBody>
+                    <a:bodyPr/>
+                    <a:lstStyle/>
+                    <a:p>
+                      <a:pPr>
+                        <a:defRPr sz="1200" b="1"/>
+                      </a:pPr>
+                      <a:r>
+                        <a:t>Barrido de frecuencia</a:t>
+                      </a:r>
+                    </a:p>
+                  </a:txBody>
+                  <a:tcPr/>
+                </a:tc>
+                <a:tc>
+                  <a:txBody>
+                    <a:bodyPr/>
+                    <a:lstStyle/>
+                    <a:p>
+                      <a:pPr>
+                        <a:defRPr sz="1200" b="0"/>
+                      </a:pPr>
+                      <a:r>
+                        <a:t>6.7 / 6.9</a:t>
+                      </a:r>
+                    </a:p>
+                  </a:txBody>
+                  <a:tcPr/>
+                </a:tc>
+                <a:tc>
+                  <a:txBody>
+                    <a:bodyPr/>
+                    <a:lstStyle/>
+                    <a:p>
+                      <a:pPr>
+                        <a:defRPr sz="1200" b="0"/>
+                      </a:pPr>
+                      <a:r>
+                        <a:t>6.9 / 7.2</a:t>
+                      </a:r>
+                    </a:p>
+                  </a:txBody>
+                  <a:tcPr/>
+                </a:tc>
+                <a:tc>
+                  <a:txBody>
+                    <a:bodyPr/>
+                    <a:lstStyle/>
+                    <a:p>
+                      <a:pPr>
+                        <a:defRPr sz="1200" b="0"/>
+                      </a:pPr>
+                      <a:r>
+                        <a:t>7.3 / 7.4</a:t>
+                      </a:r>
+                    </a:p>
+                  </a:txBody>
+                  <a:tcPr/>
+                </a:tc>
+              </a:tr>
+            </a:tbl>
+          </a:graphicData>
+        </a:graphic>
+      </p:graphicFrame>
+      <p:sp>
+        <p:nvSpPr>
+          <p:cNvPr id="4" name="TextBox 3"/>
           <p:cNvSpPr txBox="1"/>
           <p:nvPr/>
         </p:nvSpPr>
         <p:spPr>
           <a:xfrm>
-            <a:off x="548640" y="1280160"/>
-            <a:ext cx="10972800" cy="5120640"/>
+            <a:off x="731520" y="3767328"/>
+            <a:ext cx="10698480" cy="1280160"/>
           </a:xfrm>
           <a:prstGeom prst="rect">
             <a:avLst/>
@@ -6522,62 +6924,14 @@
           <a:lstStyle/>
           <a:p>
             <a:pPr>
-              <a:spcAft>
-                <a:spcPts val="500"/>
-              </a:spcAft>
-              <a:defRPr sz="1600">
+              <a:defRPr sz="1200" i="1">
                 <a:solidFill>
                   <a:srgbClr val="404040"/>
                 </a:solidFill>
               </a:defRPr>
             </a:pPr>
             <a:r>
-              <a:t>1–3) Optuna + grid/uniform con hiperparámetros + la grilla como hiperparámetro: 181 trials en Mendieta. Mejor DIP con 64 puntos en grilla: 29.9 dB (config 'vase' del paper afinada); uniform siempre peor. En el muestreo nuevo, la grilla (6 columnas × 5 filas) es el parámetro más sensible.</a:t>
-            </a:r>
-          </a:p>
-          <a:p>
-            <a:pPr>
-              <a:spcAft>
-                <a:spcPts val="500"/>
-              </a:spcAft>
-              <a:defRPr sz="1600">
-                <a:solidFill>
-                  <a:srgbClr val="404040"/>
-                </a:solidFill>
-              </a:defRPr>
-            </a:pPr>
-            <a:r>
-              <a:t>4) Ventana: la bisección ya concentra ~25 de los 64 puntos en una franja angosta alrededor del frente (ventana adaptativa).</a:t>
-            </a:r>
-          </a:p>
-          <a:p>
-            <a:pPr>
-              <a:spcAft>
-                <a:spcPts val="500"/>
-              </a:spcAft>
-              <a:defRPr sz="1600">
-                <a:solidFill>
-                  <a:srgbClr val="404040"/>
-                </a:solidFill>
-              </a:defRPr>
-            </a:pPr>
-            <a:r>
-              <a:t>5) Rosenbrock en 3D: hecho (diapositiva anterior).</a:t>
-            </a:r>
-          </a:p>
-          <a:p>
-            <a:pPr>
-              <a:spcAft>
-                <a:spcPts val="500"/>
-              </a:spcAft>
-              <a:defRPr sz="1600">
-                <a:solidFill>
-                  <a:srgbClr val="404040"/>
-                </a:solidFill>
-              </a:defRPr>
-            </a:pPr>
-            <a:r>
-              <a:t>6) Interpolación de scipy vs. DIP: con los mismos puntos empatan con la receta de la tesis (24.4 vs. 25.0); DIP con la config del paper gana (28.5).</a:t>
+              <a:t>En formas suaves la TPS gana o empata siempre (DIP hasta puede fallar: Gauss 1 %). En estructuras finas o saltos DIP gana, pero solo con suficientes puntos (5-10 %). El barrido de frecuencia no lo reconstruye ninguno: el detalle es más fino que la separación entre puntos (Nyquist).</a:t>
             </a:r>
           </a:p>
         </p:txBody>
@@ -6623,28 +6977,52 @@
           <a:lstStyle/>
           <a:p>
             <a:pPr>
-              <a:defRPr sz="2700" b="1">
+              <a:defRPr sz="2600" b="1">
                 <a:solidFill>
                   <a:srgbClr val="1F3B73"/>
                 </a:solidFill>
               </a:defRPr>
             </a:pPr>
             <a:r>
-              <a:t>Lo que se probó y NO funcionó (para no repetirlo)</a:t>
-            </a:r>
-          </a:p>
-        </p:txBody>
-      </p:sp>
-      <p:sp>
-        <p:nvSpPr>
-          <p:cNvPr id="3" name="TextBox 2"/>
+              <a:t>TPS vs DIP en 3D</a:t>
+            </a:r>
+          </a:p>
+        </p:txBody>
+      </p:sp>
+      <p:pic>
+        <p:nvPicPr>
+          <p:cNvPr id="3" name="Picture 2" descr="tps_vs_dip_3d.png"/>
+          <p:cNvPicPr>
+            <a:picLocks noChangeAspect="1"/>
+          </p:cNvPicPr>
+          <p:nvPr/>
+        </p:nvPicPr>
+        <p:blipFill>
+          <a:blip r:embed="rId2"/>
+          <a:stretch>
+            <a:fillRect/>
+          </a:stretch>
+        </p:blipFill>
+        <p:spPr>
+          <a:xfrm>
+            <a:off x="3267455" y="1280160"/>
+            <a:ext cx="5654040" cy="4846320"/>
+          </a:xfrm>
+          <a:prstGeom prst="rect">
+            <a:avLst/>
+          </a:prstGeom>
+        </p:spPr>
+      </p:pic>
+      <p:sp>
+        <p:nvSpPr>
+          <p:cNvPr id="4" name="TextBox 3"/>
           <p:cNvSpPr txBox="1"/>
           <p:nvPr/>
         </p:nvSpPr>
         <p:spPr>
           <a:xfrm>
-            <a:off x="548640" y="1280160"/>
-            <a:ext cx="10972800" cy="5120640"/>
+            <a:off x="548640" y="6172200"/>
+            <a:ext cx="11064240" cy="640080"/>
           </a:xfrm>
           <a:prstGeom prst="rect">
             <a:avLst/>
@@ -6657,123 +7035,15 @@
           </a:bodyPr>
           <a:lstStyle/>
           <a:p>
-            <a:pPr>
-              <a:spcAft>
-                <a:spcPts val="500"/>
-              </a:spcAft>
-              <a:defRPr sz="1500">
+            <a:pPr algn="ctr">
+              <a:defRPr sz="1200" i="1">
                 <a:solidFill>
                   <a:srgbClr val="404040"/>
                 </a:solidFill>
               </a:defRPr>
             </a:pPr>
             <a:r>
-              <a:t>Frente como parábola por puntos medios de pares con salto: inestable, dejaba una costura.</a:t>
-            </a:r>
-          </a:p>
-          <a:p>
-            <a:pPr>
-              <a:spcAft>
-                <a:spcPts val="500"/>
-              </a:spcAft>
-              <a:defRPr sz="1500">
-                <a:solidFill>
-                  <a:srgbClr val="404040"/>
-                </a:solidFill>
-              </a:defRPr>
-            </a:pPr>
-            <a:r>
-              <a:t>Bisección al nivel medio: en los g suaves caía dentro de la rampa, no en el acantilado.</a:t>
-            </a:r>
-          </a:p>
-          <a:p>
-            <a:pPr>
-              <a:spcAft>
-                <a:spcPts val="500"/>
-              </a:spcAft>
-              <a:defRPr sz="1500">
-                <a:solidFill>
-                  <a:srgbClr val="404040"/>
-                </a:solidFill>
-              </a:defRPr>
-            </a:pPr>
-            <a:r>
-              <a:t>Sondas del perfil de la rampa (3-7-14 px sobre el borde): le quitan presupuesto al relleno.</a:t>
-            </a:r>
-          </a:p>
-          <a:p>
-            <a:pPr>
-              <a:spcAft>
-                <a:spcPts val="500"/>
-              </a:spcAft>
-              <a:defRPr sz="1500">
-                <a:solidFill>
-                  <a:srgbClr val="404040"/>
-                </a:solidFill>
-              </a:defRPr>
-            </a:pPr>
-            <a:r>
-              <a:t>Proceso gaussiano en lugar de la TPS: con tan pocos puntos, las escalas aprendidas quedan mal (g=-2: 22 dB vs. 36).</a:t>
-            </a:r>
-          </a:p>
-          <a:p>
-            <a:pPr>
-              <a:spcAft>
-                <a:spcPts val="500"/>
-              </a:spcAft>
-              <a:defRPr sz="1500">
-                <a:solidFill>
-                  <a:srgbClr val="404040"/>
-                </a:solidFill>
-              </a:defRPr>
-            </a:pPr>
-            <a:r>
-              <a:t>Relleno por ancho de las cotas de monotonía: mejor peor g, pero −2.7 dB en g=-4.</a:t>
-            </a:r>
-          </a:p>
-          <a:p>
-            <a:pPr>
-              <a:spcAft>
-                <a:spcPts val="500"/>
-              </a:spcAft>
-              <a:defRPr sz="1500">
-                <a:solidFill>
-                  <a:srgbClr val="404040"/>
-                </a:solidFill>
-              </a:defRPr>
-            </a:pPr>
-            <a:r>
-              <a:t>Grilla de 7-8 columnas: no falla el detector, se acaba el presupuesto en la bisección.</a:t>
-            </a:r>
-          </a:p>
-          <a:p>
-            <a:pPr>
-              <a:spcAft>
-                <a:spcPts val="500"/>
-              </a:spcAft>
-              <a:defRPr sz="1500">
-                <a:solidFill>
-                  <a:srgbClr val="404040"/>
-                </a:solidFill>
-              </a:defRPr>
-            </a:pPr>
-            <a:r>
-              <a:t>DIP 'kate' del paper con 64 puntos (18 dB): pensado para imágenes casi completas.</a:t>
-            </a:r>
-          </a:p>
-          <a:p>
-            <a:pPr>
-              <a:spcAft>
-                <a:spcPts val="500"/>
-              </a:spcAft>
-              <a:defRPr sz="1500">
-                <a:solidFill>
-                  <a:srgbClr val="404040"/>
-                </a:solidFill>
-              </a:defRPr>
-            </a:pPr>
-            <a:r>
-              <a:t>Fusión sin guarda en 9 g: cuando DIP falla en un g (-4 dB), arrastra el promedio.</a:t>
+              <a:t>Rosenbrock: la TPS deja la cresta ondulada, DIP la sigue lisa. Himmelblau: iguales. Tablero: la TPS no puede hacer escalones (es una chapa que se dobla), DIP sí.</a:t>
             </a:r>
           </a:p>
         </p:txBody>
@@ -6826,7 +7096,7 @@
               </a:defRPr>
             </a:pPr>
             <a:r>
-              <a:t>Listo para KMC: planificador de tandas (autoexp/kmc_planner.py)</a:t>
+              <a:t>Pedidos de la reunión: estado</a:t>
             </a:r>
           </a:p>
         </p:txBody>
@@ -6857,14 +7127,14 @@
               <a:spcAft>
                 <a:spcPts val="500"/>
               </a:spcAft>
-              <a:defRPr sz="1700">
+              <a:defRPr sz="1600">
                 <a:solidFill>
                   <a:srgbClr val="404040"/>
                 </a:solidFill>
               </a:defRPr>
             </a:pPr>
             <a:r>
-              <a:t>init --budget 64 --sigma σ  →  next  →  (correr KMC)  →  add resultados.csv  →  next ...  →  reconstruct</a:t>
+              <a:t>1–3) Optuna + grid/uniform con hiperparámetros + la grilla como hiperparámetro: 181 trials en Mendieta. Mejor DIP con 64 puntos en grilla: 29.9 dB (config 'vase' del paper afinada); uniform siempre peor. En el muestreo nuevo, la grilla (6 columnas × 5 filas) es el parámetro más sensible.</a:t>
             </a:r>
           </a:p>
           <a:p>
@@ -6872,14 +7142,14 @@
               <a:spcAft>
                 <a:spcPts val="500"/>
               </a:spcAft>
-              <a:defRPr sz="1700">
+              <a:defRPr sz="1600">
                 <a:solidFill>
                   <a:srgbClr val="404040"/>
                 </a:solidFill>
               </a:defRPr>
             </a:pPr>
             <a:r>
-              <a:t>Cada 'next' devuelve la tanda siguiente en (log Ξ, log ℓ), para correr en paralelo en el cluster.</a:t>
+              <a:t>4) Ventana: la bisección ya concentra ~25 de los 64 puntos en una franja angosta alrededor del frente (ventana adaptativa).</a:t>
             </a:r>
           </a:p>
           <a:p>
@@ -6887,14 +7157,14 @@
               <a:spcAft>
                 <a:spcPts val="500"/>
               </a:spcAft>
-              <a:defRPr sz="1700">
+              <a:defRPr sz="1600">
                 <a:solidFill>
                   <a:srgbClr val="404040"/>
                 </a:solidFill>
               </a:defRPr>
             </a:pPr>
             <a:r>
-              <a:t>Con 64 puntos: 9 tandas = 30 (grilla) + 4-5 rondas de ~5 (bisección) + 3-4 rondas de 4 (relleno).</a:t>
+              <a:t>5) Rosenbrock en 3D: hecho (diapositiva anterior).</a:t>
             </a:r>
           </a:p>
           <a:p>
@@ -6902,29 +7172,14 @@
               <a:spcAft>
                 <a:spcPts val="500"/>
               </a:spcAft>
-              <a:defRPr sz="1700">
+              <a:defRPr sz="1600">
                 <a:solidFill>
                   <a:srgbClr val="404040"/>
                 </a:solidFill>
               </a:defRPr>
             </a:pPr>
             <a:r>
-              <a:t>Probado de punta a punta contra el modelo del continuo (simulate): g=-4 46.2 dB, g=-2 38.6, g=-0.5 39.4; g=-2 con ruido σ=0.01: 37.6.</a:t>
-            </a:r>
-          </a:p>
-          <a:p>
-            <a:pPr>
-              <a:spcAft>
-                <a:spcPts val="500"/>
-              </a:spcAft>
-              <a:defRPr sz="1700">
-                <a:solidFill>
-                  <a:srgbClr val="404040"/>
-                </a:solidFill>
-              </a:defRPr>
-            </a:pPr>
-            <a:r>
-              <a:t>σ se estima con corridas repetidas de KMC (NRUNS) y fija todos los umbrales solo.</a:t>
+              <a:t>6) Interpolación de scipy vs. DIP: con los mismos puntos empatan con la receta de la tesis (24.4 vs. 25.0); DIP con la config del paper gana (28.5).</a:t>
             </a:r>
           </a:p>
         </p:txBody>
@@ -6977,7 +7232,7 @@
               </a:defRPr>
             </a:pPr>
             <a:r>
-              <a:t>Para KMC: recomendación y lo que falta validar</a:t>
+              <a:t>Lo que se probó y NO funcionó (para no repetirlo)</a:t>
             </a:r>
           </a:p>
         </p:txBody>
@@ -7008,14 +7263,14 @@
               <a:spcAft>
                 <a:spcPts val="500"/>
               </a:spcAft>
-              <a:defRPr sz="1600">
+              <a:defRPr sz="1500">
                 <a:solidFill>
                   <a:srgbClr val="404040"/>
                 </a:solidFill>
               </a:defRPr>
             </a:pPr>
             <a:r>
-              <a:t>Muestreo por tandas: grilla (paralelo) → ~5 rondas de bisección (una corrida por columna, en paralelo) → ~4 rondas de relleno de a 4. Unas 10 rondas de KMC en total.</a:t>
+              <a:t>Frente como parábola por puntos medios de pares con salto: inestable, dejaba una costura.</a:t>
             </a:r>
           </a:p>
           <a:p>
@@ -7023,14 +7278,14 @@
               <a:spcAft>
                 <a:spcPts val="500"/>
               </a:spcAft>
-              <a:defRPr sz="1600">
+              <a:defRPr sz="1500">
                 <a:solidFill>
                   <a:srgbClr val="404040"/>
                 </a:solidFill>
               </a:defRPr>
             </a:pPr>
             <a:r>
-              <a:t>Elegir las columnas según el presupuesto, dejando ~10 puntos para el relleno.</a:t>
+              <a:t>Bisección al nivel medio: en los g suaves caía dentro de la rampa, no en el acantilado.</a:t>
             </a:r>
           </a:p>
           <a:p>
@@ -7038,14 +7293,14 @@
               <a:spcAft>
                 <a:spcPts val="500"/>
               </a:spcAft>
-              <a:defRPr sz="1600">
+              <a:defRPr sz="1500">
                 <a:solidFill>
                   <a:srgbClr val="404040"/>
                 </a:solidFill>
               </a:defRPr>
             </a:pPr>
             <a:r>
-              <a:t>Reconstrucción: fusión TPS (cerca del acantilado) + DIP (zona suave) + monotonía, con guarda.</a:t>
+              <a:t>Sondas del perfil de la rampa (3-7-14 px sobre el borde): le quitan presupuesto al relleno.</a:t>
             </a:r>
           </a:p>
           <a:p>
@@ -7053,59 +7308,225 @@
               <a:spcAft>
                 <a:spcPts val="500"/>
               </a:spcAft>
-              <a:defRPr sz="1600">
+              <a:defRPr sz="1500">
                 <a:solidFill>
                   <a:srgbClr val="404040"/>
                 </a:solidFill>
               </a:defRPr>
             </a:pPr>
             <a:r>
-              <a:t>Pendiente, y lo más importante:</a:t>
-            </a:r>
-          </a:p>
-          <a:p>
-            <a:pPr lvl="1">
+              <a:t>Proceso gaussiano en lugar de la TPS: con tan pocos puntos, las escalas aprendidas quedan mal (g=-2: 22 dB vs. 36).</a:t>
+            </a:r>
+          </a:p>
+          <a:p>
+            <a:pPr>
               <a:spcAft>
                 <a:spcPts val="500"/>
               </a:spcAft>
-              <a:defRPr sz="1300">
+              <a:defRPr sz="1500">
                 <a:solidFill>
                   <a:srgbClr val="404040"/>
                 </a:solidFill>
               </a:defRPr>
             </a:pPr>
             <a:r>
-              <a:t>¿Existe el acantilado a 0 en KMC, o el borde es difuso / ruidoso?</a:t>
-            </a:r>
-          </a:p>
-          <a:p>
-            <a:pPr lvl="1">
+              <a:t>Relleno por ancho de las cotas de monotonía: mejor peor g, pero −2.7 dB en g=-4.</a:t>
+            </a:r>
+          </a:p>
+          <a:p>
+            <a:pPr>
               <a:spcAft>
                 <a:spcPts val="500"/>
               </a:spcAft>
-              <a:defRPr sz="1300">
+              <a:defRPr sz="1500">
                 <a:solidFill>
                   <a:srgbClr val="404040"/>
                 </a:solidFill>
               </a:defRPr>
             </a:pPr>
             <a:r>
-              <a:t>Ruido: con σ = 0.01 se pierden ~1.5 dB y con σ = 0.03 ~5 dB (fusión con DIP). Con ruido DIP suma más (sobre todo SSIM). Hay que estimar σ de KMC con corridas repetidas.</a:t>
-            </a:r>
-          </a:p>
-          <a:p>
-            <a:pPr lvl="1">
+              <a:t>Grilla de 7-8 columnas: no falla el detector, se acaba el presupuesto en la bisección.</a:t>
+            </a:r>
+          </a:p>
+          <a:p>
+            <a:pPr>
               <a:spcAft>
                 <a:spcPts val="500"/>
               </a:spcAft>
-              <a:defRPr sz="1300">
+              <a:defRPr sz="1500">
                 <a:solidFill>
                   <a:srgbClr val="404040"/>
                 </a:solidFill>
               </a:defRPr>
             </a:pPr>
             <a:r>
-              <a:t>Guarda de DIP: si DIP no ajusta los puntos reales, se usa solo la TPS (o se relanza DIP con otra semilla).</a:t>
+              <a:t>DIP 'kate' del paper con 64 puntos (18 dB): pensado para imágenes casi completas.</a:t>
+            </a:r>
+          </a:p>
+          <a:p>
+            <a:pPr>
+              <a:spcAft>
+                <a:spcPts val="500"/>
+              </a:spcAft>
+              <a:defRPr sz="1500">
+                <a:solidFill>
+                  <a:srgbClr val="404040"/>
+                </a:solidFill>
+              </a:defRPr>
+            </a:pPr>
+            <a:r>
+              <a:t>Fusión sin guarda en 9 g: cuando DIP falla en un g (-4 dB), arrastra el promedio.</a:t>
+            </a:r>
+          </a:p>
+        </p:txBody>
+      </p:sp>
+    </p:spTree>
+  </p:cSld>
+  <p:clrMapOvr>
+    <a:masterClrMapping/>
+  </p:clrMapOvr>
+</p:sld>
+</file>
+
+<file path=ppt/slides/slide29.xml><?xml version="1.0" encoding="utf-8"?>
+<p:sld xmlns:a="http://schemas.openxmlformats.org/drawingml/2006/main" xmlns:p="http://schemas.openxmlformats.org/presentationml/2006/main" xmlns:r="http://schemas.openxmlformats.org/officeDocument/2006/relationships">
+  <p:cSld>
+    <p:spTree>
+      <p:nvGrpSpPr>
+        <p:cNvPr id="1" name=""/>
+        <p:cNvGrpSpPr/>
+        <p:nvPr/>
+      </p:nvGrpSpPr>
+      <p:grpSpPr/>
+      <p:sp>
+        <p:nvSpPr>
+          <p:cNvPr id="2" name="TextBox 1"/>
+          <p:cNvSpPr txBox="1"/>
+          <p:nvPr/>
+        </p:nvSpPr>
+        <p:spPr>
+          <a:xfrm>
+            <a:off x="548640" y="320040"/>
+            <a:ext cx="11064240" cy="822960"/>
+          </a:xfrm>
+          <a:prstGeom prst="rect">
+            <a:avLst/>
+          </a:prstGeom>
+          <a:noFill/>
+        </p:spPr>
+        <p:txBody>
+          <a:bodyPr wrap="square">
+            <a:spAutoFit/>
+          </a:bodyPr>
+          <a:lstStyle/>
+          <a:p>
+            <a:pPr>
+              <a:defRPr sz="2700" b="1">
+                <a:solidFill>
+                  <a:srgbClr val="1F3B73"/>
+                </a:solidFill>
+              </a:defRPr>
+            </a:pPr>
+            <a:r>
+              <a:t>Listo para KMC: planificador de tandas (autoexp/kmc_planner.py)</a:t>
+            </a:r>
+          </a:p>
+        </p:txBody>
+      </p:sp>
+      <p:sp>
+        <p:nvSpPr>
+          <p:cNvPr id="3" name="TextBox 2"/>
+          <p:cNvSpPr txBox="1"/>
+          <p:nvPr/>
+        </p:nvSpPr>
+        <p:spPr>
+          <a:xfrm>
+            <a:off x="548640" y="1280160"/>
+            <a:ext cx="10972800" cy="5120640"/>
+          </a:xfrm>
+          <a:prstGeom prst="rect">
+            <a:avLst/>
+          </a:prstGeom>
+          <a:noFill/>
+        </p:spPr>
+        <p:txBody>
+          <a:bodyPr wrap="square">
+            <a:spAutoFit/>
+          </a:bodyPr>
+          <a:lstStyle/>
+          <a:p>
+            <a:pPr>
+              <a:spcAft>
+                <a:spcPts val="500"/>
+              </a:spcAft>
+              <a:defRPr sz="1700">
+                <a:solidFill>
+                  <a:srgbClr val="404040"/>
+                </a:solidFill>
+              </a:defRPr>
+            </a:pPr>
+            <a:r>
+              <a:t>init --budget 64 --sigma σ  →  next  →  (correr KMC)  →  add resultados.csv  →  next ...  →  reconstruct</a:t>
+            </a:r>
+          </a:p>
+          <a:p>
+            <a:pPr>
+              <a:spcAft>
+                <a:spcPts val="500"/>
+              </a:spcAft>
+              <a:defRPr sz="1700">
+                <a:solidFill>
+                  <a:srgbClr val="404040"/>
+                </a:solidFill>
+              </a:defRPr>
+            </a:pPr>
+            <a:r>
+              <a:t>Cada 'next' devuelve la tanda siguiente en (log Ξ, log ℓ), para correr en paralelo en el cluster.</a:t>
+            </a:r>
+          </a:p>
+          <a:p>
+            <a:pPr>
+              <a:spcAft>
+                <a:spcPts val="500"/>
+              </a:spcAft>
+              <a:defRPr sz="1700">
+                <a:solidFill>
+                  <a:srgbClr val="404040"/>
+                </a:solidFill>
+              </a:defRPr>
+            </a:pPr>
+            <a:r>
+              <a:t>Con 64 puntos: 9 tandas = 30 (grilla) + 4-5 rondas de ~5 (bisección) + 3-4 rondas de 4 (relleno).</a:t>
+            </a:r>
+          </a:p>
+          <a:p>
+            <a:pPr>
+              <a:spcAft>
+                <a:spcPts val="500"/>
+              </a:spcAft>
+              <a:defRPr sz="1700">
+                <a:solidFill>
+                  <a:srgbClr val="404040"/>
+                </a:solidFill>
+              </a:defRPr>
+            </a:pPr>
+            <a:r>
+              <a:t>Probado de punta a punta contra el modelo del continuo (simulate): g=-4 46.2 dB, g=-2 38.6, g=-0.5 39.4; g=-2 con ruido σ=0.01: 37.6.</a:t>
+            </a:r>
+          </a:p>
+          <a:p>
+            <a:pPr>
+              <a:spcAft>
+                <a:spcPts val="500"/>
+              </a:spcAft>
+              <a:defRPr sz="1700">
+                <a:solidFill>
+                  <a:srgbClr val="404040"/>
+                </a:solidFill>
+              </a:defRPr>
+            </a:pPr>
+            <a:r>
+              <a:t>σ se estima con corridas repetidas de KMC (NRUNS) y fija todos los umbrales solo.</a:t>
             </a:r>
           </a:p>
         </p:txBody>
@@ -7242,6 +7663,187 @@
             </a:pPr>
             <a:r>
               <a:t>Regla clave: ningún método puede mirar el mapa. Solo puede consultar puntos, igual que se haría con KMC.</a:t>
+            </a:r>
+          </a:p>
+        </p:txBody>
+      </p:sp>
+    </p:spTree>
+  </p:cSld>
+  <p:clrMapOvr>
+    <a:masterClrMapping/>
+  </p:clrMapOvr>
+</p:sld>
+</file>
+
+<file path=ppt/slides/slide30.xml><?xml version="1.0" encoding="utf-8"?>
+<p:sld xmlns:a="http://schemas.openxmlformats.org/drawingml/2006/main" xmlns:p="http://schemas.openxmlformats.org/presentationml/2006/main" xmlns:r="http://schemas.openxmlformats.org/officeDocument/2006/relationships">
+  <p:cSld>
+    <p:spTree>
+      <p:nvGrpSpPr>
+        <p:cNvPr id="1" name=""/>
+        <p:cNvGrpSpPr/>
+        <p:nvPr/>
+      </p:nvGrpSpPr>
+      <p:grpSpPr/>
+      <p:sp>
+        <p:nvSpPr>
+          <p:cNvPr id="2" name="TextBox 1"/>
+          <p:cNvSpPr txBox="1"/>
+          <p:nvPr/>
+        </p:nvSpPr>
+        <p:spPr>
+          <a:xfrm>
+            <a:off x="548640" y="320040"/>
+            <a:ext cx="11064240" cy="822960"/>
+          </a:xfrm>
+          <a:prstGeom prst="rect">
+            <a:avLst/>
+          </a:prstGeom>
+          <a:noFill/>
+        </p:spPr>
+        <p:txBody>
+          <a:bodyPr wrap="square">
+            <a:spAutoFit/>
+          </a:bodyPr>
+          <a:lstStyle/>
+          <a:p>
+            <a:pPr>
+              <a:defRPr sz="2700" b="1">
+                <a:solidFill>
+                  <a:srgbClr val="1F3B73"/>
+                </a:solidFill>
+              </a:defRPr>
+            </a:pPr>
+            <a:r>
+              <a:t>Para KMC: recomendación y lo que falta validar</a:t>
+            </a:r>
+          </a:p>
+        </p:txBody>
+      </p:sp>
+      <p:sp>
+        <p:nvSpPr>
+          <p:cNvPr id="3" name="TextBox 2"/>
+          <p:cNvSpPr txBox="1"/>
+          <p:nvPr/>
+        </p:nvSpPr>
+        <p:spPr>
+          <a:xfrm>
+            <a:off x="548640" y="1280160"/>
+            <a:ext cx="10972800" cy="5120640"/>
+          </a:xfrm>
+          <a:prstGeom prst="rect">
+            <a:avLst/>
+          </a:prstGeom>
+          <a:noFill/>
+        </p:spPr>
+        <p:txBody>
+          <a:bodyPr wrap="square">
+            <a:spAutoFit/>
+          </a:bodyPr>
+          <a:lstStyle/>
+          <a:p>
+            <a:pPr>
+              <a:spcAft>
+                <a:spcPts val="500"/>
+              </a:spcAft>
+              <a:defRPr sz="1600">
+                <a:solidFill>
+                  <a:srgbClr val="404040"/>
+                </a:solidFill>
+              </a:defRPr>
+            </a:pPr>
+            <a:r>
+              <a:t>Muestreo por tandas: grilla (paralelo) → ~5 rondas de bisección (una corrida por columna, en paralelo) → ~4 rondas de relleno de a 4. Unas 10 rondas de KMC en total.</a:t>
+            </a:r>
+          </a:p>
+          <a:p>
+            <a:pPr>
+              <a:spcAft>
+                <a:spcPts val="500"/>
+              </a:spcAft>
+              <a:defRPr sz="1600">
+                <a:solidFill>
+                  <a:srgbClr val="404040"/>
+                </a:solidFill>
+              </a:defRPr>
+            </a:pPr>
+            <a:r>
+              <a:t>Elegir las columnas según el presupuesto, dejando ~10 puntos para el relleno.</a:t>
+            </a:r>
+          </a:p>
+          <a:p>
+            <a:pPr>
+              <a:spcAft>
+                <a:spcPts val="500"/>
+              </a:spcAft>
+              <a:defRPr sz="1600">
+                <a:solidFill>
+                  <a:srgbClr val="404040"/>
+                </a:solidFill>
+              </a:defRPr>
+            </a:pPr>
+            <a:r>
+              <a:t>Reconstrucción: fusión TPS (cerca del acantilado) + DIP (zona suave) + monotonía, con guarda.</a:t>
+            </a:r>
+          </a:p>
+          <a:p>
+            <a:pPr>
+              <a:spcAft>
+                <a:spcPts val="500"/>
+              </a:spcAft>
+              <a:defRPr sz="1600">
+                <a:solidFill>
+                  <a:srgbClr val="404040"/>
+                </a:solidFill>
+              </a:defRPr>
+            </a:pPr>
+            <a:r>
+              <a:t>Pendiente, y lo más importante:</a:t>
+            </a:r>
+          </a:p>
+          <a:p>
+            <a:pPr lvl="1">
+              <a:spcAft>
+                <a:spcPts val="500"/>
+              </a:spcAft>
+              <a:defRPr sz="1300">
+                <a:solidFill>
+                  <a:srgbClr val="404040"/>
+                </a:solidFill>
+              </a:defRPr>
+            </a:pPr>
+            <a:r>
+              <a:t>¿Existe el acantilado a 0 en KMC, o el borde es difuso / ruidoso?</a:t>
+            </a:r>
+          </a:p>
+          <a:p>
+            <a:pPr lvl="1">
+              <a:spcAft>
+                <a:spcPts val="500"/>
+              </a:spcAft>
+              <a:defRPr sz="1300">
+                <a:solidFill>
+                  <a:srgbClr val="404040"/>
+                </a:solidFill>
+              </a:defRPr>
+            </a:pPr>
+            <a:r>
+              <a:t>Ruido: con σ = 0.01 se pierden ~1.5 dB y con σ = 0.03 ~5 dB (fusión con DIP). Con ruido DIP suma más (sobre todo SSIM). Hay que estimar σ de KMC con corridas repetidas.</a:t>
+            </a:r>
+          </a:p>
+          <a:p>
+            <a:pPr lvl="1">
+              <a:spcAft>
+                <a:spcPts val="500"/>
+              </a:spcAft>
+              <a:defRPr sz="1300">
+                <a:solidFill>
+                  <a:srgbClr val="404040"/>
+                </a:solidFill>
+              </a:defRPr>
+            </a:pPr>
+            <a:r>
+              <a:t>Guarda de DIP: si DIP no ajusta los puntos reales, se usa solo la TPS (o se relanza DIP con otra semilla).</a:t>
             </a:r>
           </a:p>
         </p:txBody>

</xml_diff>

<commit_message>
autoexp: minimo sin DIP = 88 pts (grilla 36): 9 g >= 41.2 dB
</commit_message>
<xml_diff>
--- a/presentaciones/presentacion4_autoexp/presentacion4_autoexp.pptx
+++ b/presentaciones/presentacion4_autoexp/presentacion4_autoexp.pptx
@@ -5973,7 +5973,7 @@
         </p:nvGraphicFramePr>
         <p:xfrm>
           <a:off x="731520" y="1371600"/>
-          <a:ext cx="9875520" cy="1920240"/>
+          <a:ext cx="9875520" cy="3072384"/>
         </p:xfrm>
         <a:graphic>
           <a:graphicData uri="http://schemas.openxmlformats.org/drawingml/2006/table">
@@ -6183,7 +6183,7 @@
                         <a:defRPr sz="1200" b="1"/>
                       </a:pPr>
                       <a:r>
-                        <a:t>80 puntos</a:t>
+                        <a:t>80 puntos (grilla 24)</a:t>
                       </a:r>
                     </a:p>
                   </a:txBody>
@@ -6198,7 +6198,7 @@
                         <a:defRPr sz="1200" b="0"/>
                       </a:pPr>
                       <a:r>
-                        <a:t>39.9</a:t>
+                        <a:t>40.6</a:t>
                       </a:r>
                     </a:p>
                   </a:txBody>
@@ -6213,7 +6213,7 @@
                         <a:defRPr sz="1200" b="0"/>
                       </a:pPr>
                       <a:r>
-                        <a:t>39.0</a:t>
+                        <a:t>38.7</a:t>
                       </a:r>
                     </a:p>
                   </a:txBody>
@@ -6228,7 +6228,7 @@
                         <a:defRPr sz="1200" b="0"/>
                       </a:pPr>
                       <a:r>
-                        <a:t>1 de 4</a:t>
+                        <a:t>3 de 4</a:t>
                       </a:r>
                     </a:p>
                   </a:txBody>
@@ -6245,6 +6245,130 @@
                         <a:defRPr sz="1200" b="1"/>
                       </a:pPr>
                       <a:r>
+                        <a:t>84 puntos (grilla 36)</a:t>
+                      </a:r>
+                    </a:p>
+                  </a:txBody>
+                  <a:tcPr/>
+                </a:tc>
+                <a:tc>
+                  <a:txBody>
+                    <a:bodyPr/>
+                    <a:lstStyle/>
+                    <a:p>
+                      <a:pPr>
+                        <a:defRPr sz="1200" b="0"/>
+                      </a:pPr>
+                      <a:r>
+                        <a:t>40.7</a:t>
+                      </a:r>
+                    </a:p>
+                  </a:txBody>
+                  <a:tcPr/>
+                </a:tc>
+                <a:tc>
+                  <a:txBody>
+                    <a:bodyPr/>
+                    <a:lstStyle/>
+                    <a:p>
+                      <a:pPr>
+                        <a:defRPr sz="1200" b="0"/>
+                      </a:pPr>
+                      <a:r>
+                        <a:t>39.5</a:t>
+                      </a:r>
+                    </a:p>
+                  </a:txBody>
+                  <a:tcPr/>
+                </a:tc>
+                <a:tc>
+                  <a:txBody>
+                    <a:bodyPr/>
+                    <a:lstStyle/>
+                    <a:p>
+                      <a:pPr>
+                        <a:defRPr sz="1200" b="0"/>
+                      </a:pPr>
+                      <a:r>
+                        <a:t>2 de 4</a:t>
+                      </a:r>
+                    </a:p>
+                  </a:txBody>
+                  <a:tcPr/>
+                </a:tc>
+              </a:tr>
+              <a:tr h="384048">
+                <a:tc>
+                  <a:txBody>
+                    <a:bodyPr/>
+                    <a:lstStyle/>
+                    <a:p>
+                      <a:pPr>
+                        <a:defRPr sz="1200" b="1"/>
+                      </a:pPr>
+                      <a:r>
+                        <a:t>88 puntos (0.54 %, grilla 36)</a:t>
+                      </a:r>
+                    </a:p>
+                  </a:txBody>
+                  <a:tcPr/>
+                </a:tc>
+                <a:tc>
+                  <a:txBody>
+                    <a:bodyPr/>
+                    <a:lstStyle/>
+                    <a:p>
+                      <a:pPr>
+                        <a:defRPr sz="1200" b="0"/>
+                      </a:pPr>
+                      <a:r>
+                        <a:t>41.6</a:t>
+                      </a:r>
+                    </a:p>
+                  </a:txBody>
+                  <a:tcPr/>
+                </a:tc>
+                <a:tc>
+                  <a:txBody>
+                    <a:bodyPr/>
+                    <a:lstStyle/>
+                    <a:p>
+                      <a:pPr>
+                        <a:defRPr sz="1200" b="0"/>
+                      </a:pPr>
+                      <a:r>
+                        <a:t>41.2</a:t>
+                      </a:r>
+                    </a:p>
+                  </a:txBody>
+                  <a:tcPr/>
+                </a:tc>
+                <a:tc>
+                  <a:txBody>
+                    <a:bodyPr/>
+                    <a:lstStyle/>
+                    <a:p>
+                      <a:pPr>
+                        <a:defRPr sz="1200" b="0"/>
+                      </a:pPr>
+                      <a:r>
+                        <a:t>4 de 4</a:t>
+                      </a:r>
+                    </a:p>
+                  </a:txBody>
+                  <a:tcPr/>
+                </a:tc>
+              </a:tr>
+              <a:tr h="384048">
+                <a:tc>
+                  <a:txBody>
+                    <a:bodyPr/>
+                    <a:lstStyle/>
+                    <a:p>
+                      <a:pPr>
+                        <a:defRPr sz="1200" b="1"/>
+                      </a:pPr>
+                      <a:r>
                         <a:t>96 puntos (0.59 %)</a:t>
                       </a:r>
                     </a:p>
@@ -6291,6 +6415,68 @@
                       </a:pPr>
                       <a:r>
                         <a:t>4 de 4</a:t>
+                      </a:r>
+                    </a:p>
+                  </a:txBody>
+                  <a:tcPr/>
+                </a:tc>
+              </a:tr>
+              <a:tr h="384048">
+                <a:tc>
+                  <a:txBody>
+                    <a:bodyPr/>
+                    <a:lstStyle/>
+                    <a:p>
+                      <a:pPr>
+                        <a:defRPr sz="1200" b="1"/>
+                      </a:pPr>
+                      <a:r>
+                        <a:t>80 puntos + DIP (fusión, 9 g)</a:t>
+                      </a:r>
+                    </a:p>
+                  </a:txBody>
+                  <a:tcPr/>
+                </a:tc>
+                <a:tc>
+                  <a:txBody>
+                    <a:bodyPr/>
+                    <a:lstStyle/>
+                    <a:p>
+                      <a:pPr>
+                        <a:defRPr sz="1200" b="0"/>
+                      </a:pPr>
+                      <a:r>
+                        <a:t>43.3</a:t>
+                      </a:r>
+                    </a:p>
+                  </a:txBody>
+                  <a:tcPr/>
+                </a:tc>
+                <a:tc>
+                  <a:txBody>
+                    <a:bodyPr/>
+                    <a:lstStyle/>
+                    <a:p>
+                      <a:pPr>
+                        <a:defRPr sz="1200" b="0"/>
+                      </a:pPr>
+                      <a:r>
+                        <a:t>39.8</a:t>
+                      </a:r>
+                    </a:p>
+                  </a:txBody>
+                  <a:tcPr/>
+                </a:tc>
+                <a:tc>
+                  <a:txBody>
+                    <a:bodyPr/>
+                    <a:lstStyle/>
+                    <a:p>
+                      <a:pPr>
+                        <a:defRPr sz="1200" b="0"/>
+                      </a:pPr>
+                      <a:r>
+                        <a:t>8 de 9</a:t>
                       </a:r>
                     </a:p>
                   </a:txBody>
@@ -6309,7 +6495,7 @@
         </p:nvSpPr>
         <p:spPr>
           <a:xfrm>
-            <a:off x="731520" y="3383280"/>
+            <a:off x="731520" y="4535424"/>
             <a:ext cx="10698480" cy="1280160"/>
           </a:xfrm>
           <a:prstGeom prst="rect">
@@ -6331,7 +6517,7 @@
               </a:defRPr>
             </a:pPr>
             <a:r>
-              <a:t>Sin DIP, en los g -2.5, -2, -1.5 y -1 (los otros 5 ya pasan los 40 con 64). Validado con 96 puntos en los 9 g: 44.4 dB de media, el peor 40.2: todos superan los 40 dB. Lo que limita a los g suaves es la rampa pegada al borde (0-12 px), donde ni la TPS ni DIP tienen datos: falta información, no un mejor reconstructor.</a:t>
+              <a:t>Sin DIP, en los g -2.5, -2, -1.5 y -1 (los otros 5 ya pasan los 40 con 64). Validado en los 9 g sin DIP: 88 puntos (grilla 36) → 42.9 de media, peor 41.2. Con DIP, 80 puntos quedan a 0.2 dB (8 de 9). Lo que limita a los g suaves es la rampa pegada al borde (0-12 px), donde ni la TPS ni DIP tienen datos: falta información, no un mejor reconstructor.</a:t>
             </a:r>
           </a:p>
         </p:txBody>

</xml_diff>

<commit_message>
autoexp: minimo para 40 dB en 9 g = 84 pts con DIP (43.4/40.2), 88 sin DIP
</commit_message>
<xml_diff>
--- a/presentaciones/presentacion4_autoexp/presentacion4_autoexp.pptx
+++ b/presentaciones/presentacion4_autoexp/presentacion4_autoexp.pptx
@@ -5958,7 +5958,7 @@
               </a:defRPr>
             </a:pPr>
             <a:r>
-              <a:t>¿Cuántos puntos hacen falta para 40 dB en todos los g?</a:t>
+              <a:t>¿Cuántos puntos hacen falta para 40 dB en todos los g? 84 con DIP, 88 sin DIP</a:t>
             </a:r>
           </a:p>
         </p:txBody>
@@ -5973,7 +5973,7 @@
         </p:nvGraphicFramePr>
         <p:xfrm>
           <a:off x="731520" y="1371600"/>
-          <a:ext cx="9875520" cy="3072384"/>
+          <a:ext cx="9875520" cy="3456432"/>
         </p:xfrm>
         <a:graphic>
           <a:graphicData uri="http://schemas.openxmlformats.org/drawingml/2006/table">
@@ -6483,6 +6483,68 @@
                   <a:tcPr/>
                 </a:tc>
               </a:tr>
+              <a:tr h="384048">
+                <a:tc>
+                  <a:txBody>
+                    <a:bodyPr/>
+                    <a:lstStyle/>
+                    <a:p>
+                      <a:pPr>
+                        <a:defRPr sz="1200" b="1"/>
+                      </a:pPr>
+                      <a:r>
+                        <a:t>84 puntos + DIP (fusión, 9 g)</a:t>
+                      </a:r>
+                    </a:p>
+                  </a:txBody>
+                  <a:tcPr/>
+                </a:tc>
+                <a:tc>
+                  <a:txBody>
+                    <a:bodyPr/>
+                    <a:lstStyle/>
+                    <a:p>
+                      <a:pPr>
+                        <a:defRPr sz="1200" b="0"/>
+                      </a:pPr>
+                      <a:r>
+                        <a:t>43.4</a:t>
+                      </a:r>
+                    </a:p>
+                  </a:txBody>
+                  <a:tcPr/>
+                </a:tc>
+                <a:tc>
+                  <a:txBody>
+                    <a:bodyPr/>
+                    <a:lstStyle/>
+                    <a:p>
+                      <a:pPr>
+                        <a:defRPr sz="1200" b="0"/>
+                      </a:pPr>
+                      <a:r>
+                        <a:t>40.2</a:t>
+                      </a:r>
+                    </a:p>
+                  </a:txBody>
+                  <a:tcPr/>
+                </a:tc>
+                <a:tc>
+                  <a:txBody>
+                    <a:bodyPr/>
+                    <a:lstStyle/>
+                    <a:p>
+                      <a:pPr>
+                        <a:defRPr sz="1200" b="0"/>
+                      </a:pPr>
+                      <a:r>
+                        <a:t>9 de 9</a:t>
+                      </a:r>
+                    </a:p>
+                  </a:txBody>
+                  <a:tcPr/>
+                </a:tc>
+              </a:tr>
             </a:tbl>
           </a:graphicData>
         </a:graphic>
@@ -6495,7 +6557,7 @@
         </p:nvSpPr>
         <p:spPr>
           <a:xfrm>
-            <a:off x="731520" y="4535424"/>
+            <a:off x="731520" y="4919472"/>
             <a:ext cx="10698480" cy="1280160"/>
           </a:xfrm>
           <a:prstGeom prst="rect">
@@ -6517,7 +6579,7 @@
               </a:defRPr>
             </a:pPr>
             <a:r>
-              <a:t>Sin DIP, en los g -2.5, -2, -1.5 y -1 (los otros 5 ya pasan los 40 con 64). Validado en los 9 g sin DIP: 88 puntos (grilla 36) → 42.9 de media, peor 41.2. Con DIP, 80 puntos quedan a 0.2 dB (8 de 9). Lo que limita a los g suaves es la rampa pegada al borde (0-12 px), donde ni la TPS ni DIP tienen datos: falta información, no un mejor reconstructor.</a:t>
+              <a:t>Filas sin DIP: g -2.5, -2, -1.5 y -1 (los otros 5 ya pasan los 40 con 64). Mínimo validado en los 9 g: 84 puntos (0.51 %) con DIP (43.4, peor 40.2); 88 (0.54 %) sin DIP (42.9, peor 41.2). El DIP previo necesitaba ~328: unas 4 veces menos puntos, y sin mirar el mapa. Lo que limita a los g suaves es la rampa pegada al borde (0-12 px), donde ni la TPS ni DIP tienen datos: falta información, no un mejor reconstructor.</a:t>
             </a:r>
           </a:p>
         </p:txBody>

</xml_diff>

<commit_message>
interp2d (motor interno) vs TPS: equivalentes; origen de la biseccion en la presentacion
</commit_message>
<xml_diff>
--- a/presentaciones/presentacion4_autoexp/presentacion4_autoexp.pptx
+++ b/presentaciones/presentacion4_autoexp/presentacion4_autoexp.pptx
@@ -8363,7 +8363,7 @@
               </a:defRPr>
             </a:pPr>
             <a:r>
-              <a:t>Nota: el interp2d del link ya no existe en scipy moderno; se usaron griddata y RBFInterpolator, que son sus reemplazos.</a:t>
+              <a:t>El interp2d del link se eliminó en scipy 1.14. Con su motor interno (RectBivariateSpline en grilla): linear 23.3, cubic 24.1, quintic 21.9 dB; la TPS (RBFInterpolator) 24.4. Equivalentes.</a:t>
             </a:r>
           </a:p>
           <a:p>
@@ -8620,7 +8620,7 @@
               </a:defRPr>
             </a:pPr>
             <a:r>
-              <a:t>2) Bisección: en cada columna con salto, búsqueda binaria vertical ('¿vale 0 o no?'). Ubica el acantilado a 1 px con ~5 consultas por columna.</a:t>
+              <a:t>2) Bisección (método de bisección del análisis numérico; retoma el prototipo de búsqueda binaria del 15/9): en cada columna con salto, búsqueda binaria vertical ('¿vale 0 o no?'). Ubica el acantilado a 1 px con ~5 consultas por columna.</a:t>
             </a:r>
           </a:p>
           <a:p>

</xml_diff>